<commit_message>
M_bias deck on the I13-1 state-C results: re-simulation (I13_1/all18 cards and records, clamp written; every RRMS reproduces the stored state-C rows, native max |d| 1.8e-5), method plots (state-C records, starting-card stage 0.1109 / 0.1049), I-V figures, numbers M_bias 0.0735 / 0.0695 / 0.0637, C0_refit 0.1051 / 0.0984, T1_inloop 0.0753 / 0.0713, start 0.1109 / 0.1049, GMR 0.745 [0.660, 0.850] 17/18; new slide 'BSIM4 A2 clamp: one model state per card (I13-1)' with the old (state L) vs new (state C) table; 43 slides
Co-Authored-By: Claude Opus 5.5 <noreply@anthropic.com>
Claude-Session: https://claude.ai/code/session_01FTjyogfhfbXwhjQosGAjKp
</commit_message>
<xml_diff>
--- a/slides/cryo_ml_mbias_real_data.pptx
+++ b/slides/cryo_ml_mbias_real_data.pptx
@@ -47,6 +47,7 @@
     <p:sldId id="295" r:id="rId46"/>
     <p:sldId id="296" r:id="rId47"/>
     <p:sldId id="297" r:id="rId48"/>
+    <p:sldId id="298" r:id="rId49"/>
   </p:sldIdLst>
   <p:sldSz cx="12191695" cy="6858000" type="screen4x3"/>
   <p:notesSz cx="6858000" cy="9144000"/>
@@ -3211,7 +3212,7 @@
                   <a:srgbClr val="5A6066"/>
                 </a:solidFill>
               </a:rPr>
-              <a:t>All-device RRMS: released card 0.2751, paper 43 parameters 0.2038, M_bias 0.0732</a:t>
+              <a:t>All-device RRMS: released card 0.2751, paper 43 parameters 0.2038, M_bias 0.0735</a:t>
             </a:r>
           </a:p>
           <a:p>
@@ -3226,7 +3227,7 @@
                   <a:srgbClr val="5A6066"/>
                 </a:solidFill>
               </a:rPr>
-              <a:t>2026-10-21</a:t>
+              <a:t>2026-10-22 (BSIM4 clamp state C, I13-1)</a:t>
             </a:r>
           </a:p>
         </p:txBody>
@@ -3677,7 +3678,7 @@
                   <a:srgbClr val="202428"/>
                 </a:solidFill>
               </a:rPr>
-              <a:t>Fold pmos_L2_W5 (23,955 points): RRMS term 0.1058 at g = 0; 0.0731-0.0748 per seed; 0.0735 for the 5-seed mean g.</a:t>
+              <a:t>Fold pmos_L2_W5 (23,955 points): RRMS term 0.1127 at g = 0; 0.0778-0.0798 per seed; 0.0786 for the 5-seed mean g.</a:t>
             </a:r>
           </a:p>
           <a:p>
@@ -3692,7 +3693,7 @@
                   <a:srgbClr val="202428"/>
                 </a:solidFill>
               </a:rPr>
-              <a:t>Std of g across seeds at the training points: median 0.0052, max 0.080.</a:t>
+              <a:t>Std of g across seeds at the training points: median 0.0051, max 0.156.</a:t>
             </a:r>
           </a:p>
           <a:p>
@@ -3707,7 +3708,7 @@
                   <a:srgbClr val="202428"/>
                 </a:solidFill>
               </a:rPr>
-              <a:t>This trace is a re-run (108 s); max |g - stored fold g| = 1.2e-03.</a:t>
+              <a:t>This trace is a re-run (69 s); max |g - stored fold g| = 1.8e-03.</a:t>
             </a:r>
           </a:p>
         </p:txBody>
@@ -3820,7 +3821,7 @@
                   <a:srgbClr val="202428"/>
                 </a:solidFill>
               </a:rPr>
-              <a:t>Range of g at the held-out scored points: nMOS [-0.071, 0.038], median |g| 0.0042; pMOS [-0.400, 0.236], median |g| 0.0153.</a:t>
+              <a:t>Range of g at the held-out scored points: nMOS [-0.074, 0.058], median |g| 0.0135; pMOS [-0.414, 0.245], median |g| 0.0149.</a:t>
             </a:r>
           </a:p>
           <a:p>
@@ -4011,7 +4012,7 @@
                   <a:srgbClr val="202428"/>
                 </a:solidFill>
               </a:rPr>
-              <a:t>Simulations per device: 134-403, mean 317; 21 s. Kept: best card seen (mean RRMS with g). pmos_L2_W5: 0.0732 -&gt; 0.0720 -&gt; 0.0707.</a:t>
+              <a:t>Simulations per device: 127-403, mean 326; 18 s. Kept: best card seen (mean RRMS with g). pmos_L2_W5: 0.0731 -&gt; 0.0716 -&gt; 0.0701.</a:t>
             </a:r>
           </a:p>
         </p:txBody>
@@ -4124,7 +4125,7 @@
                   <a:srgbClr val="202428"/>
                 </a:solidFill>
               </a:rPr>
-              <a:t>No refit: starting card x exp(g) 0.0775. Refit with g: 0.0732. Without g: starting card 0.1044, C0_refit 0.1043.</a:t>
+              <a:t>No refit: starting card x exp(g) 0.0834. Refit with g: 0.0735. Without g: starting card 0.1109, C0_refit 0.1051.</a:t>
             </a:r>
           </a:p>
         </p:txBody>
@@ -4327,7 +4328,7 @@
                   <a:srgbClr val="202428"/>
                 </a:solidFill>
               </a:rPr>
-              <a:t>Models trained: 18 fold models + 1 full model (all 18 devices, export only) = 19 x 5 seeds = 95 tasks, 330 s. T1 tables 4 s. Refits 54, 191 s.</a:t>
+              <a:t>Models trained: 18 fold models + 1 full model (all 18 devices, export only) = 19 x 5 seeds = 95 tasks, 261 s. T1 tables 3 s. Refits 54, 335 s.</a:t>
             </a:r>
           </a:p>
           <a:p>
@@ -4669,7 +4670,7 @@
                         </a:defRPr>
                       </a:pPr>
                       <a:r>
-                        <a:t>0.755</a:t>
+                        <a:t>0.745</a:t>
                       </a:r>
                     </a:p>
                   </a:txBody>
@@ -4692,7 +4693,7 @@
                         </a:defRPr>
                       </a:pPr>
                       <a:r>
-                        <a:t>[0.673, 0.852]</a:t>
+                        <a:t>[0.660, 0.850]</a:t>
                       </a:r>
                     </a:p>
                   </a:txBody>
@@ -4715,7 +4716,7 @@
                         </a:defRPr>
                       </a:pPr>
                       <a:r>
-                        <a:t>16/18</a:t>
+                        <a:t>17/18</a:t>
                       </a:r>
                     </a:p>
                   </a:txBody>
@@ -4763,7 +4764,7 @@
                         </a:defRPr>
                       </a:pPr>
                       <a:r>
-                        <a:t>0.974</a:t>
+                        <a:t>0.960</a:t>
                       </a:r>
                     </a:p>
                   </a:txBody>
@@ -4786,7 +4787,7 @@
                         </a:defRPr>
                       </a:pPr>
                       <a:r>
-                        <a:t>[0.945, 1.001]</a:t>
+                        <a:t>[0.934, 0.986]</a:t>
                       </a:r>
                     </a:p>
                   </a:txBody>
@@ -4809,7 +4810,7 @@
                         </a:defRPr>
                       </a:pPr>
                       <a:r>
-                        <a:t>11/18</a:t>
+                        <a:t>14/18</a:t>
                       </a:r>
                     </a:p>
                   </a:txBody>
@@ -4857,7 +4858,7 @@
                         </a:defRPr>
                       </a:pPr>
                       <a:r>
-                        <a:t>0.775</a:t>
+                        <a:t>0.776</a:t>
                       </a:r>
                     </a:p>
                   </a:txBody>
@@ -4880,7 +4881,7 @@
                         </a:defRPr>
                       </a:pPr>
                       <a:r>
-                        <a:t>[0.695, 0.865]</a:t>
+                        <a:t>[0.692, 0.875]</a:t>
                       </a:r>
                     </a:p>
                   </a:txBody>
@@ -4903,7 +4904,7 @@
                         </a:defRPr>
                       </a:pPr>
                       <a:r>
-                        <a:t>16/18</a:t>
+                        <a:t>17/18</a:t>
                       </a:r>
                     </a:p>
                   </a:txBody>
@@ -5163,7 +5164,7 @@
                   <a:srgbClr val="202428"/>
                 </a:solidFill>
               </a:rPr>
-              <a:t>Checks: g of the Verilog-A arithmetic vs Python, 200 random bias points: max |dg| 2.4e-11. Device RRMS, SPICE-native vs NGSpice card x exp(g) in Python: max |d| 1.7e-05 over 18 devices.</a:t>
+              <a:t>Checks: g of the Verilog-A arithmetic vs Python, 200 random bias points: max |dg| 2.6e-11. Device RRMS, SPICE-native vs NGSpice card x exp(g) in Python: max |d| 1.8e-05 over 18 devices.</a:t>
             </a:r>
           </a:p>
         </p:txBody>
@@ -5890,7 +5891,7 @@
                         </a:defRPr>
                       </a:pPr>
                       <a:r>
-                        <a:t>all-device 0.1044</a:t>
+                        <a:t>all-device 0.1109</a:t>
                       </a:r>
                     </a:p>
                   </a:txBody>
@@ -6055,7 +6056,7 @@
                         </a:defRPr>
                       </a:pPr>
                       <a:r>
-                        <a:t>4 s</a:t>
+                        <a:t>3 s</a:t>
                       </a:r>
                     </a:p>
                   </a:txBody>
@@ -6149,7 +6150,7 @@
                         </a:defRPr>
                       </a:pPr>
                       <a:r>
-                        <a:t>330 s</a:t>
+                        <a:t>261 s</a:t>
                       </a:r>
                     </a:p>
                   </a:txBody>
@@ -6220,7 +6221,7 @@
                         </a:defRPr>
                       </a:pPr>
                       <a:r>
-                        <a:t>317 per refit (mean, M_bias)</a:t>
+                        <a:t>326 per refit (mean, M_bias)</a:t>
                       </a:r>
                     </a:p>
                   </a:txBody>
@@ -6243,7 +6244,7 @@
                         </a:defRPr>
                       </a:pPr>
                       <a:r>
-                        <a:t>191 s</a:t>
+                        <a:t>335 s</a:t>
                       </a:r>
                     </a:p>
                   </a:txBody>
@@ -9325,7 +9326,7 @@
                         </a:defRPr>
                       </a:pPr>
                       <a:r>
-                        <a:t>Direct NGSpice, round 3 + FD (starting card)</a:t>
+                        <a:t>Direct NGSpice, round 3 + FD (starting card), state C (e)</a:t>
                       </a:r>
                     </a:p>
                   </a:txBody>
@@ -9394,7 +9395,7 @@
                         </a:defRPr>
                       </a:pPr>
                       <a:r>
-                        <a:t>0.1044</a:t>
+                        <a:t>0.1109</a:t>
                       </a:r>
                     </a:p>
                   </a:txBody>
@@ -9417,7 +9418,7 @@
                         </a:defRPr>
                       </a:pPr>
                       <a:r>
-                        <a:t>0.0976</a:t>
+                        <a:t>0.1049</a:t>
                       </a:r>
                     </a:p>
                   </a:txBody>
@@ -9511,7 +9512,7 @@
                         </a:defRPr>
                       </a:pPr>
                       <a:r>
-                        <a:t>This deck: leave-one-device-out, all 18 devices</a:t>
+                        <a:t>This deck: leave-one-device-out, all 18 devices, BSIM4 clamp state C</a:t>
                       </a:r>
                     </a:p>
                   </a:txBody>
@@ -9745,7 +9746,7 @@
                         </a:defRPr>
                       </a:pPr>
                       <a:r>
-                        <a:t>0.1043</a:t>
+                        <a:t>0.1051</a:t>
                       </a:r>
                     </a:p>
                   </a:txBody>
@@ -9768,7 +9769,7 @@
                         </a:defRPr>
                       </a:pPr>
                       <a:r>
-                        <a:t>0.0975</a:t>
+                        <a:t>0.0984</a:t>
                       </a:r>
                     </a:p>
                   </a:txBody>
@@ -9837,7 +9838,7 @@
                         </a:defRPr>
                       </a:pPr>
                       <a:r>
-                        <a:t>I3_2/all18</a:t>
+                        <a:t>I13_1/all18</a:t>
                       </a:r>
                     </a:p>
                   </a:txBody>
@@ -9931,7 +9932,7 @@
                         </a:defRPr>
                       </a:pPr>
                       <a:r>
-                        <a:t>0.0744</a:t>
+                        <a:t>0.0753</a:t>
                       </a:r>
                     </a:p>
                   </a:txBody>
@@ -9954,7 +9955,7 @@
                         </a:defRPr>
                       </a:pPr>
                       <a:r>
-                        <a:t>0.0703</a:t>
+                        <a:t>0.0713</a:t>
                       </a:r>
                     </a:p>
                   </a:txBody>
@@ -9977,7 +9978,7 @@
                         </a:defRPr>
                       </a:pPr>
                       <a:r>
-                        <a:t>0.0672</a:t>
+                        <a:t>0.0680</a:t>
                       </a:r>
                     </a:p>
                   </a:txBody>
@@ -10000,7 +10001,7 @@
                         </a:defRPr>
                       </a:pPr>
                       <a:r>
-                        <a:t>+317 calls/device</a:t>
+                        <a:t>+322 calls/device</a:t>
                       </a:r>
                     </a:p>
                   </a:txBody>
@@ -10023,7 +10024,7 @@
                         </a:defRPr>
                       </a:pPr>
                       <a:r>
-                        <a:t>I3_2/all18</a:t>
+                        <a:t>I13_1/all18</a:t>
                       </a:r>
                     </a:p>
                   </a:txBody>
@@ -10117,7 +10118,7 @@
                         </a:defRPr>
                       </a:pPr>
                       <a:r>
-                        <a:t>0.0732</a:t>
+                        <a:t>0.0735</a:t>
                       </a:r>
                     </a:p>
                   </a:txBody>
@@ -10140,7 +10141,7 @@
                         </a:defRPr>
                       </a:pPr>
                       <a:r>
-                        <a:t>0.0691</a:t>
+                        <a:t>0.0695</a:t>
                       </a:r>
                     </a:p>
                   </a:txBody>
@@ -10163,7 +10164,7 @@
                         </a:defRPr>
                       </a:pPr>
                       <a:r>
-                        <a:t>0.0643</a:t>
+                        <a:t>0.0637</a:t>
                       </a:r>
                     </a:p>
                   </a:txBody>
@@ -10186,7 +10187,7 @@
                         </a:defRPr>
                       </a:pPr>
                       <a:r>
-                        <a:t>+317 calls/device</a:t>
+                        <a:t>+326 calls/device</a:t>
                       </a:r>
                     </a:p>
                   </a:txBody>
@@ -10209,7 +10210,7 @@
                         </a:defRPr>
                       </a:pPr>
                       <a:r>
-                        <a:t>I3_2/all18</a:t>
+                        <a:t>I13_1/all18</a:t>
                       </a:r>
                     </a:p>
                   </a:txBody>
@@ -11161,12 +11162,12 @@
               </a:spcAft>
             </a:pPr>
             <a:r>
-              <a:rPr sz="950">
+              <a:rPr sz="900">
                 <a:solidFill>
                   <a:srgbClr val="202428"/>
                 </a:solidFill>
               </a:rPr>
-              <a:t>Fixed procedures applied to every device; no per-device choice between methods. Rows with n = 12 compare only with each other.  (a) Re-scored with failed-curve rejection (stored before the fix: 0.1513).  (b) One constant g per (polarity, curve tag), 21 values; defined only at the measured biases.  (c) 43 card parameters per device plus 5 x 353 network weights shared by all devices.  (d) Pre-registered I3-2 run on the 12 former DEV devices.  Cost: NGSpice simulations; '+' = on top of the starting card; direct NGSpice rounds: calls in that round.</a:t>
+              <a:t>Fixed procedures applied to every device; no per-device choice between methods. Rows with n = 12 compare only with each other.  (a) Re-scored with failed-curve rejection (stored before the fix: 0.1513).  (b) One constant g per (polarity, curve tag), 21 values; defined only at the measured biases.  (c) 43 card parameters per device plus 5 x 353 network weights shared by all devices.  (d) Pre-registered I3-2 run on the 12 former DEV devices.  Cost: NGSpice simulations; '+' = on top of the starting card; direct NGSpice rounds: calls in that round.  (e) Starting card scored with the BSIM4 A2 clamp written into the card (I13-1); the earlier rows are the stored scores (old deck, state L; 5 devices have a2 &gt; 1 in the 43-parameter cards).</a:t>
             </a:r>
           </a:p>
         </p:txBody>
@@ -11330,7 +11331,7 @@
                   <a:srgbClr val="202428"/>
                 </a:solidFill>
               </a:rPr>
-              <a:t>Simulator: ngspice-41 (arm64 build; reproduces the reference scores exactly). Every RRMS on these slides is from an NGSpice simulation.</a:t>
+              <a:t>Simulator: ngspice-41 (arm64 build; reproduces the reference scores exactly). Every RRMS on these slides is from an NGSpice simulation, with the BSIM4 A2 clamp written into the card (state C, slide 'BSIM4 A2 clamp').</a:t>
             </a:r>
           </a:p>
           <a:p>
@@ -11688,7 +11689,7 @@
                         </a:defRPr>
                       </a:pPr>
                       <a:r>
-                        <a:t>0.0214</a:t>
+                        <a:t>0.0284</a:t>
                       </a:r>
                     </a:p>
                   </a:txBody>
@@ -11711,7 +11712,7 @@
                         </a:defRPr>
                       </a:pPr>
                       <a:r>
-                        <a:t>0.0226</a:t>
+                        <a:t>0.0297</a:t>
                       </a:r>
                     </a:p>
                   </a:txBody>
@@ -11782,7 +11783,7 @@
                         </a:defRPr>
                       </a:pPr>
                       <a:r>
-                        <a:t>0.0155</a:t>
+                        <a:t>0.0699</a:t>
                       </a:r>
                     </a:p>
                   </a:txBody>
@@ -11805,7 +11806,7 @@
                         </a:defRPr>
                       </a:pPr>
                       <a:r>
-                        <a:t>0.0153</a:t>
+                        <a:t>0.0215</a:t>
                       </a:r>
                     </a:p>
                   </a:txBody>
@@ -11828,7 +11829,7 @@
                         </a:defRPr>
                       </a:pPr>
                       <a:r>
-                        <a:t>0.0183</a:t>
+                        <a:t>0.0190</a:t>
                       </a:r>
                     </a:p>
                   </a:txBody>
@@ -11851,7 +11852,7 @@
                         </a:defRPr>
                       </a:pPr>
                       <a:r>
-                        <a:t>0.0193</a:t>
+                        <a:t>0.0176</a:t>
                       </a:r>
                     </a:p>
                   </a:txBody>
@@ -11922,7 +11923,7 @@
                         </a:defRPr>
                       </a:pPr>
                       <a:r>
-                        <a:t>0.0188</a:t>
+                        <a:t>0.0301</a:t>
                       </a:r>
                     </a:p>
                   </a:txBody>
@@ -11945,7 +11946,7 @@
                         </a:defRPr>
                       </a:pPr>
                       <a:r>
-                        <a:t>0.0188</a:t>
+                        <a:t>0.0194</a:t>
                       </a:r>
                     </a:p>
                   </a:txBody>
@@ -11968,7 +11969,7 @@
                         </a:defRPr>
                       </a:pPr>
                       <a:r>
-                        <a:t>0.0176</a:t>
+                        <a:t>0.0189</a:t>
                       </a:r>
                     </a:p>
                   </a:txBody>
@@ -11991,7 +11992,7 @@
                         </a:defRPr>
                       </a:pPr>
                       <a:r>
-                        <a:t>0.0171</a:t>
+                        <a:t>0.0186</a:t>
                       </a:r>
                     </a:p>
                   </a:txBody>
@@ -12108,7 +12109,7 @@
                         </a:defRPr>
                       </a:pPr>
                       <a:r>
-                        <a:t>0.0678</a:t>
+                        <a:t>0.0694</a:t>
                       </a:r>
                     </a:p>
                   </a:txBody>
@@ -12131,7 +12132,7 @@
                         </a:defRPr>
                       </a:pPr>
                       <a:r>
-                        <a:t>0.0681</a:t>
+                        <a:t>0.0692</a:t>
                       </a:r>
                     </a:p>
                   </a:txBody>
@@ -12248,7 +12249,7 @@
                         </a:defRPr>
                       </a:pPr>
                       <a:r>
-                        <a:t>0.0269</a:t>
+                        <a:t>0.0284</a:t>
                       </a:r>
                     </a:p>
                   </a:txBody>
@@ -12271,7 +12272,7 @@
                         </a:defRPr>
                       </a:pPr>
                       <a:r>
-                        <a:t>0.0251</a:t>
+                        <a:t>0.0262</a:t>
                       </a:r>
                     </a:p>
                   </a:txBody>
@@ -12388,7 +12389,7 @@
                         </a:defRPr>
                       </a:pPr>
                       <a:r>
-                        <a:t>0.0506</a:t>
+                        <a:t>0.0501</a:t>
                       </a:r>
                     </a:p>
                   </a:txBody>
@@ -12411,7 +12412,7 @@
                         </a:defRPr>
                       </a:pPr>
                       <a:r>
-                        <a:t>0.0487</a:t>
+                        <a:t>0.0468</a:t>
                       </a:r>
                     </a:p>
                   </a:txBody>
@@ -12482,7 +12483,7 @@
                         </a:defRPr>
                       </a:pPr>
                       <a:r>
-                        <a:t>0.0491</a:t>
+                        <a:t>0.0797</a:t>
                       </a:r>
                     </a:p>
                   </a:txBody>
@@ -12505,7 +12506,7 @@
                         </a:defRPr>
                       </a:pPr>
                       <a:r>
-                        <a:t>0.0489</a:t>
+                        <a:t>0.0561</a:t>
                       </a:r>
                     </a:p>
                   </a:txBody>
@@ -12528,7 +12529,7 @@
                         </a:defRPr>
                       </a:pPr>
                       <a:r>
-                        <a:t>0.0420</a:t>
+                        <a:t>0.0478</a:t>
                       </a:r>
                     </a:p>
                   </a:txBody>
@@ -12551,7 +12552,7 @@
                         </a:defRPr>
                       </a:pPr>
                       <a:r>
-                        <a:t>0.0415</a:t>
+                        <a:t>0.0465</a:t>
                       </a:r>
                     </a:p>
                   </a:txBody>
@@ -12622,7 +12623,7 @@
                         </a:defRPr>
                       </a:pPr>
                       <a:r>
-                        <a:t>0.0257</a:t>
+                        <a:t>0.0463</a:t>
                       </a:r>
                     </a:p>
                   </a:txBody>
@@ -12645,7 +12646,7 @@
                         </a:defRPr>
                       </a:pPr>
                       <a:r>
-                        <a:t>0.0255</a:t>
+                        <a:t>0.0260</a:t>
                       </a:r>
                     </a:p>
                   </a:txBody>
@@ -12668,7 +12669,7 @@
                         </a:defRPr>
                       </a:pPr>
                       <a:r>
-                        <a:t>0.0194</a:t>
+                        <a:t>0.0190</a:t>
                       </a:r>
                     </a:p>
                   </a:txBody>
@@ -12691,7 +12692,7 @@
                         </a:defRPr>
                       </a:pPr>
                       <a:r>
-                        <a:t>0.0187</a:t>
+                        <a:t>0.0174</a:t>
                       </a:r>
                     </a:p>
                   </a:txBody>
@@ -12808,7 +12809,7 @@
                         </a:defRPr>
                       </a:pPr>
                       <a:r>
-                        <a:t>0.3255</a:t>
+                        <a:t>0.3260</a:t>
                       </a:r>
                     </a:p>
                   </a:txBody>
@@ -12831,7 +12832,7 @@
                         </a:defRPr>
                       </a:pPr>
                       <a:r>
-                        <a:t>0.3315</a:t>
+                        <a:t>0.3308</a:t>
                       </a:r>
                     </a:p>
                   </a:txBody>
@@ -12971,7 +12972,7 @@
                         </a:defRPr>
                       </a:pPr>
                       <a:r>
-                        <a:t>0.1049</a:t>
+                        <a:t>0.1032</a:t>
                       </a:r>
                     </a:p>
                   </a:txBody>
@@ -13088,7 +13089,7 @@
                         </a:defRPr>
                       </a:pPr>
                       <a:r>
-                        <a:t>0.0666</a:t>
+                        <a:t>0.0665</a:t>
                       </a:r>
                     </a:p>
                   </a:txBody>
@@ -13111,7 +13112,7 @@
                         </a:defRPr>
                       </a:pPr>
                       <a:r>
-                        <a:t>0.0605</a:t>
+                        <a:t>0.0582</a:t>
                       </a:r>
                     </a:p>
                   </a:txBody>
@@ -13251,7 +13252,7 @@
                         </a:defRPr>
                       </a:pPr>
                       <a:r>
-                        <a:t>0.0966</a:t>
+                        <a:t>0.0969</a:t>
                       </a:r>
                     </a:p>
                   </a:txBody>
@@ -13391,7 +13392,7 @@
                         </a:defRPr>
                       </a:pPr>
                       <a:r>
-                        <a:t>0.1136</a:t>
+                        <a:t>0.1063</a:t>
                       </a:r>
                     </a:p>
                   </a:txBody>
@@ -13531,7 +13532,7 @@
                         </a:defRPr>
                       </a:pPr>
                       <a:r>
-                        <a:t>0.0707</a:t>
+                        <a:t>0.0701</a:t>
                       </a:r>
                     </a:p>
                   </a:txBody>
@@ -13648,7 +13649,7 @@
                         </a:defRPr>
                       </a:pPr>
                       <a:r>
-                        <a:t>0.0763</a:t>
+                        <a:t>0.0756</a:t>
                       </a:r>
                     </a:p>
                   </a:txBody>
@@ -13671,7 +13672,7 @@
                         </a:defRPr>
                       </a:pPr>
                       <a:r>
-                        <a:t>0.0744</a:t>
+                        <a:t>0.0785</a:t>
                       </a:r>
                     </a:p>
                   </a:txBody>
@@ -13788,7 +13789,7 @@
                         </a:defRPr>
                       </a:pPr>
                       <a:r>
-                        <a:t>0.0752</a:t>
+                        <a:t>0.0751</a:t>
                       </a:r>
                     </a:p>
                   </a:txBody>
@@ -13811,7 +13812,7 @@
                         </a:defRPr>
                       </a:pPr>
                       <a:r>
-                        <a:t>0.0721</a:t>
+                        <a:t>0.0730</a:t>
                       </a:r>
                     </a:p>
                   </a:txBody>
@@ -13928,7 +13929,7 @@
                         </a:defRPr>
                       </a:pPr>
                       <a:r>
-                        <a:t>0.0881</a:t>
+                        <a:t>0.0880</a:t>
                       </a:r>
                     </a:p>
                   </a:txBody>
@@ -13951,7 +13952,7 @@
                         </a:defRPr>
                       </a:pPr>
                       <a:r>
-                        <a:t>0.0778</a:t>
+                        <a:t>0.0769</a:t>
                       </a:r>
                     </a:p>
                   </a:txBody>
@@ -14091,7 +14092,7 @@
                         </a:defRPr>
                       </a:pPr>
                       <a:r>
-                        <a:t>0.0537</a:t>
+                        <a:t>0.0567</a:t>
                       </a:r>
                     </a:p>
                   </a:txBody>
@@ -14162,7 +14163,7 @@
                         </a:defRPr>
                       </a:pPr>
                       <a:r>
-                        <a:t>0.1044</a:t>
+                        <a:t>0.1109</a:t>
                       </a:r>
                     </a:p>
                   </a:txBody>
@@ -14185,7 +14186,7 @@
                         </a:defRPr>
                       </a:pPr>
                       <a:r>
-                        <a:t>0.1043</a:t>
+                        <a:t>0.1051</a:t>
                       </a:r>
                     </a:p>
                   </a:txBody>
@@ -14208,7 +14209,7 @@
                         </a:defRPr>
                       </a:pPr>
                       <a:r>
-                        <a:t>0.0744</a:t>
+                        <a:t>0.0753</a:t>
                       </a:r>
                     </a:p>
                   </a:txBody>
@@ -14231,7 +14232,7 @@
                         </a:defRPr>
                       </a:pPr>
                       <a:r>
-                        <a:t>0.0732</a:t>
+                        <a:t>0.0735</a:t>
                       </a:r>
                     </a:p>
                   </a:txBody>
@@ -14302,7 +14303,7 @@
                         </a:defRPr>
                       </a:pPr>
                       <a:r>
-                        <a:t>0.0976</a:t>
+                        <a:t>0.1049</a:t>
                       </a:r>
                     </a:p>
                   </a:txBody>
@@ -14325,7 +14326,7 @@
                         </a:defRPr>
                       </a:pPr>
                       <a:r>
-                        <a:t>0.0975</a:t>
+                        <a:t>0.0984</a:t>
                       </a:r>
                     </a:p>
                   </a:txBody>
@@ -14348,7 +14349,7 @@
                         </a:defRPr>
                       </a:pPr>
                       <a:r>
-                        <a:t>0.0703</a:t>
+                        <a:t>0.0713</a:t>
                       </a:r>
                     </a:p>
                   </a:txBody>
@@ -14371,7 +14372,7 @@
                         </a:defRPr>
                       </a:pPr>
                       <a:r>
-                        <a:t>0.0691</a:t>
+                        <a:t>0.0695</a:t>
                       </a:r>
                     </a:p>
                   </a:txBody>
@@ -14488,7 +14489,7 @@
                         </a:defRPr>
                       </a:pPr>
                       <a:r>
-                        <a:t>0.0672</a:t>
+                        <a:t>0.0680</a:t>
                       </a:r>
                     </a:p>
                   </a:txBody>
@@ -14511,7 +14512,7 @@
                         </a:defRPr>
                       </a:pPr>
                       <a:r>
-                        <a:t>0.0643</a:t>
+                        <a:t>0.0637</a:t>
                       </a:r>
                     </a:p>
                   </a:txBody>
@@ -14604,7 +14605,7 @@
                   <a:srgbClr val="202428"/>
                 </a:solidFill>
               </a:rPr>
-              <a:t>M_bias below C0_refit on 16 of 18 devices.</a:t>
+              <a:t>M_bias below C0_refit on 17 of 18 devices.</a:t>
             </a:r>
           </a:p>
           <a:p>
@@ -14670,635 +14671,21 @@
                   <a:srgbClr val="202428"/>
                 </a:solidFill>
               </a:rPr>
-              <a:t>Earlier pre-registered run: 12 devices, training on 11</a:t>
+              <a:t>BSIM4 A2 clamp: one model state per card (I13-1)</a:t>
             </a:r>
           </a:p>
         </p:txBody>
       </p:sp>
-      <p:graphicFrame>
-        <p:nvGraphicFramePr>
-          <p:cNvPr id="3" name="Table 2"/>
-          <p:cNvGraphicFramePr>
-            <a:graphicFrameLocks noGrp="1"/>
-          </p:cNvGraphicFramePr>
-          <p:nvPr/>
-        </p:nvGraphicFramePr>
-        <p:xfrm>
-          <a:off x="457200" y="1005840"/>
-          <a:ext cx="10698480" cy="1920240"/>
-        </p:xfrm>
-        <a:graphic>
-          <a:graphicData uri="http://schemas.openxmlformats.org/drawingml/2006/table">
-            <a:tbl>
-              <a:tblPr firstRow="1" bandRow="1">
-                <a:tableStyleId>{5C22544A-7EE6-4342-B048-85BDC9FD1C3A}</a:tableStyleId>
-              </a:tblPr>
-              <a:tblGrid>
-                <a:gridCol w="4846320"/>
-                <a:gridCol w="1463040"/>
-                <a:gridCol w="1463040"/>
-                <a:gridCol w="1463040"/>
-                <a:gridCol w="1463040"/>
-              </a:tblGrid>
-              <a:tr h="384048">
-                <a:tc>
-                  <a:txBody>
-                    <a:bodyPr/>
-                    <a:lstStyle/>
-                    <a:p>
-                      <a:pPr algn="l">
-                        <a:defRPr sz="1300" b="1">
-                          <a:solidFill>
-                            <a:srgbClr val="202428"/>
-                          </a:solidFill>
-                        </a:defRPr>
-                      </a:pPr>
-                      <a:r>
-                        <a:t>Same 12 devices</a:t>
-                      </a:r>
-                    </a:p>
-                  </a:txBody>
-                  <a:tcPr marL="45720" marR="45720" marT="9144" marB="9144">
-                    <a:solidFill>
-                      <a:srgbClr val="E8ECF0"/>
-                    </a:solidFill>
-                  </a:tcPr>
-                </a:tc>
-                <a:tc>
-                  <a:txBody>
-                    <a:bodyPr/>
-                    <a:lstStyle/>
-                    <a:p>
-                      <a:pPr algn="l">
-                        <a:defRPr sz="1300" b="1">
-                          <a:solidFill>
-                            <a:srgbClr val="202428"/>
-                          </a:solidFill>
-                        </a:defRPr>
-                      </a:pPr>
-                      <a:r>
-                        <a:t>Published card</a:t>
-                      </a:r>
-                    </a:p>
-                  </a:txBody>
-                  <a:tcPr marL="45720" marR="45720" marT="9144" marB="9144">
-                    <a:solidFill>
-                      <a:srgbClr val="E8ECF0"/>
-                    </a:solidFill>
-                  </a:tcPr>
-                </a:tc>
-                <a:tc>
-                  <a:txBody>
-                    <a:bodyPr/>
-                    <a:lstStyle/>
-                    <a:p>
-                      <a:pPr algn="l">
-                        <a:defRPr sz="1300" b="1">
-                          <a:solidFill>
-                            <a:srgbClr val="202428"/>
-                          </a:solidFill>
-                        </a:defRPr>
-                      </a:pPr>
-                      <a:r>
-                        <a:t>C0_refit</a:t>
-                      </a:r>
-                    </a:p>
-                  </a:txBody>
-                  <a:tcPr marL="45720" marR="45720" marT="9144" marB="9144">
-                    <a:solidFill>
-                      <a:srgbClr val="E8ECF0"/>
-                    </a:solidFill>
-                  </a:tcPr>
-                </a:tc>
-                <a:tc>
-                  <a:txBody>
-                    <a:bodyPr/>
-                    <a:lstStyle/>
-                    <a:p>
-                      <a:pPr algn="l">
-                        <a:defRPr sz="1300" b="1">
-                          <a:solidFill>
-                            <a:srgbClr val="202428"/>
-                          </a:solidFill>
-                        </a:defRPr>
-                      </a:pPr>
-                      <a:r>
-                        <a:t>T1_inloop</a:t>
-                      </a:r>
-                    </a:p>
-                  </a:txBody>
-                  <a:tcPr marL="45720" marR="45720" marT="9144" marB="9144">
-                    <a:solidFill>
-                      <a:srgbClr val="E8ECF0"/>
-                    </a:solidFill>
-                  </a:tcPr>
-                </a:tc>
-                <a:tc>
-                  <a:txBody>
-                    <a:bodyPr/>
-                    <a:lstStyle/>
-                    <a:p>
-                      <a:pPr algn="l">
-                        <a:defRPr sz="1300" b="1">
-                          <a:solidFill>
-                            <a:srgbClr val="202428"/>
-                          </a:solidFill>
-                        </a:defRPr>
-                      </a:pPr>
-                      <a:r>
-                        <a:t>M_bias</a:t>
-                      </a:r>
-                    </a:p>
-                  </a:txBody>
-                  <a:tcPr marL="45720" marR="45720" marT="9144" marB="9144">
-                    <a:solidFill>
-                      <a:srgbClr val="E8ECF0"/>
-                    </a:solidFill>
-                  </a:tcPr>
-                </a:tc>
-              </a:tr>
-              <a:tr h="384048">
-                <a:tc>
-                  <a:txBody>
-                    <a:bodyPr/>
-                    <a:lstStyle/>
-                    <a:p>
-                      <a:pPr algn="l">
-                        <a:defRPr sz="1300">
-                          <a:solidFill>
-                            <a:srgbClr val="202428"/>
-                          </a:solidFill>
-                        </a:defRPr>
-                      </a:pPr>
-                      <a:r>
-                        <a:t>I3-2 run (2026-10-20), g trained on 11 devices, all-device</a:t>
-                      </a:r>
-                    </a:p>
-                  </a:txBody>
-                  <a:tcPr marL="45720" marR="45720" marT="9144" marB="9144">
-                    <a:solidFill>
-                      <a:srgbClr val="FFFFFF"/>
-                    </a:solidFill>
-                  </a:tcPr>
-                </a:tc>
-                <a:tc>
-                  <a:txBody>
-                    <a:bodyPr/>
-                    <a:lstStyle/>
-                    <a:p>
-                      <a:pPr algn="r">
-                        <a:defRPr sz="1300">
-                          <a:solidFill>
-                            <a:srgbClr val="202428"/>
-                          </a:solidFill>
-                        </a:defRPr>
-                      </a:pPr>
-                      <a:r>
-                        <a:t>0.2848</a:t>
-                      </a:r>
-                    </a:p>
-                  </a:txBody>
-                  <a:tcPr marL="45720" marR="45720" marT="9144" marB="9144">
-                    <a:solidFill>
-                      <a:srgbClr val="FFFFFF"/>
-                    </a:solidFill>
-                  </a:tcPr>
-                </a:tc>
-                <a:tc>
-                  <a:txBody>
-                    <a:bodyPr/>
-                    <a:lstStyle/>
-                    <a:p>
-                      <a:pPr algn="r">
-                        <a:defRPr sz="1300">
-                          <a:solidFill>
-                            <a:srgbClr val="202428"/>
-                          </a:solidFill>
-                        </a:defRPr>
-                      </a:pPr>
-                      <a:r>
-                        <a:t>0.1072</a:t>
-                      </a:r>
-                    </a:p>
-                  </a:txBody>
-                  <a:tcPr marL="45720" marR="45720" marT="9144" marB="9144">
-                    <a:solidFill>
-                      <a:srgbClr val="FFFFFF"/>
-                    </a:solidFill>
-                  </a:tcPr>
-                </a:tc>
-                <a:tc>
-                  <a:txBody>
-                    <a:bodyPr/>
-                    <a:lstStyle/>
-                    <a:p>
-                      <a:pPr algn="r">
-                        <a:defRPr sz="1300">
-                          <a:solidFill>
-                            <a:srgbClr val="202428"/>
-                          </a:solidFill>
-                        </a:defRPr>
-                      </a:pPr>
-                      <a:r>
-                        <a:t>0.0820</a:t>
-                      </a:r>
-                    </a:p>
-                  </a:txBody>
-                  <a:tcPr marL="45720" marR="45720" marT="9144" marB="9144">
-                    <a:solidFill>
-                      <a:srgbClr val="FFFFFF"/>
-                    </a:solidFill>
-                  </a:tcPr>
-                </a:tc>
-                <a:tc>
-                  <a:txBody>
-                    <a:bodyPr/>
-                    <a:lstStyle/>
-                    <a:p>
-                      <a:pPr algn="r">
-                        <a:defRPr sz="1300">
-                          <a:solidFill>
-                            <a:srgbClr val="202428"/>
-                          </a:solidFill>
-                        </a:defRPr>
-                      </a:pPr>
-                      <a:r>
-                        <a:t>0.0806</a:t>
-                      </a:r>
-                    </a:p>
-                  </a:txBody>
-                  <a:tcPr marL="45720" marR="45720" marT="9144" marB="9144">
-                    <a:solidFill>
-                      <a:srgbClr val="FFFFFF"/>
-                    </a:solidFill>
-                  </a:tcPr>
-                </a:tc>
-              </a:tr>
-              <a:tr h="384048">
-                <a:tc>
-                  <a:txBody>
-                    <a:bodyPr/>
-                    <a:lstStyle/>
-                    <a:p>
-                      <a:pPr algn="l">
-                        <a:defRPr sz="1300">
-                          <a:solidFill>
-                            <a:srgbClr val="202428"/>
-                          </a:solidFill>
-                        </a:defRPr>
-                      </a:pPr>
-                      <a:r>
-                        <a:t>I3-2 run (2026-10-20), g trained on 11 devices, combined</a:t>
-                      </a:r>
-                    </a:p>
-                  </a:txBody>
-                  <a:tcPr marL="45720" marR="45720" marT="9144" marB="9144">
-                    <a:solidFill>
-                      <a:srgbClr val="FFFFFF"/>
-                    </a:solidFill>
-                  </a:tcPr>
-                </a:tc>
-                <a:tc>
-                  <a:txBody>
-                    <a:bodyPr/>
-                    <a:lstStyle/>
-                    <a:p>
-                      <a:pPr algn="r">
-                        <a:defRPr sz="1300">
-                          <a:solidFill>
-                            <a:srgbClr val="202428"/>
-                          </a:solidFill>
-                        </a:defRPr>
-                      </a:pPr>
-                      <a:r>
-                        <a:t>0.2608</a:t>
-                      </a:r>
-                    </a:p>
-                  </a:txBody>
-                  <a:tcPr marL="45720" marR="45720" marT="9144" marB="9144">
-                    <a:solidFill>
-                      <a:srgbClr val="FFFFFF"/>
-                    </a:solidFill>
-                  </a:tcPr>
-                </a:tc>
-                <a:tc>
-                  <a:txBody>
-                    <a:bodyPr/>
-                    <a:lstStyle/>
-                    <a:p>
-                      <a:pPr algn="r">
-                        <a:defRPr sz="1300">
-                          <a:solidFill>
-                            <a:srgbClr val="202428"/>
-                          </a:solidFill>
-                        </a:defRPr>
-                      </a:pPr>
-                      <a:r>
-                        <a:t>0.0981</a:t>
-                      </a:r>
-                    </a:p>
-                  </a:txBody>
-                  <a:tcPr marL="45720" marR="45720" marT="9144" marB="9144">
-                    <a:solidFill>
-                      <a:srgbClr val="FFFFFF"/>
-                    </a:solidFill>
-                  </a:tcPr>
-                </a:tc>
-                <a:tc>
-                  <a:txBody>
-                    <a:bodyPr/>
-                    <a:lstStyle/>
-                    <a:p>
-                      <a:pPr algn="r">
-                        <a:defRPr sz="1300">
-                          <a:solidFill>
-                            <a:srgbClr val="202428"/>
-                          </a:solidFill>
-                        </a:defRPr>
-                      </a:pPr>
-                      <a:r>
-                        <a:t>0.0760</a:t>
-                      </a:r>
-                    </a:p>
-                  </a:txBody>
-                  <a:tcPr marL="45720" marR="45720" marT="9144" marB="9144">
-                    <a:solidFill>
-                      <a:srgbClr val="FFFFFF"/>
-                    </a:solidFill>
-                  </a:tcPr>
-                </a:tc>
-                <a:tc>
-                  <a:txBody>
-                    <a:bodyPr/>
-                    <a:lstStyle/>
-                    <a:p>
-                      <a:pPr algn="r">
-                        <a:defRPr sz="1300">
-                          <a:solidFill>
-                            <a:srgbClr val="202428"/>
-                          </a:solidFill>
-                        </a:defRPr>
-                      </a:pPr>
-                      <a:r>
-                        <a:t>0.0749</a:t>
-                      </a:r>
-                    </a:p>
-                  </a:txBody>
-                  <a:tcPr marL="45720" marR="45720" marT="9144" marB="9144">
-                    <a:solidFill>
-                      <a:srgbClr val="FFFFFF"/>
-                    </a:solidFill>
-                  </a:tcPr>
-                </a:tc>
-              </a:tr>
-              <a:tr h="384048">
-                <a:tc>
-                  <a:txBody>
-                    <a:bodyPr/>
-                    <a:lstStyle/>
-                    <a:p>
-                      <a:pPr algn="l">
-                        <a:defRPr sz="1300">
-                          <a:solidFill>
-                            <a:srgbClr val="202428"/>
-                          </a:solidFill>
-                        </a:defRPr>
-                      </a:pPr>
-                      <a:r>
-                        <a:t>All-18 run, g trained on 17 devices, all-device</a:t>
-                      </a:r>
-                    </a:p>
-                  </a:txBody>
-                  <a:tcPr marL="45720" marR="45720" marT="9144" marB="9144">
-                    <a:solidFill>
-                      <a:srgbClr val="FFFFFF"/>
-                    </a:solidFill>
-                  </a:tcPr>
-                </a:tc>
-                <a:tc>
-                  <a:txBody>
-                    <a:bodyPr/>
-                    <a:lstStyle/>
-                    <a:p>
-                      <a:pPr algn="r">
-                        <a:defRPr sz="1300">
-                          <a:solidFill>
-                            <a:srgbClr val="202428"/>
-                          </a:solidFill>
-                        </a:defRPr>
-                      </a:pPr>
-                      <a:r>
-                        <a:t>0.2848</a:t>
-                      </a:r>
-                    </a:p>
-                  </a:txBody>
-                  <a:tcPr marL="45720" marR="45720" marT="9144" marB="9144">
-                    <a:solidFill>
-                      <a:srgbClr val="FFFFFF"/>
-                    </a:solidFill>
-                  </a:tcPr>
-                </a:tc>
-                <a:tc>
-                  <a:txBody>
-                    <a:bodyPr/>
-                    <a:lstStyle/>
-                    <a:p>
-                      <a:pPr algn="r">
-                        <a:defRPr sz="1300">
-                          <a:solidFill>
-                            <a:srgbClr val="202428"/>
-                          </a:solidFill>
-                        </a:defRPr>
-                      </a:pPr>
-                      <a:r>
-                        <a:t>0.1072</a:t>
-                      </a:r>
-                    </a:p>
-                  </a:txBody>
-                  <a:tcPr marL="45720" marR="45720" marT="9144" marB="9144">
-                    <a:solidFill>
-                      <a:srgbClr val="FFFFFF"/>
-                    </a:solidFill>
-                  </a:tcPr>
-                </a:tc>
-                <a:tc>
-                  <a:txBody>
-                    <a:bodyPr/>
-                    <a:lstStyle/>
-                    <a:p>
-                      <a:pPr algn="r">
-                        <a:defRPr sz="1300">
-                          <a:solidFill>
-                            <a:srgbClr val="202428"/>
-                          </a:solidFill>
-                        </a:defRPr>
-                      </a:pPr>
-                      <a:r>
-                        <a:t>0.0822</a:t>
-                      </a:r>
-                    </a:p>
-                  </a:txBody>
-                  <a:tcPr marL="45720" marR="45720" marT="9144" marB="9144">
-                    <a:solidFill>
-                      <a:srgbClr val="FFFFFF"/>
-                    </a:solidFill>
-                  </a:tcPr>
-                </a:tc>
-                <a:tc>
-                  <a:txBody>
-                    <a:bodyPr/>
-                    <a:lstStyle/>
-                    <a:p>
-                      <a:pPr algn="r">
-                        <a:defRPr sz="1300">
-                          <a:solidFill>
-                            <a:srgbClr val="202428"/>
-                          </a:solidFill>
-                        </a:defRPr>
-                      </a:pPr>
-                      <a:r>
-                        <a:t>0.0803</a:t>
-                      </a:r>
-                    </a:p>
-                  </a:txBody>
-                  <a:tcPr marL="45720" marR="45720" marT="9144" marB="9144">
-                    <a:solidFill>
-                      <a:srgbClr val="FFFFFF"/>
-                    </a:solidFill>
-                  </a:tcPr>
-                </a:tc>
-              </a:tr>
-              <a:tr h="384048">
-                <a:tc>
-                  <a:txBody>
-                    <a:bodyPr/>
-                    <a:lstStyle/>
-                    <a:p>
-                      <a:pPr algn="l">
-                        <a:defRPr sz="1300">
-                          <a:solidFill>
-                            <a:srgbClr val="202428"/>
-                          </a:solidFill>
-                        </a:defRPr>
-                      </a:pPr>
-                      <a:r>
-                        <a:t>All-18 run, g trained on 17 devices, combined</a:t>
-                      </a:r>
-                    </a:p>
-                  </a:txBody>
-                  <a:tcPr marL="45720" marR="45720" marT="9144" marB="9144">
-                    <a:solidFill>
-                      <a:srgbClr val="FFFFFF"/>
-                    </a:solidFill>
-                  </a:tcPr>
-                </a:tc>
-                <a:tc>
-                  <a:txBody>
-                    <a:bodyPr/>
-                    <a:lstStyle/>
-                    <a:p>
-                      <a:pPr algn="r">
-                        <a:defRPr sz="1300">
-                          <a:solidFill>
-                            <a:srgbClr val="202428"/>
-                          </a:solidFill>
-                        </a:defRPr>
-                      </a:pPr>
-                      <a:r>
-                        <a:t>0.2608</a:t>
-                      </a:r>
-                    </a:p>
-                  </a:txBody>
-                  <a:tcPr marL="45720" marR="45720" marT="9144" marB="9144">
-                    <a:solidFill>
-                      <a:srgbClr val="FFFFFF"/>
-                    </a:solidFill>
-                  </a:tcPr>
-                </a:tc>
-                <a:tc>
-                  <a:txBody>
-                    <a:bodyPr/>
-                    <a:lstStyle/>
-                    <a:p>
-                      <a:pPr algn="r">
-                        <a:defRPr sz="1300">
-                          <a:solidFill>
-                            <a:srgbClr val="202428"/>
-                          </a:solidFill>
-                        </a:defRPr>
-                      </a:pPr>
-                      <a:r>
-                        <a:t>0.0981</a:t>
-                      </a:r>
-                    </a:p>
-                  </a:txBody>
-                  <a:tcPr marL="45720" marR="45720" marT="9144" marB="9144">
-                    <a:solidFill>
-                      <a:srgbClr val="FFFFFF"/>
-                    </a:solidFill>
-                  </a:tcPr>
-                </a:tc>
-                <a:tc>
-                  <a:txBody>
-                    <a:bodyPr/>
-                    <a:lstStyle/>
-                    <a:p>
-                      <a:pPr algn="r">
-                        <a:defRPr sz="1300">
-                          <a:solidFill>
-                            <a:srgbClr val="202428"/>
-                          </a:solidFill>
-                        </a:defRPr>
-                      </a:pPr>
-                      <a:r>
-                        <a:t>0.0761</a:t>
-                      </a:r>
-                    </a:p>
-                  </a:txBody>
-                  <a:tcPr marL="45720" marR="45720" marT="9144" marB="9144">
-                    <a:solidFill>
-                      <a:srgbClr val="FFFFFF"/>
-                    </a:solidFill>
-                  </a:tcPr>
-                </a:tc>
-                <a:tc>
-                  <a:txBody>
-                    <a:bodyPr/>
-                    <a:lstStyle/>
-                    <a:p>
-                      <a:pPr algn="r">
-                        <a:defRPr sz="1300">
-                          <a:solidFill>
-                            <a:srgbClr val="202428"/>
-                          </a:solidFill>
-                        </a:defRPr>
-                      </a:pPr>
-                      <a:r>
-                        <a:t>0.0745</a:t>
-                      </a:r>
-                    </a:p>
-                  </a:txBody>
-                  <a:tcPr marL="45720" marR="45720" marT="9144" marB="9144">
-                    <a:solidFill>
-                      <a:srgbClr val="FFFFFF"/>
-                    </a:solidFill>
-                  </a:tcPr>
-                </a:tc>
-              </a:tr>
-            </a:tbl>
-          </a:graphicData>
-        </a:graphic>
-      </p:graphicFrame>
       <p:sp>
         <p:nvSpPr>
-          <p:cNvPr id="4" name="TextBox 3"/>
+          <p:cNvPr id="3" name="TextBox 2"/>
           <p:cNvSpPr txBox="1"/>
           <p:nvPr/>
         </p:nvSpPr>
         <p:spPr>
           <a:xfrm>
-            <a:off x="548640" y="3291840"/>
-            <a:ext cx="11064240" cy="2286000"/>
+            <a:off x="548640" y="868680"/>
+            <a:ext cx="11064240" cy="2377440"/>
           </a:xfrm>
           <a:prstGeom prst="rect">
             <a:avLst/>
@@ -15317,12 +14704,12 @@
               </a:spcAft>
             </a:pPr>
             <a:r>
-              <a:rPr sz="1500">
+              <a:rPr sz="1350">
                 <a:solidFill>
                   <a:srgbClr val="202428"/>
                 </a:solidFill>
               </a:rPr>
-              <a:t>The I3-2 run was pre-registered on the 12 former DEV devices; the 6 TEST devices were not loaded then.</a:t>
+              <a:t>ngspice-41 b4check.c checks each BSIM4 model once per process (static model name) and sets A2 = 1 and A1 = 0 when the size-dependent A2 &gt; 1; b4temp.c rebuilds the size-dependent parameters at every analysis.</a:t>
             </a:r>
           </a:p>
           <a:p>
@@ -15332,12 +14719,12 @@
               </a:spcAft>
             </a:pPr>
             <a:r>
-              <a:rPr sz="1500">
+              <a:rPr sz="1350">
                 <a:solidFill>
                   <a:srgbClr val="202428"/>
                 </a:solidFill>
               </a:rPr>
-              <a:t>On 2026-10-21 the user opened the 6 TEST devices. The all-18 run uses the same recipe with 17 training devices per fold.</a:t>
+              <a:t>The measured-curve deck runs one dc analysis per curve in one process. For a card with a2 &gt; 1 the first curve was simulated with A2 = 1, the other curves with the card a2 (state L, all stored 43-parameter scores before I13-1).</a:t>
             </a:r>
           </a:p>
           <a:p>
@@ -15347,16 +14734,899 @@
               </a:spcAft>
             </a:pPr>
             <a:r>
-              <a:rPr sz="1500">
+              <a:rPr sz="1350">
                 <a:solidFill>
                   <a:srgbClr val="202428"/>
                 </a:solidFill>
               </a:rPr>
-              <a:t>C0_refit does not depend on the training devices: on the 12 devices the two runs give the same values (max |difference| 0.0e+00).</a:t>
+              <a:t>a2 &gt; 1 in every 43-parameter arm on nmos_L0p19_W7 (1.877), nmos_L0p25_W1p6 (1.045), nmos_L20_W0p64 (2.002), nmos_L8_W1p6 (1.062), pmos_L0p35_W1p6 (1.253). Published cards: a2 &lt;= 0.467.</a:t>
+            </a:r>
+          </a:p>
+          <a:p>
+            <a:pPr>
+              <a:spcAft>
+                <a:spcPts val="400"/>
+              </a:spcAft>
+            </a:pPr>
+            <a:r>
+              <a:rPr sz="1350">
+                <a:solidFill>
+                  <a:srgbClr val="202428"/>
+                </a:solidFill>
+              </a:rPr>
+              <a:t>Fix: the clamp is written into the card (state C: every curve as in a fresh process). All numbers in this deck are state C; refit and training reruns, starting cards not refit.</a:t>
             </a:r>
           </a:p>
         </p:txBody>
       </p:sp>
+      <p:graphicFrame>
+        <p:nvGraphicFramePr>
+          <p:cNvPr id="4" name="Table 3"/>
+          <p:cNvGraphicFramePr>
+            <a:graphicFrameLocks noGrp="1"/>
+          </p:cNvGraphicFramePr>
+          <p:nvPr/>
+        </p:nvGraphicFramePr>
+        <p:xfrm>
+          <a:off x="548640" y="3291840"/>
+          <a:ext cx="10972800" cy="2962656"/>
+        </p:xfrm>
+        <a:graphic>
+          <a:graphicData uri="http://schemas.openxmlformats.org/drawingml/2006/table">
+            <a:tbl>
+              <a:tblPr firstRow="1" bandRow="1">
+                <a:tableStyleId>{5C22544A-7EE6-4342-B048-85BDC9FD1C3A}</a:tableStyleId>
+              </a:tblPr>
+              <a:tblGrid>
+                <a:gridCol w="3017520"/>
+                <a:gridCol w="3108960"/>
+                <a:gridCol w="3108960"/>
+                <a:gridCol w="1737360"/>
+              </a:tblGrid>
+              <a:tr h="329184">
+                <a:tc>
+                  <a:txBody>
+                    <a:bodyPr/>
+                    <a:lstStyle/>
+                    <a:p>
+                      <a:pPr algn="l">
+                        <a:defRPr sz="1150" b="1">
+                          <a:solidFill>
+                            <a:srgbClr val="202428"/>
+                          </a:solidFill>
+                        </a:defRPr>
+                      </a:pPr>
+                      <a:r>
+                        <a:t>Arm (18 devices)</a:t>
+                      </a:r>
+                    </a:p>
+                  </a:txBody>
+                  <a:tcPr marL="45720" marR="45720" marT="9144" marB="9144">
+                    <a:solidFill>
+                      <a:srgbClr val="E8ECF0"/>
+                    </a:solidFill>
+                  </a:tcPr>
+                </a:tc>
+                <a:tc>
+                  <a:txBody>
+                    <a:bodyPr/>
+                    <a:lstStyle/>
+                    <a:p>
+                      <a:pPr algn="l">
+                        <a:defRPr sz="1150" b="1">
+                          <a:solidFill>
+                            <a:srgbClr val="202428"/>
+                          </a:solidFill>
+                        </a:defRPr>
+                      </a:pPr>
+                      <a:r>
+                        <a:t>Old, state L: all / comb / median</a:t>
+                      </a:r>
+                    </a:p>
+                  </a:txBody>
+                  <a:tcPr marL="45720" marR="45720" marT="9144" marB="9144">
+                    <a:solidFill>
+                      <a:srgbClr val="E8ECF0"/>
+                    </a:solidFill>
+                  </a:tcPr>
+                </a:tc>
+                <a:tc>
+                  <a:txBody>
+                    <a:bodyPr/>
+                    <a:lstStyle/>
+                    <a:p>
+                      <a:pPr algn="l">
+                        <a:defRPr sz="1150" b="1">
+                          <a:solidFill>
+                            <a:srgbClr val="202428"/>
+                          </a:solidFill>
+                        </a:defRPr>
+                      </a:pPr>
+                      <a:r>
+                        <a:t>New, state C: all / comb / median</a:t>
+                      </a:r>
+                    </a:p>
+                  </a:txBody>
+                  <a:tcPr marL="45720" marR="45720" marT="9144" marB="9144">
+                    <a:solidFill>
+                      <a:srgbClr val="E8ECF0"/>
+                    </a:solidFill>
+                  </a:tcPr>
+                </a:tc>
+                <a:tc>
+                  <a:txBody>
+                    <a:bodyPr/>
+                    <a:lstStyle/>
+                    <a:p>
+                      <a:pPr algn="l">
+                        <a:defRPr sz="1150" b="1">
+                          <a:solidFill>
+                            <a:srgbClr val="202428"/>
+                          </a:solidFill>
+                        </a:defRPr>
+                      </a:pPr>
+                      <a:r>
+                        <a:t>New - old (all-device)</a:t>
+                      </a:r>
+                    </a:p>
+                  </a:txBody>
+                  <a:tcPr marL="45720" marR="45720" marT="9144" marB="9144">
+                    <a:solidFill>
+                      <a:srgbClr val="E8ECF0"/>
+                    </a:solidFill>
+                  </a:tcPr>
+                </a:tc>
+              </a:tr>
+              <a:tr h="329184">
+                <a:tc>
+                  <a:txBody>
+                    <a:bodyPr/>
+                    <a:lstStyle/>
+                    <a:p>
+                      <a:pPr algn="l">
+                        <a:defRPr sz="1150">
+                          <a:solidFill>
+                            <a:srgbClr val="202428"/>
+                          </a:solidFill>
+                        </a:defRPr>
+                      </a:pPr>
+                      <a:r>
+                        <a:t>Published 77 K card</a:t>
+                      </a:r>
+                    </a:p>
+                  </a:txBody>
+                  <a:tcPr marL="45720" marR="45720" marT="9144" marB="9144">
+                    <a:solidFill>
+                      <a:srgbClr val="FFFFFF"/>
+                    </a:solidFill>
+                  </a:tcPr>
+                </a:tc>
+                <a:tc>
+                  <a:txBody>
+                    <a:bodyPr/>
+                    <a:lstStyle/>
+                    <a:p>
+                      <a:pPr algn="r">
+                        <a:defRPr sz="1150">
+                          <a:solidFill>
+                            <a:srgbClr val="202428"/>
+                          </a:solidFill>
+                        </a:defRPr>
+                      </a:pPr>
+                      <a:r>
+                        <a:t>0.2751 / 0.2595 / 0.2304</a:t>
+                      </a:r>
+                    </a:p>
+                  </a:txBody>
+                  <a:tcPr marL="45720" marR="45720" marT="9144" marB="9144">
+                    <a:solidFill>
+                      <a:srgbClr val="FFFFFF"/>
+                    </a:solidFill>
+                  </a:tcPr>
+                </a:tc>
+                <a:tc>
+                  <a:txBody>
+                    <a:bodyPr/>
+                    <a:lstStyle/>
+                    <a:p>
+                      <a:pPr algn="r">
+                        <a:defRPr sz="1150">
+                          <a:solidFill>
+                            <a:srgbClr val="202428"/>
+                          </a:solidFill>
+                        </a:defRPr>
+                      </a:pPr>
+                      <a:r>
+                        <a:t>0.2751 / 0.2595 / 0.2304</a:t>
+                      </a:r>
+                    </a:p>
+                  </a:txBody>
+                  <a:tcPr marL="45720" marR="45720" marT="9144" marB="9144">
+                    <a:solidFill>
+                      <a:srgbClr val="FFFFFF"/>
+                    </a:solidFill>
+                  </a:tcPr>
+                </a:tc>
+                <a:tc>
+                  <a:txBody>
+                    <a:bodyPr/>
+                    <a:lstStyle/>
+                    <a:p>
+                      <a:pPr algn="r">
+                        <a:defRPr sz="1150">
+                          <a:solidFill>
+                            <a:srgbClr val="202428"/>
+                          </a:solidFill>
+                        </a:defRPr>
+                      </a:pPr>
+                      <a:r>
+                        <a:t>+0.0000</a:t>
+                      </a:r>
+                    </a:p>
+                  </a:txBody>
+                  <a:tcPr marL="45720" marR="45720" marT="9144" marB="9144">
+                    <a:solidFill>
+                      <a:srgbClr val="FFFFFF"/>
+                    </a:solidFill>
+                  </a:tcPr>
+                </a:tc>
+              </a:tr>
+              <a:tr h="329184">
+                <a:tc>
+                  <a:txBody>
+                    <a:bodyPr/>
+                    <a:lstStyle/>
+                    <a:p>
+                      <a:pPr algn="l">
+                        <a:defRPr sz="1150">
+                          <a:solidFill>
+                            <a:srgbClr val="202428"/>
+                          </a:solidFill>
+                        </a:defRPr>
+                      </a:pPr>
+                      <a:r>
+                        <a:t>Starting card (not refit)</a:t>
+                      </a:r>
+                    </a:p>
+                  </a:txBody>
+                  <a:tcPr marL="45720" marR="45720" marT="9144" marB="9144">
+                    <a:solidFill>
+                      <a:srgbClr val="FFFFFF"/>
+                    </a:solidFill>
+                  </a:tcPr>
+                </a:tc>
+                <a:tc>
+                  <a:txBody>
+                    <a:bodyPr/>
+                    <a:lstStyle/>
+                    <a:p>
+                      <a:pPr algn="r">
+                        <a:defRPr sz="1150">
+                          <a:solidFill>
+                            <a:srgbClr val="202428"/>
+                          </a:solidFill>
+                        </a:defRPr>
+                      </a:pPr>
+                      <a:r>
+                        <a:t>0.1044 / 0.0976 / 0.0823</a:t>
+                      </a:r>
+                    </a:p>
+                  </a:txBody>
+                  <a:tcPr marL="45720" marR="45720" marT="9144" marB="9144">
+                    <a:solidFill>
+                      <a:srgbClr val="FFFFFF"/>
+                    </a:solidFill>
+                  </a:tcPr>
+                </a:tc>
+                <a:tc>
+                  <a:txBody>
+                    <a:bodyPr/>
+                    <a:lstStyle/>
+                    <a:p>
+                      <a:pPr algn="r">
+                        <a:defRPr sz="1150">
+                          <a:solidFill>
+                            <a:srgbClr val="202428"/>
+                          </a:solidFill>
+                        </a:defRPr>
+                      </a:pPr>
+                      <a:r>
+                        <a:t>0.1109 / 0.1049 / 0.0823</a:t>
+                      </a:r>
+                    </a:p>
+                  </a:txBody>
+                  <a:tcPr marL="45720" marR="45720" marT="9144" marB="9144">
+                    <a:solidFill>
+                      <a:srgbClr val="FFFFFF"/>
+                    </a:solidFill>
+                  </a:tcPr>
+                </a:tc>
+                <a:tc>
+                  <a:txBody>
+                    <a:bodyPr/>
+                    <a:lstStyle/>
+                    <a:p>
+                      <a:pPr algn="r">
+                        <a:defRPr sz="1150">
+                          <a:solidFill>
+                            <a:srgbClr val="202428"/>
+                          </a:solidFill>
+                        </a:defRPr>
+                      </a:pPr>
+                      <a:r>
+                        <a:t>+0.0065</a:t>
+                      </a:r>
+                    </a:p>
+                  </a:txBody>
+                  <a:tcPr marL="45720" marR="45720" marT="9144" marB="9144">
+                    <a:solidFill>
+                      <a:srgbClr val="FFFFFF"/>
+                    </a:solidFill>
+                  </a:tcPr>
+                </a:tc>
+              </a:tr>
+              <a:tr h="329184">
+                <a:tc>
+                  <a:txBody>
+                    <a:bodyPr/>
+                    <a:lstStyle/>
+                    <a:p>
+                      <a:pPr algn="l">
+                        <a:defRPr sz="1150">
+                          <a:solidFill>
+                            <a:srgbClr val="202428"/>
+                          </a:solidFill>
+                        </a:defRPr>
+                      </a:pPr>
+                      <a:r>
+                        <a:t>C0_refit</a:t>
+                      </a:r>
+                    </a:p>
+                  </a:txBody>
+                  <a:tcPr marL="45720" marR="45720" marT="9144" marB="9144">
+                    <a:solidFill>
+                      <a:srgbClr val="FFFFFF"/>
+                    </a:solidFill>
+                  </a:tcPr>
+                </a:tc>
+                <a:tc>
+                  <a:txBody>
+                    <a:bodyPr/>
+                    <a:lstStyle/>
+                    <a:p>
+                      <a:pPr algn="r">
+                        <a:defRPr sz="1150">
+                          <a:solidFill>
+                            <a:srgbClr val="202428"/>
+                          </a:solidFill>
+                        </a:defRPr>
+                      </a:pPr>
+                      <a:r>
+                        <a:t>0.1043 / 0.0975 / 0.0820</a:t>
+                      </a:r>
+                    </a:p>
+                  </a:txBody>
+                  <a:tcPr marL="45720" marR="45720" marT="9144" marB="9144">
+                    <a:solidFill>
+                      <a:srgbClr val="FFFFFF"/>
+                    </a:solidFill>
+                  </a:tcPr>
+                </a:tc>
+                <a:tc>
+                  <a:txBody>
+                    <a:bodyPr/>
+                    <a:lstStyle/>
+                    <a:p>
+                      <a:pPr algn="r">
+                        <a:defRPr sz="1150">
+                          <a:solidFill>
+                            <a:srgbClr val="202428"/>
+                          </a:solidFill>
+                        </a:defRPr>
+                      </a:pPr>
+                      <a:r>
+                        <a:t>0.1051 / 0.0984 / 0.0820</a:t>
+                      </a:r>
+                    </a:p>
+                  </a:txBody>
+                  <a:tcPr marL="45720" marR="45720" marT="9144" marB="9144">
+                    <a:solidFill>
+                      <a:srgbClr val="FFFFFF"/>
+                    </a:solidFill>
+                  </a:tcPr>
+                </a:tc>
+                <a:tc>
+                  <a:txBody>
+                    <a:bodyPr/>
+                    <a:lstStyle/>
+                    <a:p>
+                      <a:pPr algn="r">
+                        <a:defRPr sz="1150">
+                          <a:solidFill>
+                            <a:srgbClr val="202428"/>
+                          </a:solidFill>
+                        </a:defRPr>
+                      </a:pPr>
+                      <a:r>
+                        <a:t>+0.0008</a:t>
+                      </a:r>
+                    </a:p>
+                  </a:txBody>
+                  <a:tcPr marL="45720" marR="45720" marT="9144" marB="9144">
+                    <a:solidFill>
+                      <a:srgbClr val="FFFFFF"/>
+                    </a:solidFill>
+                  </a:tcPr>
+                </a:tc>
+              </a:tr>
+              <a:tr h="329184">
+                <a:tc>
+                  <a:txBody>
+                    <a:bodyPr/>
+                    <a:lstStyle/>
+                    <a:p>
+                      <a:pPr algn="l">
+                        <a:defRPr sz="1150">
+                          <a:solidFill>
+                            <a:srgbClr val="202428"/>
+                          </a:solidFill>
+                        </a:defRPr>
+                      </a:pPr>
+                      <a:r>
+                        <a:t>T1_inloop</a:t>
+                      </a:r>
+                    </a:p>
+                  </a:txBody>
+                  <a:tcPr marL="45720" marR="45720" marT="9144" marB="9144">
+                    <a:solidFill>
+                      <a:srgbClr val="FFFFFF"/>
+                    </a:solidFill>
+                  </a:tcPr>
+                </a:tc>
+                <a:tc>
+                  <a:txBody>
+                    <a:bodyPr/>
+                    <a:lstStyle/>
+                    <a:p>
+                      <a:pPr algn="r">
+                        <a:defRPr sz="1150">
+                          <a:solidFill>
+                            <a:srgbClr val="202428"/>
+                          </a:solidFill>
+                        </a:defRPr>
+                      </a:pPr>
+                      <a:r>
+                        <a:t>0.0744 / 0.0703 / 0.0672</a:t>
+                      </a:r>
+                    </a:p>
+                  </a:txBody>
+                  <a:tcPr marL="45720" marR="45720" marT="9144" marB="9144">
+                    <a:solidFill>
+                      <a:srgbClr val="FFFFFF"/>
+                    </a:solidFill>
+                  </a:tcPr>
+                </a:tc>
+                <a:tc>
+                  <a:txBody>
+                    <a:bodyPr/>
+                    <a:lstStyle/>
+                    <a:p>
+                      <a:pPr algn="r">
+                        <a:defRPr sz="1150">
+                          <a:solidFill>
+                            <a:srgbClr val="202428"/>
+                          </a:solidFill>
+                        </a:defRPr>
+                      </a:pPr>
+                      <a:r>
+                        <a:t>0.0753 / 0.0713 / 0.0680</a:t>
+                      </a:r>
+                    </a:p>
+                  </a:txBody>
+                  <a:tcPr marL="45720" marR="45720" marT="9144" marB="9144">
+                    <a:solidFill>
+                      <a:srgbClr val="FFFFFF"/>
+                    </a:solidFill>
+                  </a:tcPr>
+                </a:tc>
+                <a:tc>
+                  <a:txBody>
+                    <a:bodyPr/>
+                    <a:lstStyle/>
+                    <a:p>
+                      <a:pPr algn="r">
+                        <a:defRPr sz="1150">
+                          <a:solidFill>
+                            <a:srgbClr val="202428"/>
+                          </a:solidFill>
+                        </a:defRPr>
+                      </a:pPr>
+                      <a:r>
+                        <a:t>+0.0009</a:t>
+                      </a:r>
+                    </a:p>
+                  </a:txBody>
+                  <a:tcPr marL="45720" marR="45720" marT="9144" marB="9144">
+                    <a:solidFill>
+                      <a:srgbClr val="FFFFFF"/>
+                    </a:solidFill>
+                  </a:tcPr>
+                </a:tc>
+              </a:tr>
+              <a:tr h="329184">
+                <a:tc>
+                  <a:txBody>
+                    <a:bodyPr/>
+                    <a:lstStyle/>
+                    <a:p>
+                      <a:pPr algn="l">
+                        <a:defRPr sz="1150">
+                          <a:solidFill>
+                            <a:srgbClr val="202428"/>
+                          </a:solidFill>
+                        </a:defRPr>
+                      </a:pPr>
+                      <a:r>
+                        <a:t>M_bias</a:t>
+                      </a:r>
+                    </a:p>
+                  </a:txBody>
+                  <a:tcPr marL="45720" marR="45720" marT="9144" marB="9144">
+                    <a:solidFill>
+                      <a:srgbClr val="FFFFFF"/>
+                    </a:solidFill>
+                  </a:tcPr>
+                </a:tc>
+                <a:tc>
+                  <a:txBody>
+                    <a:bodyPr/>
+                    <a:lstStyle/>
+                    <a:p>
+                      <a:pPr algn="r">
+                        <a:defRPr sz="1150">
+                          <a:solidFill>
+                            <a:srgbClr val="202428"/>
+                          </a:solidFill>
+                        </a:defRPr>
+                      </a:pPr>
+                      <a:r>
+                        <a:t>0.0732 / 0.0691 / 0.0643</a:t>
+                      </a:r>
+                    </a:p>
+                  </a:txBody>
+                  <a:tcPr marL="45720" marR="45720" marT="9144" marB="9144">
+                    <a:solidFill>
+                      <a:srgbClr val="FFFFFF"/>
+                    </a:solidFill>
+                  </a:tcPr>
+                </a:tc>
+                <a:tc>
+                  <a:txBody>
+                    <a:bodyPr/>
+                    <a:lstStyle/>
+                    <a:p>
+                      <a:pPr algn="r">
+                        <a:defRPr sz="1150">
+                          <a:solidFill>
+                            <a:srgbClr val="202428"/>
+                          </a:solidFill>
+                        </a:defRPr>
+                      </a:pPr>
+                      <a:r>
+                        <a:t>0.0735 / 0.0695 / 0.0637</a:t>
+                      </a:r>
+                    </a:p>
+                  </a:txBody>
+                  <a:tcPr marL="45720" marR="45720" marT="9144" marB="9144">
+                    <a:solidFill>
+                      <a:srgbClr val="FFFFFF"/>
+                    </a:solidFill>
+                  </a:tcPr>
+                </a:tc>
+                <a:tc>
+                  <a:txBody>
+                    <a:bodyPr/>
+                    <a:lstStyle/>
+                    <a:p>
+                      <a:pPr algn="r">
+                        <a:defRPr sz="1150">
+                          <a:solidFill>
+                            <a:srgbClr val="202428"/>
+                          </a:solidFill>
+                        </a:defRPr>
+                      </a:pPr>
+                      <a:r>
+                        <a:t>+0.0003</a:t>
+                      </a:r>
+                    </a:p>
+                  </a:txBody>
+                  <a:tcPr marL="45720" marR="45720" marT="9144" marB="9144">
+                    <a:solidFill>
+                      <a:srgbClr val="FFFFFF"/>
+                    </a:solidFill>
+                  </a:tcPr>
+                </a:tc>
+              </a:tr>
+              <a:tr h="329184">
+                <a:tc>
+                  <a:txBody>
+                    <a:bodyPr/>
+                    <a:lstStyle/>
+                    <a:p>
+                      <a:pPr algn="l">
+                        <a:defRPr sz="1150">
+                          <a:solidFill>
+                            <a:srgbClr val="202428"/>
+                          </a:solidFill>
+                        </a:defRPr>
+                      </a:pPr>
+                      <a:r>
+                        <a:t>M_bias v2 (symmetric inputs, I12-1)</a:t>
+                      </a:r>
+                    </a:p>
+                  </a:txBody>
+                  <a:tcPr marL="45720" marR="45720" marT="9144" marB="9144">
+                    <a:solidFill>
+                      <a:srgbClr val="FFFFFF"/>
+                    </a:solidFill>
+                  </a:tcPr>
+                </a:tc>
+                <a:tc>
+                  <a:txBody>
+                    <a:bodyPr/>
+                    <a:lstStyle/>
+                    <a:p>
+                      <a:pPr algn="r">
+                        <a:defRPr sz="1150">
+                          <a:solidFill>
+                            <a:srgbClr val="202428"/>
+                          </a:solidFill>
+                        </a:defRPr>
+                      </a:pPr>
+                      <a:r>
+                        <a:t>0.0774 / 0.0732 / 0.0534</a:t>
+                      </a:r>
+                    </a:p>
+                  </a:txBody>
+                  <a:tcPr marL="45720" marR="45720" marT="9144" marB="9144">
+                    <a:solidFill>
+                      <a:srgbClr val="FFFFFF"/>
+                    </a:solidFill>
+                  </a:tcPr>
+                </a:tc>
+                <a:tc>
+                  <a:txBody>
+                    <a:bodyPr/>
+                    <a:lstStyle/>
+                    <a:p>
+                      <a:pPr algn="r">
+                        <a:defRPr sz="1150">
+                          <a:solidFill>
+                            <a:srgbClr val="202428"/>
+                          </a:solidFill>
+                        </a:defRPr>
+                      </a:pPr>
+                      <a:r>
+                        <a:t>0.0772 / 0.0732 / 0.0544</a:t>
+                      </a:r>
+                    </a:p>
+                  </a:txBody>
+                  <a:tcPr marL="45720" marR="45720" marT="9144" marB="9144">
+                    <a:solidFill>
+                      <a:srgbClr val="FFFFFF"/>
+                    </a:solidFill>
+                  </a:tcPr>
+                </a:tc>
+                <a:tc>
+                  <a:txBody>
+                    <a:bodyPr/>
+                    <a:lstStyle/>
+                    <a:p>
+                      <a:pPr algn="r">
+                        <a:defRPr sz="1150">
+                          <a:solidFill>
+                            <a:srgbClr val="202428"/>
+                          </a:solidFill>
+                        </a:defRPr>
+                      </a:pPr>
+                      <a:r>
+                        <a:t>-0.0002</a:t>
+                      </a:r>
+                    </a:p>
+                  </a:txBody>
+                  <a:tcPr marL="45720" marR="45720" marT="9144" marB="9144">
+                    <a:solidFill>
+                      <a:srgbClr val="FFFFFF"/>
+                    </a:solidFill>
+                  </a:tcPr>
+                </a:tc>
+              </a:tr>
+              <a:tr h="329184">
+                <a:tc>
+                  <a:txBody>
+                    <a:bodyPr/>
+                    <a:lstStyle/>
+                    <a:p>
+                      <a:pPr algn="l">
+                        <a:defRPr sz="1150">
+                          <a:solidFill>
+                            <a:srgbClr val="202428"/>
+                          </a:solidFill>
+                        </a:defRPr>
+                      </a:pPr>
+                      <a:r>
+                        <a:t>GMR M_bias / C0_refit</a:t>
+                      </a:r>
+                    </a:p>
+                  </a:txBody>
+                  <a:tcPr marL="45720" marR="45720" marT="9144" marB="9144">
+                    <a:solidFill>
+                      <a:srgbClr val="FFFFFF"/>
+                    </a:solidFill>
+                  </a:tcPr>
+                </a:tc>
+                <a:tc>
+                  <a:txBody>
+                    <a:bodyPr/>
+                    <a:lstStyle/>
+                    <a:p>
+                      <a:pPr algn="r">
+                        <a:defRPr sz="1150">
+                          <a:solidFill>
+                            <a:srgbClr val="202428"/>
+                          </a:solidFill>
+                        </a:defRPr>
+                      </a:pPr>
+                      <a:r>
+                        <a:t>0.755 [0.673, 0.852], 16/18</a:t>
+                      </a:r>
+                    </a:p>
+                  </a:txBody>
+                  <a:tcPr marL="45720" marR="45720" marT="9144" marB="9144">
+                    <a:solidFill>
+                      <a:srgbClr val="FFFFFF"/>
+                    </a:solidFill>
+                  </a:tcPr>
+                </a:tc>
+                <a:tc>
+                  <a:txBody>
+                    <a:bodyPr/>
+                    <a:lstStyle/>
+                    <a:p>
+                      <a:pPr algn="r">
+                        <a:defRPr sz="1150">
+                          <a:solidFill>
+                            <a:srgbClr val="202428"/>
+                          </a:solidFill>
+                        </a:defRPr>
+                      </a:pPr>
+                      <a:r>
+                        <a:t>0.745 [0.660, 0.850], 17/18</a:t>
+                      </a:r>
+                    </a:p>
+                  </a:txBody>
+                  <a:tcPr marL="45720" marR="45720" marT="9144" marB="9144">
+                    <a:solidFill>
+                      <a:srgbClr val="FFFFFF"/>
+                    </a:solidFill>
+                  </a:tcPr>
+                </a:tc>
+                <a:tc>
+                  <a:txBody>
+                    <a:bodyPr/>
+                    <a:lstStyle/>
+                    <a:p>
+                      <a:pPr algn="r">
+                        <a:defRPr sz="1150">
+                          <a:solidFill>
+                            <a:srgbClr val="202428"/>
+                          </a:solidFill>
+                        </a:defRPr>
+                      </a:pPr>
+                    </a:p>
+                  </a:txBody>
+                  <a:tcPr marL="45720" marR="45720" marT="9144" marB="9144">
+                    <a:solidFill>
+                      <a:srgbClr val="FFFFFF"/>
+                    </a:solidFill>
+                  </a:tcPr>
+                </a:tc>
+              </a:tr>
+              <a:tr h="329184">
+                <a:tc>
+                  <a:txBody>
+                    <a:bodyPr/>
+                    <a:lstStyle/>
+                    <a:p>
+                      <a:pPr algn="l">
+                        <a:defRPr sz="1150">
+                          <a:solidFill>
+                            <a:srgbClr val="202428"/>
+                          </a:solidFill>
+                        </a:defRPr>
+                      </a:pPr>
+                      <a:r>
+                        <a:t>GMR M_bias / T1_inloop</a:t>
+                      </a:r>
+                    </a:p>
+                  </a:txBody>
+                  <a:tcPr marL="45720" marR="45720" marT="9144" marB="9144">
+                    <a:solidFill>
+                      <a:srgbClr val="FFFFFF"/>
+                    </a:solidFill>
+                  </a:tcPr>
+                </a:tc>
+                <a:tc>
+                  <a:txBody>
+                    <a:bodyPr/>
+                    <a:lstStyle/>
+                    <a:p>
+                      <a:pPr algn="r">
+                        <a:defRPr sz="1150">
+                          <a:solidFill>
+                            <a:srgbClr val="202428"/>
+                          </a:solidFill>
+                        </a:defRPr>
+                      </a:pPr>
+                      <a:r>
+                        <a:t>0.974 [0.945, 1.001], 11/18</a:t>
+                      </a:r>
+                    </a:p>
+                  </a:txBody>
+                  <a:tcPr marL="45720" marR="45720" marT="9144" marB="9144">
+                    <a:solidFill>
+                      <a:srgbClr val="FFFFFF"/>
+                    </a:solidFill>
+                  </a:tcPr>
+                </a:tc>
+                <a:tc>
+                  <a:txBody>
+                    <a:bodyPr/>
+                    <a:lstStyle/>
+                    <a:p>
+                      <a:pPr algn="r">
+                        <a:defRPr sz="1150">
+                          <a:solidFill>
+                            <a:srgbClr val="202428"/>
+                          </a:solidFill>
+                        </a:defRPr>
+                      </a:pPr>
+                      <a:r>
+                        <a:t>0.960 [0.934, 0.986], 14/18</a:t>
+                      </a:r>
+                    </a:p>
+                  </a:txBody>
+                  <a:tcPr marL="45720" marR="45720" marT="9144" marB="9144">
+                    <a:solidFill>
+                      <a:srgbClr val="FFFFFF"/>
+                    </a:solidFill>
+                  </a:tcPr>
+                </a:tc>
+                <a:tc>
+                  <a:txBody>
+                    <a:bodyPr/>
+                    <a:lstStyle/>
+                    <a:p>
+                      <a:pPr algn="r">
+                        <a:defRPr sz="1150">
+                          <a:solidFill>
+                            <a:srgbClr val="202428"/>
+                          </a:solidFill>
+                        </a:defRPr>
+                      </a:pPr>
+                    </a:p>
+                  </a:txBody>
+                  <a:tcPr marL="45720" marR="45720" marT="9144" marB="9144">
+                    <a:solidFill>
+                      <a:srgbClr val="FFFFFF"/>
+                    </a:solidFill>
+                  </a:tcPr>
+                </a:tc>
+              </a:tr>
+            </a:tbl>
+          </a:graphicData>
+        </a:graphic>
+      </p:graphicFrame>
     </p:spTree>
   </p:cSld>
   <p:clrMapOvr>
@@ -15403,35 +15673,693 @@
                   <a:srgbClr val="202428"/>
                 </a:solidFill>
               </a:rPr>
-              <a:t>Per-device RRMS, 18 devices (log scale)</a:t>
+              <a:t>Earlier pre-registered run: 12 devices, training on 11</a:t>
             </a:r>
           </a:p>
         </p:txBody>
       </p:sp>
-      <p:pic>
-        <p:nvPicPr>
-          <p:cNvPr id="3" name="Picture 2" descr="rrms_per_device.png"/>
-          <p:cNvPicPr>
-            <a:picLocks noChangeAspect="1"/>
-          </p:cNvPicPr>
+      <p:graphicFrame>
+        <p:nvGraphicFramePr>
+          <p:cNvPr id="3" name="Table 2"/>
+          <p:cNvGraphicFramePr>
+            <a:graphicFrameLocks noGrp="1"/>
+          </p:cNvGraphicFramePr>
           <p:nvPr/>
-        </p:nvPicPr>
-        <p:blipFill>
-          <a:blip r:embed="rId2"/>
-          <a:stretch>
-            <a:fillRect/>
-          </a:stretch>
-        </p:blipFill>
+        </p:nvGraphicFramePr>
+        <p:xfrm>
+          <a:off x="457200" y="1005840"/>
+          <a:ext cx="10698480" cy="1920240"/>
+        </p:xfrm>
+        <a:graphic>
+          <a:graphicData uri="http://schemas.openxmlformats.org/drawingml/2006/table">
+            <a:tbl>
+              <a:tblPr firstRow="1" bandRow="1">
+                <a:tableStyleId>{5C22544A-7EE6-4342-B048-85BDC9FD1C3A}</a:tableStyleId>
+              </a:tblPr>
+              <a:tblGrid>
+                <a:gridCol w="4846320"/>
+                <a:gridCol w="1463040"/>
+                <a:gridCol w="1463040"/>
+                <a:gridCol w="1463040"/>
+                <a:gridCol w="1463040"/>
+              </a:tblGrid>
+              <a:tr h="384048">
+                <a:tc>
+                  <a:txBody>
+                    <a:bodyPr/>
+                    <a:lstStyle/>
+                    <a:p>
+                      <a:pPr algn="l">
+                        <a:defRPr sz="1300" b="1">
+                          <a:solidFill>
+                            <a:srgbClr val="202428"/>
+                          </a:solidFill>
+                        </a:defRPr>
+                      </a:pPr>
+                      <a:r>
+                        <a:t>Same 12 devices</a:t>
+                      </a:r>
+                    </a:p>
+                  </a:txBody>
+                  <a:tcPr marL="45720" marR="45720" marT="9144" marB="9144">
+                    <a:solidFill>
+                      <a:srgbClr val="E8ECF0"/>
+                    </a:solidFill>
+                  </a:tcPr>
+                </a:tc>
+                <a:tc>
+                  <a:txBody>
+                    <a:bodyPr/>
+                    <a:lstStyle/>
+                    <a:p>
+                      <a:pPr algn="l">
+                        <a:defRPr sz="1300" b="1">
+                          <a:solidFill>
+                            <a:srgbClr val="202428"/>
+                          </a:solidFill>
+                        </a:defRPr>
+                      </a:pPr>
+                      <a:r>
+                        <a:t>Published card</a:t>
+                      </a:r>
+                    </a:p>
+                  </a:txBody>
+                  <a:tcPr marL="45720" marR="45720" marT="9144" marB="9144">
+                    <a:solidFill>
+                      <a:srgbClr val="E8ECF0"/>
+                    </a:solidFill>
+                  </a:tcPr>
+                </a:tc>
+                <a:tc>
+                  <a:txBody>
+                    <a:bodyPr/>
+                    <a:lstStyle/>
+                    <a:p>
+                      <a:pPr algn="l">
+                        <a:defRPr sz="1300" b="1">
+                          <a:solidFill>
+                            <a:srgbClr val="202428"/>
+                          </a:solidFill>
+                        </a:defRPr>
+                      </a:pPr>
+                      <a:r>
+                        <a:t>C0_refit</a:t>
+                      </a:r>
+                    </a:p>
+                  </a:txBody>
+                  <a:tcPr marL="45720" marR="45720" marT="9144" marB="9144">
+                    <a:solidFill>
+                      <a:srgbClr val="E8ECF0"/>
+                    </a:solidFill>
+                  </a:tcPr>
+                </a:tc>
+                <a:tc>
+                  <a:txBody>
+                    <a:bodyPr/>
+                    <a:lstStyle/>
+                    <a:p>
+                      <a:pPr algn="l">
+                        <a:defRPr sz="1300" b="1">
+                          <a:solidFill>
+                            <a:srgbClr val="202428"/>
+                          </a:solidFill>
+                        </a:defRPr>
+                      </a:pPr>
+                      <a:r>
+                        <a:t>T1_inloop</a:t>
+                      </a:r>
+                    </a:p>
+                  </a:txBody>
+                  <a:tcPr marL="45720" marR="45720" marT="9144" marB="9144">
+                    <a:solidFill>
+                      <a:srgbClr val="E8ECF0"/>
+                    </a:solidFill>
+                  </a:tcPr>
+                </a:tc>
+                <a:tc>
+                  <a:txBody>
+                    <a:bodyPr/>
+                    <a:lstStyle/>
+                    <a:p>
+                      <a:pPr algn="l">
+                        <a:defRPr sz="1300" b="1">
+                          <a:solidFill>
+                            <a:srgbClr val="202428"/>
+                          </a:solidFill>
+                        </a:defRPr>
+                      </a:pPr>
+                      <a:r>
+                        <a:t>M_bias</a:t>
+                      </a:r>
+                    </a:p>
+                  </a:txBody>
+                  <a:tcPr marL="45720" marR="45720" marT="9144" marB="9144">
+                    <a:solidFill>
+                      <a:srgbClr val="E8ECF0"/>
+                    </a:solidFill>
+                  </a:tcPr>
+                </a:tc>
+              </a:tr>
+              <a:tr h="384048">
+                <a:tc>
+                  <a:txBody>
+                    <a:bodyPr/>
+                    <a:lstStyle/>
+                    <a:p>
+                      <a:pPr algn="l">
+                        <a:defRPr sz="1300">
+                          <a:solidFill>
+                            <a:srgbClr val="202428"/>
+                          </a:solidFill>
+                        </a:defRPr>
+                      </a:pPr>
+                      <a:r>
+                        <a:t>I3-2 run (2026-10-20, state L), g trained on 11 devices, all-device</a:t>
+                      </a:r>
+                    </a:p>
+                  </a:txBody>
+                  <a:tcPr marL="45720" marR="45720" marT="9144" marB="9144">
+                    <a:solidFill>
+                      <a:srgbClr val="FFFFFF"/>
+                    </a:solidFill>
+                  </a:tcPr>
+                </a:tc>
+                <a:tc>
+                  <a:txBody>
+                    <a:bodyPr/>
+                    <a:lstStyle/>
+                    <a:p>
+                      <a:pPr algn="r">
+                        <a:defRPr sz="1300">
+                          <a:solidFill>
+                            <a:srgbClr val="202428"/>
+                          </a:solidFill>
+                        </a:defRPr>
+                      </a:pPr>
+                      <a:r>
+                        <a:t>0.2848</a:t>
+                      </a:r>
+                    </a:p>
+                  </a:txBody>
+                  <a:tcPr marL="45720" marR="45720" marT="9144" marB="9144">
+                    <a:solidFill>
+                      <a:srgbClr val="FFFFFF"/>
+                    </a:solidFill>
+                  </a:tcPr>
+                </a:tc>
+                <a:tc>
+                  <a:txBody>
+                    <a:bodyPr/>
+                    <a:lstStyle/>
+                    <a:p>
+                      <a:pPr algn="r">
+                        <a:defRPr sz="1300">
+                          <a:solidFill>
+                            <a:srgbClr val="202428"/>
+                          </a:solidFill>
+                        </a:defRPr>
+                      </a:pPr>
+                      <a:r>
+                        <a:t>0.1072</a:t>
+                      </a:r>
+                    </a:p>
+                  </a:txBody>
+                  <a:tcPr marL="45720" marR="45720" marT="9144" marB="9144">
+                    <a:solidFill>
+                      <a:srgbClr val="FFFFFF"/>
+                    </a:solidFill>
+                  </a:tcPr>
+                </a:tc>
+                <a:tc>
+                  <a:txBody>
+                    <a:bodyPr/>
+                    <a:lstStyle/>
+                    <a:p>
+                      <a:pPr algn="r">
+                        <a:defRPr sz="1300">
+                          <a:solidFill>
+                            <a:srgbClr val="202428"/>
+                          </a:solidFill>
+                        </a:defRPr>
+                      </a:pPr>
+                      <a:r>
+                        <a:t>0.0820</a:t>
+                      </a:r>
+                    </a:p>
+                  </a:txBody>
+                  <a:tcPr marL="45720" marR="45720" marT="9144" marB="9144">
+                    <a:solidFill>
+                      <a:srgbClr val="FFFFFF"/>
+                    </a:solidFill>
+                  </a:tcPr>
+                </a:tc>
+                <a:tc>
+                  <a:txBody>
+                    <a:bodyPr/>
+                    <a:lstStyle/>
+                    <a:p>
+                      <a:pPr algn="r">
+                        <a:defRPr sz="1300">
+                          <a:solidFill>
+                            <a:srgbClr val="202428"/>
+                          </a:solidFill>
+                        </a:defRPr>
+                      </a:pPr>
+                      <a:r>
+                        <a:t>0.0806</a:t>
+                      </a:r>
+                    </a:p>
+                  </a:txBody>
+                  <a:tcPr marL="45720" marR="45720" marT="9144" marB="9144">
+                    <a:solidFill>
+                      <a:srgbClr val="FFFFFF"/>
+                    </a:solidFill>
+                  </a:tcPr>
+                </a:tc>
+              </a:tr>
+              <a:tr h="384048">
+                <a:tc>
+                  <a:txBody>
+                    <a:bodyPr/>
+                    <a:lstStyle/>
+                    <a:p>
+                      <a:pPr algn="l">
+                        <a:defRPr sz="1300">
+                          <a:solidFill>
+                            <a:srgbClr val="202428"/>
+                          </a:solidFill>
+                        </a:defRPr>
+                      </a:pPr>
+                      <a:r>
+                        <a:t>I3-2 run (2026-10-20, state L), g trained on 11 devices, combined</a:t>
+                      </a:r>
+                    </a:p>
+                  </a:txBody>
+                  <a:tcPr marL="45720" marR="45720" marT="9144" marB="9144">
+                    <a:solidFill>
+                      <a:srgbClr val="FFFFFF"/>
+                    </a:solidFill>
+                  </a:tcPr>
+                </a:tc>
+                <a:tc>
+                  <a:txBody>
+                    <a:bodyPr/>
+                    <a:lstStyle/>
+                    <a:p>
+                      <a:pPr algn="r">
+                        <a:defRPr sz="1300">
+                          <a:solidFill>
+                            <a:srgbClr val="202428"/>
+                          </a:solidFill>
+                        </a:defRPr>
+                      </a:pPr>
+                      <a:r>
+                        <a:t>0.2608</a:t>
+                      </a:r>
+                    </a:p>
+                  </a:txBody>
+                  <a:tcPr marL="45720" marR="45720" marT="9144" marB="9144">
+                    <a:solidFill>
+                      <a:srgbClr val="FFFFFF"/>
+                    </a:solidFill>
+                  </a:tcPr>
+                </a:tc>
+                <a:tc>
+                  <a:txBody>
+                    <a:bodyPr/>
+                    <a:lstStyle/>
+                    <a:p>
+                      <a:pPr algn="r">
+                        <a:defRPr sz="1300">
+                          <a:solidFill>
+                            <a:srgbClr val="202428"/>
+                          </a:solidFill>
+                        </a:defRPr>
+                      </a:pPr>
+                      <a:r>
+                        <a:t>0.0981</a:t>
+                      </a:r>
+                    </a:p>
+                  </a:txBody>
+                  <a:tcPr marL="45720" marR="45720" marT="9144" marB="9144">
+                    <a:solidFill>
+                      <a:srgbClr val="FFFFFF"/>
+                    </a:solidFill>
+                  </a:tcPr>
+                </a:tc>
+                <a:tc>
+                  <a:txBody>
+                    <a:bodyPr/>
+                    <a:lstStyle/>
+                    <a:p>
+                      <a:pPr algn="r">
+                        <a:defRPr sz="1300">
+                          <a:solidFill>
+                            <a:srgbClr val="202428"/>
+                          </a:solidFill>
+                        </a:defRPr>
+                      </a:pPr>
+                      <a:r>
+                        <a:t>0.0760</a:t>
+                      </a:r>
+                    </a:p>
+                  </a:txBody>
+                  <a:tcPr marL="45720" marR="45720" marT="9144" marB="9144">
+                    <a:solidFill>
+                      <a:srgbClr val="FFFFFF"/>
+                    </a:solidFill>
+                  </a:tcPr>
+                </a:tc>
+                <a:tc>
+                  <a:txBody>
+                    <a:bodyPr/>
+                    <a:lstStyle/>
+                    <a:p>
+                      <a:pPr algn="r">
+                        <a:defRPr sz="1300">
+                          <a:solidFill>
+                            <a:srgbClr val="202428"/>
+                          </a:solidFill>
+                        </a:defRPr>
+                      </a:pPr>
+                      <a:r>
+                        <a:t>0.0749</a:t>
+                      </a:r>
+                    </a:p>
+                  </a:txBody>
+                  <a:tcPr marL="45720" marR="45720" marT="9144" marB="9144">
+                    <a:solidFill>
+                      <a:srgbClr val="FFFFFF"/>
+                    </a:solidFill>
+                  </a:tcPr>
+                </a:tc>
+              </a:tr>
+              <a:tr h="384048">
+                <a:tc>
+                  <a:txBody>
+                    <a:bodyPr/>
+                    <a:lstStyle/>
+                    <a:p>
+                      <a:pPr algn="l">
+                        <a:defRPr sz="1300">
+                          <a:solidFill>
+                            <a:srgbClr val="202428"/>
+                          </a:solidFill>
+                        </a:defRPr>
+                      </a:pPr>
+                      <a:r>
+                        <a:t>All-18 run (state C), g trained on 17 devices, all-device</a:t>
+                      </a:r>
+                    </a:p>
+                  </a:txBody>
+                  <a:tcPr marL="45720" marR="45720" marT="9144" marB="9144">
+                    <a:solidFill>
+                      <a:srgbClr val="FFFFFF"/>
+                    </a:solidFill>
+                  </a:tcPr>
+                </a:tc>
+                <a:tc>
+                  <a:txBody>
+                    <a:bodyPr/>
+                    <a:lstStyle/>
+                    <a:p>
+                      <a:pPr algn="r">
+                        <a:defRPr sz="1300">
+                          <a:solidFill>
+                            <a:srgbClr val="202428"/>
+                          </a:solidFill>
+                        </a:defRPr>
+                      </a:pPr>
+                      <a:r>
+                        <a:t>0.2848</a:t>
+                      </a:r>
+                    </a:p>
+                  </a:txBody>
+                  <a:tcPr marL="45720" marR="45720" marT="9144" marB="9144">
+                    <a:solidFill>
+                      <a:srgbClr val="FFFFFF"/>
+                    </a:solidFill>
+                  </a:tcPr>
+                </a:tc>
+                <a:tc>
+                  <a:txBody>
+                    <a:bodyPr/>
+                    <a:lstStyle/>
+                    <a:p>
+                      <a:pPr algn="r">
+                        <a:defRPr sz="1300">
+                          <a:solidFill>
+                            <a:srgbClr val="202428"/>
+                          </a:solidFill>
+                        </a:defRPr>
+                      </a:pPr>
+                      <a:r>
+                        <a:t>0.1078</a:t>
+                      </a:r>
+                    </a:p>
+                  </a:txBody>
+                  <a:tcPr marL="45720" marR="45720" marT="9144" marB="9144">
+                    <a:solidFill>
+                      <a:srgbClr val="FFFFFF"/>
+                    </a:solidFill>
+                  </a:tcPr>
+                </a:tc>
+                <a:tc>
+                  <a:txBody>
+                    <a:bodyPr/>
+                    <a:lstStyle/>
+                    <a:p>
+                      <a:pPr algn="r">
+                        <a:defRPr sz="1300">
+                          <a:solidFill>
+                            <a:srgbClr val="202428"/>
+                          </a:solidFill>
+                        </a:defRPr>
+                      </a:pPr>
+                      <a:r>
+                        <a:t>0.0834</a:t>
+                      </a:r>
+                    </a:p>
+                  </a:txBody>
+                  <a:tcPr marL="45720" marR="45720" marT="9144" marB="9144">
+                    <a:solidFill>
+                      <a:srgbClr val="FFFFFF"/>
+                    </a:solidFill>
+                  </a:tcPr>
+                </a:tc>
+                <a:tc>
+                  <a:txBody>
+                    <a:bodyPr/>
+                    <a:lstStyle/>
+                    <a:p>
+                      <a:pPr algn="r">
+                        <a:defRPr sz="1300">
+                          <a:solidFill>
+                            <a:srgbClr val="202428"/>
+                          </a:solidFill>
+                        </a:defRPr>
+                      </a:pPr>
+                      <a:r>
+                        <a:t>0.0816</a:t>
+                      </a:r>
+                    </a:p>
+                  </a:txBody>
+                  <a:tcPr marL="45720" marR="45720" marT="9144" marB="9144">
+                    <a:solidFill>
+                      <a:srgbClr val="FFFFFF"/>
+                    </a:solidFill>
+                  </a:tcPr>
+                </a:tc>
+              </a:tr>
+              <a:tr h="384048">
+                <a:tc>
+                  <a:txBody>
+                    <a:bodyPr/>
+                    <a:lstStyle/>
+                    <a:p>
+                      <a:pPr algn="l">
+                        <a:defRPr sz="1300">
+                          <a:solidFill>
+                            <a:srgbClr val="202428"/>
+                          </a:solidFill>
+                        </a:defRPr>
+                      </a:pPr>
+                      <a:r>
+                        <a:t>All-18 run (state C), g trained on 17 devices, combined</a:t>
+                      </a:r>
+                    </a:p>
+                  </a:txBody>
+                  <a:tcPr marL="45720" marR="45720" marT="9144" marB="9144">
+                    <a:solidFill>
+                      <a:srgbClr val="FFFFFF"/>
+                    </a:solidFill>
+                  </a:tcPr>
+                </a:tc>
+                <a:tc>
+                  <a:txBody>
+                    <a:bodyPr/>
+                    <a:lstStyle/>
+                    <a:p>
+                      <a:pPr algn="r">
+                        <a:defRPr sz="1300">
+                          <a:solidFill>
+                            <a:srgbClr val="202428"/>
+                          </a:solidFill>
+                        </a:defRPr>
+                      </a:pPr>
+                      <a:r>
+                        <a:t>0.2608</a:t>
+                      </a:r>
+                    </a:p>
+                  </a:txBody>
+                  <a:tcPr marL="45720" marR="45720" marT="9144" marB="9144">
+                    <a:solidFill>
+                      <a:srgbClr val="FFFFFF"/>
+                    </a:solidFill>
+                  </a:tcPr>
+                </a:tc>
+                <a:tc>
+                  <a:txBody>
+                    <a:bodyPr/>
+                    <a:lstStyle/>
+                    <a:p>
+                      <a:pPr algn="r">
+                        <a:defRPr sz="1300">
+                          <a:solidFill>
+                            <a:srgbClr val="202428"/>
+                          </a:solidFill>
+                        </a:defRPr>
+                      </a:pPr>
+                      <a:r>
+                        <a:t>0.0988</a:t>
+                      </a:r>
+                    </a:p>
+                  </a:txBody>
+                  <a:tcPr marL="45720" marR="45720" marT="9144" marB="9144">
+                    <a:solidFill>
+                      <a:srgbClr val="FFFFFF"/>
+                    </a:solidFill>
+                  </a:tcPr>
+                </a:tc>
+                <a:tc>
+                  <a:txBody>
+                    <a:bodyPr/>
+                    <a:lstStyle/>
+                    <a:p>
+                      <a:pPr algn="r">
+                        <a:defRPr sz="1300">
+                          <a:solidFill>
+                            <a:srgbClr val="202428"/>
+                          </a:solidFill>
+                        </a:defRPr>
+                      </a:pPr>
+                      <a:r>
+                        <a:t>0.0776</a:t>
+                      </a:r>
+                    </a:p>
+                  </a:txBody>
+                  <a:tcPr marL="45720" marR="45720" marT="9144" marB="9144">
+                    <a:solidFill>
+                      <a:srgbClr val="FFFFFF"/>
+                    </a:solidFill>
+                  </a:tcPr>
+                </a:tc>
+                <a:tc>
+                  <a:txBody>
+                    <a:bodyPr/>
+                    <a:lstStyle/>
+                    <a:p>
+                      <a:pPr algn="r">
+                        <a:defRPr sz="1300">
+                          <a:solidFill>
+                            <a:srgbClr val="202428"/>
+                          </a:solidFill>
+                        </a:defRPr>
+                      </a:pPr>
+                      <a:r>
+                        <a:t>0.0759</a:t>
+                      </a:r>
+                    </a:p>
+                  </a:txBody>
+                  <a:tcPr marL="45720" marR="45720" marT="9144" marB="9144">
+                    <a:solidFill>
+                      <a:srgbClr val="FFFFFF"/>
+                    </a:solidFill>
+                  </a:tcPr>
+                </a:tc>
+              </a:tr>
+            </a:tbl>
+          </a:graphicData>
+        </a:graphic>
+      </p:graphicFrame>
+      <p:sp>
+        <p:nvSpPr>
+          <p:cNvPr id="4" name="TextBox 3"/>
+          <p:cNvSpPr txBox="1"/>
+          <p:nvPr/>
+        </p:nvSpPr>
         <p:spPr>
           <a:xfrm>
-            <a:off x="365760" y="868680"/>
-            <a:ext cx="11430000" cy="4408714"/>
+            <a:off x="548640" y="3291840"/>
+            <a:ext cx="11064240" cy="2286000"/>
           </a:xfrm>
           <a:prstGeom prst="rect">
             <a:avLst/>
           </a:prstGeom>
+          <a:noFill/>
         </p:spPr>
-      </p:pic>
+        <p:txBody>
+          <a:bodyPr wrap="square">
+            <a:spAutoFit/>
+          </a:bodyPr>
+          <a:lstStyle/>
+          <a:p>
+            <a:pPr>
+              <a:spcAft>
+                <a:spcPts val="400"/>
+              </a:spcAft>
+            </a:pPr>
+            <a:r>
+              <a:rPr sz="1500">
+                <a:solidFill>
+                  <a:srgbClr val="202428"/>
+                </a:solidFill>
+              </a:rPr>
+              <a:t>The I3-2 run was pre-registered on the 12 former DEV devices; the 6 TEST devices were not loaded then.</a:t>
+            </a:r>
+          </a:p>
+          <a:p>
+            <a:pPr>
+              <a:spcAft>
+                <a:spcPts val="400"/>
+              </a:spcAft>
+            </a:pPr>
+            <a:r>
+              <a:rPr sz="1500">
+                <a:solidFill>
+                  <a:srgbClr val="202428"/>
+                </a:solidFill>
+              </a:rPr>
+              <a:t>On 2026-10-21 the user opened the 6 TEST devices. The all-18 run uses the same recipe with 17 training devices per fold.</a:t>
+            </a:r>
+          </a:p>
+          <a:p>
+            <a:pPr>
+              <a:spcAft>
+                <a:spcPts val="400"/>
+              </a:spcAft>
+            </a:pPr>
+            <a:r>
+              <a:rPr sz="1500">
+                <a:solidFill>
+                  <a:srgbClr val="202428"/>
+                </a:solidFill>
+              </a:rPr>
+              <a:t>C0_refit does not depend on the training devices: on the 12 devices the two runs differ only through the BSIM4 clamp state (state L vs C, devices with a2 &gt; 1; max |difference| 7.3e-03).</a:t>
+            </a:r>
+          </a:p>
+        </p:txBody>
+      </p:sp>
     </p:spTree>
   </p:cSld>
   <p:clrMapOvr>
@@ -15478,6 +16406,81 @@
                   <a:srgbClr val="202428"/>
                 </a:solidFill>
               </a:rPr>
+              <a:t>Per-device RRMS, 18 devices (log scale)</a:t>
+            </a:r>
+          </a:p>
+        </p:txBody>
+      </p:sp>
+      <p:pic>
+        <p:nvPicPr>
+          <p:cNvPr id="3" name="Picture 2" descr="rrms_per_device.png"/>
+          <p:cNvPicPr>
+            <a:picLocks noChangeAspect="1"/>
+          </p:cNvPicPr>
+          <p:nvPr/>
+        </p:nvPicPr>
+        <p:blipFill>
+          <a:blip r:embed="rId2"/>
+          <a:stretch>
+            <a:fillRect/>
+          </a:stretch>
+        </p:blipFill>
+        <p:spPr>
+          <a:xfrm>
+            <a:off x="365760" y="868680"/>
+            <a:ext cx="11430000" cy="4408714"/>
+          </a:xfrm>
+          <a:prstGeom prst="rect">
+            <a:avLst/>
+          </a:prstGeom>
+        </p:spPr>
+      </p:pic>
+    </p:spTree>
+  </p:cSld>
+  <p:clrMapOvr>
+    <a:masterClrMapping/>
+  </p:clrMapOvr>
+</p:sld>
+</file>
+
+<file path=ppt/slides/slide24.xml><?xml version="1.0" encoding="utf-8"?>
+<p:sld xmlns:a="http://schemas.openxmlformats.org/drawingml/2006/main" xmlns:p="http://schemas.openxmlformats.org/presentationml/2006/main" xmlns:r="http://schemas.openxmlformats.org/officeDocument/2006/relationships">
+  <p:cSld>
+    <p:spTree>
+      <p:nvGrpSpPr>
+        <p:cNvPr id="1" name=""/>
+        <p:cNvGrpSpPr/>
+        <p:nvPr/>
+      </p:nvGrpSpPr>
+      <p:grpSpPr/>
+      <p:sp>
+        <p:nvSpPr>
+          <p:cNvPr id="2" name="TextBox 1"/>
+          <p:cNvSpPr txBox="1"/>
+          <p:nvPr/>
+        </p:nvSpPr>
+        <p:spPr>
+          <a:xfrm>
+            <a:off x="457200" y="228600"/>
+            <a:ext cx="11247120" cy="640080"/>
+          </a:xfrm>
+          <a:prstGeom prst="rect">
+            <a:avLst/>
+          </a:prstGeom>
+          <a:noFill/>
+        </p:spPr>
+        <p:txBody>
+          <a:bodyPr wrap="none">
+            <a:spAutoFit/>
+          </a:bodyPr>
+          <a:lstStyle/>
+          <a:p>
+            <a:r>
+              <a:rPr sz="2400" b="1">
+                <a:solidFill>
+                  <a:srgbClr val="202428"/>
+                </a:solidFill>
+              </a:rPr>
               <a:t>Deployment: g as a Verilog-A element in NGSpice</a:t>
             </a:r>
           </a:p>
@@ -15753,7 +16756,7 @@
                         </a:defRPr>
                       </a:pPr>
                       <a:r>
-                        <a:t>0.073171 (0.069117)</a:t>
+                        <a:t>0.073483 (0.069534)</a:t>
                       </a:r>
                     </a:p>
                   </a:txBody>
@@ -15776,7 +16779,7 @@
                         </a:defRPr>
                       </a:pPr>
                       <a:r>
-                        <a:t>0.073163 (0.069110)</a:t>
+                        <a:t>0.073476 (0.069528)</a:t>
                       </a:r>
                     </a:p>
                   </a:txBody>
@@ -15799,7 +16802,7 @@
                         </a:defRPr>
                       </a:pPr>
                       <a:r>
-                        <a:t>1.7e-05</a:t>
+                        <a:t>1.8e-05</a:t>
                       </a:r>
                     </a:p>
                   </a:txBody>
@@ -15824,7 +16827,7 @@
                         </a:defRPr>
                       </a:pPr>
                       <a:r>
-                        <a:t>I3-2 run, 12 fold models (F1c)</a:t>
+                        <a:t>I3-2 run, 12 fold models (F1c, state L)</a:t>
                       </a:r>
                     </a:p>
                   </a:txBody>
@@ -16007,7 +17010,7 @@
 </p:sld>
 </file>
 
-<file path=ppt/slides/slide24.xml><?xml version="1.0" encoding="utf-8"?>
+<file path=ppt/slides/slide25.xml><?xml version="1.0" encoding="utf-8"?>
 <p:sld xmlns:a="http://schemas.openxmlformats.org/drawingml/2006/main" xmlns:p="http://schemas.openxmlformats.org/presentationml/2006/main" xmlns:r="http://schemas.openxmlformats.org/officeDocument/2006/relationships">
   <p:cSld>
     <p:spTree>
@@ -16120,7 +17123,7 @@
 </p:sld>
 </file>
 
-<file path=ppt/slides/slide25.xml><?xml version="1.0" encoding="utf-8"?>
+<file path=ppt/slides/slide26.xml><?xml version="1.0" encoding="utf-8"?>
 <p:sld xmlns:a="http://schemas.openxmlformats.org/drawingml/2006/main" xmlns:p="http://schemas.openxmlformats.org/presentationml/2006/main" xmlns:r="http://schemas.openxmlformats.org/officeDocument/2006/relationships">
   <p:cSld>
     <p:spTree>
@@ -16233,7 +17236,7 @@
 </p:sld>
 </file>
 
-<file path=ppt/slides/slide26.xml><?xml version="1.0" encoding="utf-8"?>
+<file path=ppt/slides/slide27.xml><?xml version="1.0" encoding="utf-8"?>
 <p:sld xmlns:a="http://schemas.openxmlformats.org/drawingml/2006/main" xmlns:p="http://schemas.openxmlformats.org/presentationml/2006/main" xmlns:r="http://schemas.openxmlformats.org/officeDocument/2006/relationships">
   <p:cSld>
     <p:spTree>
@@ -16346,7 +17349,7 @@
 </p:sld>
 </file>
 
-<file path=ppt/slides/slide27.xml><?xml version="1.0" encoding="utf-8"?>
+<file path=ppt/slides/slide28.xml><?xml version="1.0" encoding="utf-8"?>
 <p:sld xmlns:a="http://schemas.openxmlformats.org/drawingml/2006/main" xmlns:p="http://schemas.openxmlformats.org/presentationml/2006/main" xmlns:r="http://schemas.openxmlformats.org/officeDocument/2006/relationships">
   <p:cSld>
     <p:spTree>
@@ -16459,119 +17462,6 @@
 </p:sld>
 </file>
 
-<file path=ppt/slides/slide28.xml><?xml version="1.0" encoding="utf-8"?>
-<p:sld xmlns:a="http://schemas.openxmlformats.org/drawingml/2006/main" xmlns:p="http://schemas.openxmlformats.org/presentationml/2006/main" xmlns:r="http://schemas.openxmlformats.org/officeDocument/2006/relationships">
-  <p:cSld>
-    <p:spTree>
-      <p:nvGrpSpPr>
-        <p:cNvPr id="1" name=""/>
-        <p:cNvGrpSpPr/>
-        <p:nvPr/>
-      </p:nvGrpSpPr>
-      <p:grpSpPr/>
-      <p:sp>
-        <p:nvSpPr>
-          <p:cNvPr id="2" name="TextBox 1"/>
-          <p:cNvSpPr txBox="1"/>
-          <p:nvPr/>
-        </p:nvSpPr>
-        <p:spPr>
-          <a:xfrm>
-            <a:off x="457200" y="228600"/>
-            <a:ext cx="11247120" cy="640080"/>
-          </a:xfrm>
-          <a:prstGeom prst="rect">
-            <a:avLst/>
-          </a:prstGeom>
-          <a:noFill/>
-        </p:spPr>
-        <p:txBody>
-          <a:bodyPr wrap="none">
-            <a:spAutoFit/>
-          </a:bodyPr>
-          <a:lstStyle/>
-          <a:p>
-            <a:r>
-              <a:rPr sz="2000" b="1">
-                <a:solidFill>
-                  <a:srgbClr val="202428"/>
-                </a:solidFill>
-              </a:rPr>
-              <a:t>nmos_L100_W100:  NMOS, L = 100 um, W = 100 um</a:t>
-            </a:r>
-          </a:p>
-        </p:txBody>
-      </p:sp>
-      <p:pic>
-        <p:nvPicPr>
-          <p:cNvPr id="3" name="Picture 2" descr="iv_nmos_L100_W100.png"/>
-          <p:cNvPicPr>
-            <a:picLocks noChangeAspect="1"/>
-          </p:cNvPicPr>
-          <p:nvPr/>
-        </p:nvPicPr>
-        <p:blipFill>
-          <a:blip r:embed="rId2"/>
-          <a:stretch>
-            <a:fillRect/>
-          </a:stretch>
-        </p:blipFill>
-        <p:spPr>
-          <a:xfrm>
-            <a:off x="365760" y="731520"/>
-            <a:ext cx="11430000" cy="3879272"/>
-          </a:xfrm>
-          <a:prstGeom prst="rect">
-            <a:avLst/>
-          </a:prstGeom>
-        </p:spPr>
-      </p:pic>
-      <p:sp>
-        <p:nvSpPr>
-          <p:cNvPr id="4" name="TextBox 3"/>
-          <p:cNvSpPr txBox="1"/>
-          <p:nvPr/>
-        </p:nvSpPr>
-        <p:spPr>
-          <a:xfrm>
-            <a:off x="548640" y="6172200"/>
-            <a:ext cx="11064240" cy="548640"/>
-          </a:xfrm>
-          <a:prstGeom prst="rect">
-            <a:avLst/>
-          </a:prstGeom>
-          <a:noFill/>
-        </p:spPr>
-        <p:txBody>
-          <a:bodyPr wrap="square">
-            <a:spAutoFit/>
-          </a:bodyPr>
-          <a:lstStyle/>
-          <a:p>
-            <a:pPr>
-              <a:spcAft>
-                <a:spcPts val="400"/>
-              </a:spcAft>
-            </a:pPr>
-            <a:r>
-              <a:rPr sz="1100">
-                <a:solidFill>
-                  <a:srgbClr val="202428"/>
-                </a:solidFill>
-              </a:rPr>
-              <a:t>Points: measured. Lines: NGSpice (ngspice-41). M_bias line: refit card with the fold Verilog-A g in the netlist (OSDI), g trained without this device. Faded: curves outside the frozen inclusion set (not scored). RRMS: strict paper metric for this device.</a:t>
-            </a:r>
-          </a:p>
-        </p:txBody>
-      </p:sp>
-    </p:spTree>
-  </p:cSld>
-  <p:clrMapOvr>
-    <a:masterClrMapping/>
-  </p:clrMapOvr>
-</p:sld>
-</file>
-
 <file path=ppt/slides/slide29.xml><?xml version="1.0" encoding="utf-8"?>
 <p:sld xmlns:a="http://schemas.openxmlformats.org/drawingml/2006/main" xmlns:p="http://schemas.openxmlformats.org/presentationml/2006/main" xmlns:r="http://schemas.openxmlformats.org/officeDocument/2006/relationships">
   <p:cSld>
@@ -16610,14 +17500,14 @@
                   <a:srgbClr val="202428"/>
                 </a:solidFill>
               </a:rPr>
-              <a:t>nmos_L1_W1p6:  NMOS, L = 1 um, W = 1.6 um  (former TEST device)</a:t>
+              <a:t>nmos_L100_W100:  NMOS, L = 100 um, W = 100 um</a:t>
             </a:r>
           </a:p>
         </p:txBody>
       </p:sp>
       <p:pic>
         <p:nvPicPr>
-          <p:cNvPr id="3" name="Picture 2" descr="iv_nmos_L1_W1p6.png"/>
+          <p:cNvPr id="3" name="Picture 2" descr="iv_nmos_L100_W100.png"/>
           <p:cNvPicPr>
             <a:picLocks noChangeAspect="1"/>
           </p:cNvPicPr>
@@ -17170,7 +18060,7 @@
                   <a:srgbClr val="202428"/>
                 </a:solidFill>
               </a:rPr>
-              <a:t>g fixed; 134-403 simulations</a:t>
+              <a:t>g fixed; 127-403 simulations</a:t>
             </a:r>
           </a:p>
         </p:txBody>
@@ -17453,7 +18343,7 @@
                   <a:srgbClr val="202428"/>
                 </a:solidFill>
               </a:rPr>
-              <a:t>Run time (all 18 folds, process pool): g training 330 s (95 seed tasks = 19 models x 5 seeds), held-out refits 191 s (54 refits = 3 arms x 18), total 526 s.</a:t>
+              <a:t>Run time (all 18 folds, process pool): g training 261 s (95 seed tasks = 19 models x 5 seeds), held-out refits 335 s (54 refits = 3 arms x 18), total 600 s.</a:t>
             </a:r>
           </a:p>
           <a:p>
@@ -17468,7 +18358,7 @@
                   <a:srgbClr val="202428"/>
                 </a:solidFill>
               </a:rPr>
-              <a:t>All-device RRMS, held-out: starting card 0.1044; C0_refit (g = 0) 0.1043; M_bias 0.0732.</a:t>
+              <a:t>All-device RRMS, held-out: starting card 0.1109; C0_refit (g = 0) 0.1051; M_bias 0.0735.</a:t>
             </a:r>
           </a:p>
         </p:txBody>
@@ -17482,6 +18372,119 @@
 </file>
 
 <file path=ppt/slides/slide30.xml><?xml version="1.0" encoding="utf-8"?>
+<p:sld xmlns:a="http://schemas.openxmlformats.org/drawingml/2006/main" xmlns:p="http://schemas.openxmlformats.org/presentationml/2006/main" xmlns:r="http://schemas.openxmlformats.org/officeDocument/2006/relationships">
+  <p:cSld>
+    <p:spTree>
+      <p:nvGrpSpPr>
+        <p:cNvPr id="1" name=""/>
+        <p:cNvGrpSpPr/>
+        <p:nvPr/>
+      </p:nvGrpSpPr>
+      <p:grpSpPr/>
+      <p:sp>
+        <p:nvSpPr>
+          <p:cNvPr id="2" name="TextBox 1"/>
+          <p:cNvSpPr txBox="1"/>
+          <p:nvPr/>
+        </p:nvSpPr>
+        <p:spPr>
+          <a:xfrm>
+            <a:off x="457200" y="228600"/>
+            <a:ext cx="11247120" cy="640080"/>
+          </a:xfrm>
+          <a:prstGeom prst="rect">
+            <a:avLst/>
+          </a:prstGeom>
+          <a:noFill/>
+        </p:spPr>
+        <p:txBody>
+          <a:bodyPr wrap="none">
+            <a:spAutoFit/>
+          </a:bodyPr>
+          <a:lstStyle/>
+          <a:p>
+            <a:r>
+              <a:rPr sz="2000" b="1">
+                <a:solidFill>
+                  <a:srgbClr val="202428"/>
+                </a:solidFill>
+              </a:rPr>
+              <a:t>nmos_L1_W1p6:  NMOS, L = 1 um, W = 1.6 um  (former TEST device)</a:t>
+            </a:r>
+          </a:p>
+        </p:txBody>
+      </p:sp>
+      <p:pic>
+        <p:nvPicPr>
+          <p:cNvPr id="3" name="Picture 2" descr="iv_nmos_L1_W1p6.png"/>
+          <p:cNvPicPr>
+            <a:picLocks noChangeAspect="1"/>
+          </p:cNvPicPr>
+          <p:nvPr/>
+        </p:nvPicPr>
+        <p:blipFill>
+          <a:blip r:embed="rId2"/>
+          <a:stretch>
+            <a:fillRect/>
+          </a:stretch>
+        </p:blipFill>
+        <p:spPr>
+          <a:xfrm>
+            <a:off x="365760" y="731520"/>
+            <a:ext cx="11430000" cy="3879272"/>
+          </a:xfrm>
+          <a:prstGeom prst="rect">
+            <a:avLst/>
+          </a:prstGeom>
+        </p:spPr>
+      </p:pic>
+      <p:sp>
+        <p:nvSpPr>
+          <p:cNvPr id="4" name="TextBox 3"/>
+          <p:cNvSpPr txBox="1"/>
+          <p:nvPr/>
+        </p:nvSpPr>
+        <p:spPr>
+          <a:xfrm>
+            <a:off x="548640" y="6172200"/>
+            <a:ext cx="11064240" cy="548640"/>
+          </a:xfrm>
+          <a:prstGeom prst="rect">
+            <a:avLst/>
+          </a:prstGeom>
+          <a:noFill/>
+        </p:spPr>
+        <p:txBody>
+          <a:bodyPr wrap="square">
+            <a:spAutoFit/>
+          </a:bodyPr>
+          <a:lstStyle/>
+          <a:p>
+            <a:pPr>
+              <a:spcAft>
+                <a:spcPts val="400"/>
+              </a:spcAft>
+            </a:pPr>
+            <a:r>
+              <a:rPr sz="1100">
+                <a:solidFill>
+                  <a:srgbClr val="202428"/>
+                </a:solidFill>
+              </a:rPr>
+              <a:t>Points: measured. Lines: NGSpice (ngspice-41). M_bias line: refit card with the fold Verilog-A g in the netlist (OSDI), g trained without this device. Faded: curves outside the frozen inclusion set (not scored). RRMS: strict paper metric for this device.</a:t>
+            </a:r>
+          </a:p>
+        </p:txBody>
+      </p:sp>
+    </p:spTree>
+  </p:cSld>
+  <p:clrMapOvr>
+    <a:masterClrMapping/>
+  </p:clrMapOvr>
+</p:sld>
+</file>
+
+<file path=ppt/slides/slide31.xml><?xml version="1.0" encoding="utf-8"?>
 <p:sld xmlns:a="http://schemas.openxmlformats.org/drawingml/2006/main" xmlns:p="http://schemas.openxmlformats.org/presentationml/2006/main" xmlns:r="http://schemas.openxmlformats.org/officeDocument/2006/relationships">
   <p:cSld>
     <p:spTree>
@@ -17594,7 +18597,7 @@
 </p:sld>
 </file>
 
-<file path=ppt/slides/slide31.xml><?xml version="1.0" encoding="utf-8"?>
+<file path=ppt/slides/slide32.xml><?xml version="1.0" encoding="utf-8"?>
 <p:sld xmlns:a="http://schemas.openxmlformats.org/drawingml/2006/main" xmlns:p="http://schemas.openxmlformats.org/presentationml/2006/main" xmlns:r="http://schemas.openxmlformats.org/officeDocument/2006/relationships">
   <p:cSld>
     <p:spTree>
@@ -17707,7 +18710,7 @@
 </p:sld>
 </file>
 
-<file path=ppt/slides/slide32.xml><?xml version="1.0" encoding="utf-8"?>
+<file path=ppt/slides/slide33.xml><?xml version="1.0" encoding="utf-8"?>
 <p:sld xmlns:a="http://schemas.openxmlformats.org/drawingml/2006/main" xmlns:p="http://schemas.openxmlformats.org/presentationml/2006/main" xmlns:r="http://schemas.openxmlformats.org/officeDocument/2006/relationships">
   <p:cSld>
     <p:spTree>
@@ -17820,7 +18823,7 @@
 </p:sld>
 </file>
 
-<file path=ppt/slides/slide33.xml><?xml version="1.0" encoding="utf-8"?>
+<file path=ppt/slides/slide34.xml><?xml version="1.0" encoding="utf-8"?>
 <p:sld xmlns:a="http://schemas.openxmlformats.org/drawingml/2006/main" xmlns:p="http://schemas.openxmlformats.org/presentationml/2006/main" xmlns:r="http://schemas.openxmlformats.org/officeDocument/2006/relationships">
   <p:cSld>
     <p:spTree>
@@ -17933,7 +18936,7 @@
 </p:sld>
 </file>
 
-<file path=ppt/slides/slide34.xml><?xml version="1.0" encoding="utf-8"?>
+<file path=ppt/slides/slide35.xml><?xml version="1.0" encoding="utf-8"?>
 <p:sld xmlns:a="http://schemas.openxmlformats.org/drawingml/2006/main" xmlns:p="http://schemas.openxmlformats.org/presentationml/2006/main" xmlns:r="http://schemas.openxmlformats.org/officeDocument/2006/relationships">
   <p:cSld>
     <p:spTree>
@@ -18046,7 +19049,7 @@
 </p:sld>
 </file>
 
-<file path=ppt/slides/slide35.xml><?xml version="1.0" encoding="utf-8"?>
+<file path=ppt/slides/slide36.xml><?xml version="1.0" encoding="utf-8"?>
 <p:sld xmlns:a="http://schemas.openxmlformats.org/drawingml/2006/main" xmlns:p="http://schemas.openxmlformats.org/presentationml/2006/main" xmlns:r="http://schemas.openxmlformats.org/officeDocument/2006/relationships">
   <p:cSld>
     <p:spTree>
@@ -18159,7 +19162,7 @@
 </p:sld>
 </file>
 
-<file path=ppt/slides/slide36.xml><?xml version="1.0" encoding="utf-8"?>
+<file path=ppt/slides/slide37.xml><?xml version="1.0" encoding="utf-8"?>
 <p:sld xmlns:a="http://schemas.openxmlformats.org/drawingml/2006/main" xmlns:p="http://schemas.openxmlformats.org/presentationml/2006/main" xmlns:r="http://schemas.openxmlformats.org/officeDocument/2006/relationships">
   <p:cSld>
     <p:spTree>
@@ -18272,7 +19275,7 @@
 </p:sld>
 </file>
 
-<file path=ppt/slides/slide37.xml><?xml version="1.0" encoding="utf-8"?>
+<file path=ppt/slides/slide38.xml><?xml version="1.0" encoding="utf-8"?>
 <p:sld xmlns:a="http://schemas.openxmlformats.org/drawingml/2006/main" xmlns:p="http://schemas.openxmlformats.org/presentationml/2006/main" xmlns:r="http://schemas.openxmlformats.org/officeDocument/2006/relationships">
   <p:cSld>
     <p:spTree>
@@ -18385,119 +19388,6 @@
 </p:sld>
 </file>
 
-<file path=ppt/slides/slide38.xml><?xml version="1.0" encoding="utf-8"?>
-<p:sld xmlns:a="http://schemas.openxmlformats.org/drawingml/2006/main" xmlns:p="http://schemas.openxmlformats.org/presentationml/2006/main" xmlns:r="http://schemas.openxmlformats.org/officeDocument/2006/relationships">
-  <p:cSld>
-    <p:spTree>
-      <p:nvGrpSpPr>
-        <p:cNvPr id="1" name=""/>
-        <p:cNvGrpSpPr/>
-        <p:nvPr/>
-      </p:nvGrpSpPr>
-      <p:grpSpPr/>
-      <p:sp>
-        <p:nvSpPr>
-          <p:cNvPr id="2" name="TextBox 1"/>
-          <p:cNvSpPr txBox="1"/>
-          <p:nvPr/>
-        </p:nvSpPr>
-        <p:spPr>
-          <a:xfrm>
-            <a:off x="457200" y="228600"/>
-            <a:ext cx="11247120" cy="640080"/>
-          </a:xfrm>
-          <a:prstGeom prst="rect">
-            <a:avLst/>
-          </a:prstGeom>
-          <a:noFill/>
-        </p:spPr>
-        <p:txBody>
-          <a:bodyPr wrap="none">
-            <a:spAutoFit/>
-          </a:bodyPr>
-          <a:lstStyle/>
-          <a:p>
-            <a:r>
-              <a:rPr sz="2000" b="1">
-                <a:solidFill>
-                  <a:srgbClr val="202428"/>
-                </a:solidFill>
-              </a:rPr>
-              <a:t>pmos_L2_W5:  PMOS, L = 2 um, W = 5 um</a:t>
-            </a:r>
-          </a:p>
-        </p:txBody>
-      </p:sp>
-      <p:pic>
-        <p:nvPicPr>
-          <p:cNvPr id="3" name="Picture 2" descr="iv_pmos_L2_W5.png"/>
-          <p:cNvPicPr>
-            <a:picLocks noChangeAspect="1"/>
-          </p:cNvPicPr>
-          <p:nvPr/>
-        </p:nvPicPr>
-        <p:blipFill>
-          <a:blip r:embed="rId2"/>
-          <a:stretch>
-            <a:fillRect/>
-          </a:stretch>
-        </p:blipFill>
-        <p:spPr>
-          <a:xfrm>
-            <a:off x="365760" y="731520"/>
-            <a:ext cx="11430000" cy="3879272"/>
-          </a:xfrm>
-          <a:prstGeom prst="rect">
-            <a:avLst/>
-          </a:prstGeom>
-        </p:spPr>
-      </p:pic>
-      <p:sp>
-        <p:nvSpPr>
-          <p:cNvPr id="4" name="TextBox 3"/>
-          <p:cNvSpPr txBox="1"/>
-          <p:nvPr/>
-        </p:nvSpPr>
-        <p:spPr>
-          <a:xfrm>
-            <a:off x="548640" y="6172200"/>
-            <a:ext cx="11064240" cy="548640"/>
-          </a:xfrm>
-          <a:prstGeom prst="rect">
-            <a:avLst/>
-          </a:prstGeom>
-          <a:noFill/>
-        </p:spPr>
-        <p:txBody>
-          <a:bodyPr wrap="square">
-            <a:spAutoFit/>
-          </a:bodyPr>
-          <a:lstStyle/>
-          <a:p>
-            <a:pPr>
-              <a:spcAft>
-                <a:spcPts val="400"/>
-              </a:spcAft>
-            </a:pPr>
-            <a:r>
-              <a:rPr sz="1100">
-                <a:solidFill>
-                  <a:srgbClr val="202428"/>
-                </a:solidFill>
-              </a:rPr>
-              <a:t>Points: measured. Lines: NGSpice (ngspice-41). M_bias line: refit card with the fold Verilog-A g in the netlist (OSDI), g trained without this device. Faded: curves outside the frozen inclusion set (not scored). RRMS: strict paper metric for this device.</a:t>
-            </a:r>
-          </a:p>
-        </p:txBody>
-      </p:sp>
-    </p:spTree>
-  </p:cSld>
-  <p:clrMapOvr>
-    <a:masterClrMapping/>
-  </p:clrMapOvr>
-</p:sld>
-</file>
-
 <file path=ppt/slides/slide39.xml><?xml version="1.0" encoding="utf-8"?>
 <p:sld xmlns:a="http://schemas.openxmlformats.org/drawingml/2006/main" xmlns:p="http://schemas.openxmlformats.org/presentationml/2006/main" xmlns:r="http://schemas.openxmlformats.org/officeDocument/2006/relationships">
   <p:cSld>
@@ -18536,14 +19426,14 @@
                   <a:srgbClr val="202428"/>
                 </a:solidFill>
               </a:rPr>
-              <a:t>pmos_L4_W7:  PMOS, L = 4 um, W = 7 um</a:t>
+              <a:t>pmos_L2_W5:  PMOS, L = 2 um, W = 5 um</a:t>
             </a:r>
           </a:p>
         </p:txBody>
       </p:sp>
       <p:pic>
         <p:nvPicPr>
-          <p:cNvPr id="3" name="Picture 2" descr="iv_pmos_L4_W7.png"/>
+          <p:cNvPr id="3" name="Picture 2" descr="iv_pmos_L2_W5.png"/>
           <p:cNvPicPr>
             <a:picLocks noChangeAspect="1"/>
           </p:cNvPicPr>
@@ -18878,6 +19768,119 @@
                   <a:srgbClr val="202428"/>
                 </a:solidFill>
               </a:rPr>
+              <a:t>pmos_L4_W7:  PMOS, L = 4 um, W = 7 um</a:t>
+            </a:r>
+          </a:p>
+        </p:txBody>
+      </p:sp>
+      <p:pic>
+        <p:nvPicPr>
+          <p:cNvPr id="3" name="Picture 2" descr="iv_pmos_L4_W7.png"/>
+          <p:cNvPicPr>
+            <a:picLocks noChangeAspect="1"/>
+          </p:cNvPicPr>
+          <p:nvPr/>
+        </p:nvPicPr>
+        <p:blipFill>
+          <a:blip r:embed="rId2"/>
+          <a:stretch>
+            <a:fillRect/>
+          </a:stretch>
+        </p:blipFill>
+        <p:spPr>
+          <a:xfrm>
+            <a:off x="365760" y="731520"/>
+            <a:ext cx="11430000" cy="3879272"/>
+          </a:xfrm>
+          <a:prstGeom prst="rect">
+            <a:avLst/>
+          </a:prstGeom>
+        </p:spPr>
+      </p:pic>
+      <p:sp>
+        <p:nvSpPr>
+          <p:cNvPr id="4" name="TextBox 3"/>
+          <p:cNvSpPr txBox="1"/>
+          <p:nvPr/>
+        </p:nvSpPr>
+        <p:spPr>
+          <a:xfrm>
+            <a:off x="548640" y="6172200"/>
+            <a:ext cx="11064240" cy="548640"/>
+          </a:xfrm>
+          <a:prstGeom prst="rect">
+            <a:avLst/>
+          </a:prstGeom>
+          <a:noFill/>
+        </p:spPr>
+        <p:txBody>
+          <a:bodyPr wrap="square">
+            <a:spAutoFit/>
+          </a:bodyPr>
+          <a:lstStyle/>
+          <a:p>
+            <a:pPr>
+              <a:spcAft>
+                <a:spcPts val="400"/>
+              </a:spcAft>
+            </a:pPr>
+            <a:r>
+              <a:rPr sz="1100">
+                <a:solidFill>
+                  <a:srgbClr val="202428"/>
+                </a:solidFill>
+              </a:rPr>
+              <a:t>Points: measured. Lines: NGSpice (ngspice-41). M_bias line: refit card with the fold Verilog-A g in the netlist (OSDI), g trained without this device. Faded: curves outside the frozen inclusion set (not scored). RRMS: strict paper metric for this device.</a:t>
+            </a:r>
+          </a:p>
+        </p:txBody>
+      </p:sp>
+    </p:spTree>
+  </p:cSld>
+  <p:clrMapOvr>
+    <a:masterClrMapping/>
+  </p:clrMapOvr>
+</p:sld>
+</file>
+
+<file path=ppt/slides/slide41.xml><?xml version="1.0" encoding="utf-8"?>
+<p:sld xmlns:a="http://schemas.openxmlformats.org/drawingml/2006/main" xmlns:p="http://schemas.openxmlformats.org/presentationml/2006/main" xmlns:r="http://schemas.openxmlformats.org/officeDocument/2006/relationships">
+  <p:cSld>
+    <p:spTree>
+      <p:nvGrpSpPr>
+        <p:cNvPr id="1" name=""/>
+        <p:cNvGrpSpPr/>
+        <p:nvPr/>
+      </p:nvGrpSpPr>
+      <p:grpSpPr/>
+      <p:sp>
+        <p:nvSpPr>
+          <p:cNvPr id="2" name="TextBox 1"/>
+          <p:cNvSpPr txBox="1"/>
+          <p:nvPr/>
+        </p:nvSpPr>
+        <p:spPr>
+          <a:xfrm>
+            <a:off x="457200" y="228600"/>
+            <a:ext cx="11247120" cy="640080"/>
+          </a:xfrm>
+          <a:prstGeom prst="rect">
+            <a:avLst/>
+          </a:prstGeom>
+          <a:noFill/>
+        </p:spPr>
+        <p:txBody>
+          <a:bodyPr wrap="none">
+            <a:spAutoFit/>
+          </a:bodyPr>
+          <a:lstStyle/>
+          <a:p>
+            <a:r>
+              <a:rPr sz="2000" b="1">
+                <a:solidFill>
+                  <a:srgbClr val="202428"/>
+                </a:solidFill>
+              </a:rPr>
               <a:t>pmos_L8_W0p84:  PMOS, L = 8 um, W = 0.84 um  (former TEST device)</a:t>
             </a:r>
           </a:p>
@@ -18953,7 +19956,7 @@
 </p:sld>
 </file>
 
-<file path=ppt/slides/slide41.xml><?xml version="1.0" encoding="utf-8"?>
+<file path=ppt/slides/slide42.xml><?xml version="1.0" encoding="utf-8"?>
 <p:sld xmlns:a="http://schemas.openxmlformats.org/drawingml/2006/main" xmlns:p="http://schemas.openxmlformats.org/presentationml/2006/main" xmlns:r="http://schemas.openxmlformats.org/officeDocument/2006/relationships">
   <p:cSld>
     <p:spTree>
@@ -19066,7 +20069,7 @@
 </p:sld>
 </file>
 
-<file path=ppt/slides/slide42.xml><?xml version="1.0" encoding="utf-8"?>
+<file path=ppt/slides/slide43.xml><?xml version="1.0" encoding="utf-8"?>
 <p:sld xmlns:a="http://schemas.openxmlformats.org/drawingml/2006/main" xmlns:p="http://schemas.openxmlformats.org/presentationml/2006/main" xmlns:r="http://schemas.openxmlformats.org/officeDocument/2006/relationships">
   <p:cSld>
     <p:spTree>
@@ -21148,7 +22151,7 @@
                         </a:defRPr>
                       </a:pPr>
                       <a:r>
-                        <a:t>0.1044</a:t>
+                        <a:t>0.1109</a:t>
                       </a:r>
                     </a:p>
                   </a:txBody>
@@ -21384,7 +22387,7 @@
                   <a:srgbClr val="202428"/>
                 </a:solidFill>
               </a:rPr>
-              <a:t>Starting card = round 3 + FD: all-device 0.1044, combined 0.0976. Sum over the five stages: 47,502 NGSpice simulations per device.</a:t>
+              <a:t>Starting card = round 3 + FD: all-device 0.1109, combined 0.1049. Sum over the five stages: 47,502 NGSpice simulations per device.</a:t>
             </a:r>
           </a:p>
           <a:p>
@@ -21542,7 +22545,7 @@
                   <a:srgbClr val="202428"/>
                 </a:solidFill>
               </a:rPr>
-              <a:t>Median |ln(I_meas / I_card)|: nMOS 0.016, pMOS 0.065 (points with |I| &lt; 1e-13 A left out of the colour plot only).</a:t>
+              <a:t>Median |ln(I_meas / I_card)|: nMOS 0.029, pMOS 0.065 (points with |I| &lt; 1e-13 A left out of the colour plot only).</a:t>
             </a:r>
           </a:p>
         </p:txBody>

</xml_diff>

<commit_message>
M_bias deck: training-trace slide uses the stored model's trainer (i3_2_bias.fit_bias with a per-step trace callback, training records in load order) instead of its own loop over tag-sorted records; the re-run reproduces the stored state-C fold model of pmos_L2_W5 (max |g - stored g| 0, max |weight difference| 0; was 1.8e-3); deck regenerated (43 slides)
Co-Authored-By: Claude Opus 5.5 <noreply@anthropic.com>
Claude-Session: https://claude.ai/code/session_01FTjyogfhfbXwhjQosGAjKp
</commit_message>
<xml_diff>
--- a/slides/cryo_ml_mbias_real_data.pptx
+++ b/slides/cryo_ml_mbias_real_data.pptx
@@ -3678,7 +3678,7 @@
                   <a:srgbClr val="202428"/>
                 </a:solidFill>
               </a:rPr>
-              <a:t>Fold pmos_L2_W5 (23,955 points): RRMS term 0.1127 at g = 0; 0.0778-0.0798 per seed; 0.0786 for the 5-seed mean g.</a:t>
+              <a:t>Fold pmos_L2_W5 (23,955 points): RRMS term 0.1127 at g = 0; 0.0782-0.0796 per seed; 0.0787 for the 5-seed mean g.</a:t>
             </a:r>
           </a:p>
           <a:p>
@@ -3693,7 +3693,7 @@
                   <a:srgbClr val="202428"/>
                 </a:solidFill>
               </a:rPr>
-              <a:t>Std of g across seeds at the training points: median 0.0051, max 0.156.</a:t>
+              <a:t>Std of g across seeds at the training points: median 0.0055, max 0.158.</a:t>
             </a:r>
           </a:p>
           <a:p>
@@ -3708,7 +3708,7 @@
                   <a:srgbClr val="202428"/>
                 </a:solidFill>
               </a:rPr>
-              <a:t>This trace is a re-run (69 s); max |g - stored fold g| = 1.8e-03.</a:t>
+              <a:t>Trace: re-run of the stored fold model's trainer (fit_bias, training records in load order, 72 s); max |g - stored fold g| = 0, max |weight difference| = 0.</a:t>
             </a:r>
           </a:p>
         </p:txBody>

</xml_diff>

<commit_message>
M_bias deck: two slides after the deployment slide: g v2 definition (symmetric inputs, smooth abs EPS 0.01 V, gm/gds penalty, channel-only replica element, nested lambda selection with lambda* counts) with the 18-device held-out table (published, C0_refit, v1, g v2 lambda 10 V, selected rows, selected element deck; GMR vs v1), and the I16-1 deployment checks table (selected vs I15-1 g v2 and v1; outcome not deployable, failed Vds = 0 point, gds restriction devices); deck regenerated (45 slides)
Co-Authored-By: Claude Opus 5.5 <noreply@anthropic.com>
Claude-Session: https://claude.ai/code/session_01FTjyogfhfbXwhjQosGAjKp
</commit_message>
<xml_diff>
--- a/slides/cryo_ml_mbias_real_data.pptx
+++ b/slides/cryo_ml_mbias_real_data.pptx
@@ -48,6 +48,8 @@
     <p:sldId id="296" r:id="rId47"/>
     <p:sldId id="297" r:id="rId48"/>
     <p:sldId id="298" r:id="rId49"/>
+    <p:sldId id="299" r:id="rId50"/>
+    <p:sldId id="300" r:id="rId51"/>
   </p:sldIdLst>
   <p:sldSz cx="12191695" cy="6858000" type="screen4x3"/>
   <p:notesSz cx="6858000" cy="9144000"/>
@@ -17048,6 +17050,3103 @@
                   <a:srgbClr val="202428"/>
                 </a:solidFill>
               </a:rPr>
+              <a:t>g v2: symmetric inputs and a penalty weight selected on training devices</a:t>
+            </a:r>
+          </a:p>
+        </p:txBody>
+      </p:sp>
+      <p:sp>
+        <p:nvSpPr>
+          <p:cNvPr id="3" name="TextBox 2"/>
+          <p:cNvSpPr txBox="1"/>
+          <p:nvPr/>
+        </p:nvSpPr>
+        <p:spPr>
+          <a:xfrm>
+            <a:off x="548640" y="777240"/>
+            <a:ext cx="11064240" cy="3063240"/>
+          </a:xfrm>
+          <a:prstGeom prst="rect">
+            <a:avLst/>
+          </a:prstGeom>
+          <a:noFill/>
+        </p:spPr>
+        <p:txBody>
+          <a:bodyPr wrap="square">
+            <a:spAutoFit/>
+          </a:bodyPr>
+          <a:lstStyle/>
+          <a:p>
+            <a:pPr>
+              <a:spcAft>
+                <a:spcPts val="400"/>
+              </a:spcAft>
+            </a:pPr>
+            <a:r>
+              <a:rPr sz="1250">
+                <a:solidFill>
+                  <a:srgbClr val="202428"/>
+                </a:solidFill>
+              </a:rPr>
+              <a:t>Inputs (d/s symmetric): x1 = (s V(g,s) + s V(g,d) + m) / (2 VDD), x2 = m / VDD, m = sqrt(V(d,s)^2 + EPS^2), EPS = 0.01 V, s = +1 (nMOS) / -1 (pMOS), VDD = 1.8 V. Exchanging d and s leaves x1 and x2 unchanged. On forward-bias training data x1 = |V(g,s)| / VDD and x2 = |V(d,s)| / VDD (the v1 inputs) for EPS = 0.</a:t>
+            </a:r>
+          </a:p>
+          <a:p>
+            <a:pPr>
+              <a:spcAft>
+                <a:spcPts val="400"/>
+              </a:spcAft>
+            </a:pPr>
+            <a:r>
+              <a:rPr sz="1250">
+                <a:solidFill>
+                  <a:srgbClr val="202428"/>
+                </a:solidFill>
+              </a:rPr>
+              <a:t>Training: v1 loss + lambda x P. P = mean over training cards and 25 mV forward-grid points of relu(-(gm/I + dg/dV(g,s))) + relu(-(gds/I + dg/dV(d,s))), the negative part of the corrected gm and gds.</a:t>
+            </a:r>
+          </a:p>
+          <a:p>
+            <a:pPr>
+              <a:spcAft>
+                <a:spcPts val="400"/>
+              </a:spcAft>
+            </a:pPr>
+            <a:r>
+              <a:rPr sz="1250">
+                <a:solidFill>
+                  <a:srgbClr val="202428"/>
+                </a:solidFill>
+              </a:rPr>
+              <a:t>Element: I(d, s) &lt;+ (exp(g) - 1) I_rep. I_rep is the drain current of a replica BSIM4 instance (same card, no charge, no substrate, GIDL, gate or junction current), sensed by a 0 V source; a -gmin VCCS removes the replica junction gmin current.</a:t>
+            </a:r>
+          </a:p>
+          <a:p>
+            <a:pPr>
+              <a:spcAft>
+                <a:spcPts val="400"/>
+              </a:spcAft>
+            </a:pPr>
+            <a:r>
+              <a:rPr sz="1250">
+                <a:solidFill>
+                  <a:srgbClr val="202428"/>
+                </a:solidFill>
+              </a:rPr>
+              <a:t>lambda selection, training devices only: per held-out device, 3 inner folds of the 17 training devices, lambda in {0, 1, 2, 5, 10} V, lambda* = argmin mean ln RRMS of the inner held-out refits. lambda* = 1 V on 10, 2 V on 6, 0 V on 1, 10 V on 1 of 18 folds; full-data model (deployed) lambda* = 1 V.</a:t>
+            </a:r>
+          </a:p>
+        </p:txBody>
+      </p:sp>
+      <p:graphicFrame>
+        <p:nvGraphicFramePr>
+          <p:cNvPr id="4" name="Table 3"/>
+          <p:cNvGraphicFramePr>
+            <a:graphicFrameLocks noGrp="1"/>
+          </p:cNvGraphicFramePr>
+          <p:nvPr/>
+        </p:nvGraphicFramePr>
+        <p:xfrm>
+          <a:off x="548640" y="3886200"/>
+          <a:ext cx="10287000" cy="2112264"/>
+        </p:xfrm>
+        <a:graphic>
+          <a:graphicData uri="http://schemas.openxmlformats.org/drawingml/2006/table">
+            <a:tbl>
+              <a:tblPr firstRow="1" bandRow="1">
+                <a:tableStyleId>{5C22544A-7EE6-4342-B048-85BDC9FD1C3A}</a:tableStyleId>
+              </a:tblPr>
+              <a:tblGrid>
+                <a:gridCol w="3566160"/>
+                <a:gridCol w="1051560"/>
+                <a:gridCol w="1051560"/>
+                <a:gridCol w="1051560"/>
+                <a:gridCol w="2377440"/>
+                <a:gridCol w="1188720"/>
+              </a:tblGrid>
+              <a:tr h="301752">
+                <a:tc>
+                  <a:txBody>
+                    <a:bodyPr/>
+                    <a:lstStyle/>
+                    <a:p>
+                      <a:pPr algn="l">
+                        <a:defRPr sz="1150" b="1">
+                          <a:solidFill>
+                            <a:srgbClr val="202428"/>
+                          </a:solidFill>
+                        </a:defRPr>
+                      </a:pPr>
+                      <a:r>
+                        <a:t>Arm (18 devices, held-out)</a:t>
+                      </a:r>
+                    </a:p>
+                  </a:txBody>
+                  <a:tcPr marL="45720" marR="45720" marT="9144" marB="9144">
+                    <a:solidFill>
+                      <a:srgbClr val="E8ECF0"/>
+                    </a:solidFill>
+                  </a:tcPr>
+                </a:tc>
+                <a:tc>
+                  <a:txBody>
+                    <a:bodyPr/>
+                    <a:lstStyle/>
+                    <a:p>
+                      <a:pPr algn="l">
+                        <a:defRPr sz="1150" b="1">
+                          <a:solidFill>
+                            <a:srgbClr val="202428"/>
+                          </a:solidFill>
+                        </a:defRPr>
+                      </a:pPr>
+                      <a:r>
+                        <a:t>All-device</a:t>
+                      </a:r>
+                    </a:p>
+                  </a:txBody>
+                  <a:tcPr marL="45720" marR="45720" marT="9144" marB="9144">
+                    <a:solidFill>
+                      <a:srgbClr val="E8ECF0"/>
+                    </a:solidFill>
+                  </a:tcPr>
+                </a:tc>
+                <a:tc>
+                  <a:txBody>
+                    <a:bodyPr/>
+                    <a:lstStyle/>
+                    <a:p>
+                      <a:pPr algn="l">
+                        <a:defRPr sz="1150" b="1">
+                          <a:solidFill>
+                            <a:srgbClr val="202428"/>
+                          </a:solidFill>
+                        </a:defRPr>
+                      </a:pPr>
+                      <a:r>
+                        <a:t>Combined</a:t>
+                      </a:r>
+                    </a:p>
+                  </a:txBody>
+                  <a:tcPr marL="45720" marR="45720" marT="9144" marB="9144">
+                    <a:solidFill>
+                      <a:srgbClr val="E8ECF0"/>
+                    </a:solidFill>
+                  </a:tcPr>
+                </a:tc>
+                <a:tc>
+                  <a:txBody>
+                    <a:bodyPr/>
+                    <a:lstStyle/>
+                    <a:p>
+                      <a:pPr algn="l">
+                        <a:defRPr sz="1150" b="1">
+                          <a:solidFill>
+                            <a:srgbClr val="202428"/>
+                          </a:solidFill>
+                        </a:defRPr>
+                      </a:pPr>
+                      <a:r>
+                        <a:t>Median</a:t>
+                      </a:r>
+                    </a:p>
+                  </a:txBody>
+                  <a:tcPr marL="45720" marR="45720" marT="9144" marB="9144">
+                    <a:solidFill>
+                      <a:srgbClr val="E8ECF0"/>
+                    </a:solidFill>
+                  </a:tcPr>
+                </a:tc>
+                <a:tc>
+                  <a:txBody>
+                    <a:bodyPr/>
+                    <a:lstStyle/>
+                    <a:p>
+                      <a:pPr algn="l">
+                        <a:defRPr sz="1150" b="1">
+                          <a:solidFill>
+                            <a:srgbClr val="202428"/>
+                          </a:solidFill>
+                        </a:defRPr>
+                      </a:pPr>
+                      <a:r>
+                        <a:t>GMR vs M_bias v1 [95% CI]</a:t>
+                      </a:r>
+                    </a:p>
+                  </a:txBody>
+                  <a:tcPr marL="45720" marR="45720" marT="9144" marB="9144">
+                    <a:solidFill>
+                      <a:srgbClr val="E8ECF0"/>
+                    </a:solidFill>
+                  </a:tcPr>
+                </a:tc>
+                <a:tc>
+                  <a:txBody>
+                    <a:bodyPr/>
+                    <a:lstStyle/>
+                    <a:p>
+                      <a:pPr algn="l">
+                        <a:defRPr sz="1150" b="1">
+                          <a:solidFill>
+                            <a:srgbClr val="202428"/>
+                          </a:solidFill>
+                        </a:defRPr>
+                      </a:pPr>
+                      <a:r>
+                        <a:t>Lower than v1</a:t>
+                      </a:r>
+                    </a:p>
+                  </a:txBody>
+                  <a:tcPr marL="45720" marR="45720" marT="9144" marB="9144">
+                    <a:solidFill>
+                      <a:srgbClr val="E8ECF0"/>
+                    </a:solidFill>
+                  </a:tcPr>
+                </a:tc>
+              </a:tr>
+              <a:tr h="301752">
+                <a:tc>
+                  <a:txBody>
+                    <a:bodyPr/>
+                    <a:lstStyle/>
+                    <a:p>
+                      <a:pPr algn="l">
+                        <a:defRPr sz="1150">
+                          <a:solidFill>
+                            <a:srgbClr val="202428"/>
+                          </a:solidFill>
+                        </a:defRPr>
+                      </a:pPr>
+                      <a:r>
+                        <a:t>Published 77 K card</a:t>
+                      </a:r>
+                    </a:p>
+                  </a:txBody>
+                  <a:tcPr marL="45720" marR="45720" marT="9144" marB="9144">
+                    <a:solidFill>
+                      <a:srgbClr val="FFFFFF"/>
+                    </a:solidFill>
+                  </a:tcPr>
+                </a:tc>
+                <a:tc>
+                  <a:txBody>
+                    <a:bodyPr/>
+                    <a:lstStyle/>
+                    <a:p>
+                      <a:pPr algn="r">
+                        <a:defRPr sz="1150">
+                          <a:solidFill>
+                            <a:srgbClr val="202428"/>
+                          </a:solidFill>
+                        </a:defRPr>
+                      </a:pPr>
+                      <a:r>
+                        <a:t>0.2751</a:t>
+                      </a:r>
+                    </a:p>
+                  </a:txBody>
+                  <a:tcPr marL="45720" marR="45720" marT="9144" marB="9144">
+                    <a:solidFill>
+                      <a:srgbClr val="FFFFFF"/>
+                    </a:solidFill>
+                  </a:tcPr>
+                </a:tc>
+                <a:tc>
+                  <a:txBody>
+                    <a:bodyPr/>
+                    <a:lstStyle/>
+                    <a:p>
+                      <a:pPr algn="r">
+                        <a:defRPr sz="1150">
+                          <a:solidFill>
+                            <a:srgbClr val="202428"/>
+                          </a:solidFill>
+                        </a:defRPr>
+                      </a:pPr>
+                      <a:r>
+                        <a:t>0.2595</a:t>
+                      </a:r>
+                    </a:p>
+                  </a:txBody>
+                  <a:tcPr marL="45720" marR="45720" marT="9144" marB="9144">
+                    <a:solidFill>
+                      <a:srgbClr val="FFFFFF"/>
+                    </a:solidFill>
+                  </a:tcPr>
+                </a:tc>
+                <a:tc>
+                  <a:txBody>
+                    <a:bodyPr/>
+                    <a:lstStyle/>
+                    <a:p>
+                      <a:pPr algn="r">
+                        <a:defRPr sz="1150">
+                          <a:solidFill>
+                            <a:srgbClr val="202428"/>
+                          </a:solidFill>
+                        </a:defRPr>
+                      </a:pPr>
+                      <a:r>
+                        <a:t>0.2304</a:t>
+                      </a:r>
+                    </a:p>
+                  </a:txBody>
+                  <a:tcPr marL="45720" marR="45720" marT="9144" marB="9144">
+                    <a:solidFill>
+                      <a:srgbClr val="FFFFFF"/>
+                    </a:solidFill>
+                  </a:tcPr>
+                </a:tc>
+                <a:tc>
+                  <a:txBody>
+                    <a:bodyPr/>
+                    <a:lstStyle/>
+                    <a:p>
+                      <a:pPr algn="r">
+                        <a:defRPr sz="1150">
+                          <a:solidFill>
+                            <a:srgbClr val="202428"/>
+                          </a:solidFill>
+                        </a:defRPr>
+                      </a:pPr>
+                      <a:r>
+                        <a:t>4.007 [3.303, 4.832]</a:t>
+                      </a:r>
+                    </a:p>
+                  </a:txBody>
+                  <a:tcPr marL="45720" marR="45720" marT="9144" marB="9144">
+                    <a:solidFill>
+                      <a:srgbClr val="FFFFFF"/>
+                    </a:solidFill>
+                  </a:tcPr>
+                </a:tc>
+                <a:tc>
+                  <a:txBody>
+                    <a:bodyPr/>
+                    <a:lstStyle/>
+                    <a:p>
+                      <a:pPr algn="r">
+                        <a:defRPr sz="1150">
+                          <a:solidFill>
+                            <a:srgbClr val="202428"/>
+                          </a:solidFill>
+                        </a:defRPr>
+                      </a:pPr>
+                      <a:r>
+                        <a:t>0/18</a:t>
+                      </a:r>
+                    </a:p>
+                  </a:txBody>
+                  <a:tcPr marL="45720" marR="45720" marT="9144" marB="9144">
+                    <a:solidFill>
+                      <a:srgbClr val="FFFFFF"/>
+                    </a:solidFill>
+                  </a:tcPr>
+                </a:tc>
+              </a:tr>
+              <a:tr h="301752">
+                <a:tc>
+                  <a:txBody>
+                    <a:bodyPr/>
+                    <a:lstStyle/>
+                    <a:p>
+                      <a:pPr algn="l">
+                        <a:defRPr sz="1150">
+                          <a:solidFill>
+                            <a:srgbClr val="202428"/>
+                          </a:solidFill>
+                        </a:defRPr>
+                      </a:pPr>
+                      <a:r>
+                        <a:t>C0_refit (refit, g = 0)</a:t>
+                      </a:r>
+                    </a:p>
+                  </a:txBody>
+                  <a:tcPr marL="45720" marR="45720" marT="9144" marB="9144">
+                    <a:solidFill>
+                      <a:srgbClr val="FFFFFF"/>
+                    </a:solidFill>
+                  </a:tcPr>
+                </a:tc>
+                <a:tc>
+                  <a:txBody>
+                    <a:bodyPr/>
+                    <a:lstStyle/>
+                    <a:p>
+                      <a:pPr algn="r">
+                        <a:defRPr sz="1150">
+                          <a:solidFill>
+                            <a:srgbClr val="202428"/>
+                          </a:solidFill>
+                        </a:defRPr>
+                      </a:pPr>
+                      <a:r>
+                        <a:t>0.1051</a:t>
+                      </a:r>
+                    </a:p>
+                  </a:txBody>
+                  <a:tcPr marL="45720" marR="45720" marT="9144" marB="9144">
+                    <a:solidFill>
+                      <a:srgbClr val="FFFFFF"/>
+                    </a:solidFill>
+                  </a:tcPr>
+                </a:tc>
+                <a:tc>
+                  <a:txBody>
+                    <a:bodyPr/>
+                    <a:lstStyle/>
+                    <a:p>
+                      <a:pPr algn="r">
+                        <a:defRPr sz="1150">
+                          <a:solidFill>
+                            <a:srgbClr val="202428"/>
+                          </a:solidFill>
+                        </a:defRPr>
+                      </a:pPr>
+                      <a:r>
+                        <a:t>0.0984</a:t>
+                      </a:r>
+                    </a:p>
+                  </a:txBody>
+                  <a:tcPr marL="45720" marR="45720" marT="9144" marB="9144">
+                    <a:solidFill>
+                      <a:srgbClr val="FFFFFF"/>
+                    </a:solidFill>
+                  </a:tcPr>
+                </a:tc>
+                <a:tc>
+                  <a:txBody>
+                    <a:bodyPr/>
+                    <a:lstStyle/>
+                    <a:p>
+                      <a:pPr algn="r">
+                        <a:defRPr sz="1150">
+                          <a:solidFill>
+                            <a:srgbClr val="202428"/>
+                          </a:solidFill>
+                        </a:defRPr>
+                      </a:pPr>
+                      <a:r>
+                        <a:t>0.0820</a:t>
+                      </a:r>
+                    </a:p>
+                  </a:txBody>
+                  <a:tcPr marL="45720" marR="45720" marT="9144" marB="9144">
+                    <a:solidFill>
+                      <a:srgbClr val="FFFFFF"/>
+                    </a:solidFill>
+                  </a:tcPr>
+                </a:tc>
+                <a:tc>
+                  <a:txBody>
+                    <a:bodyPr/>
+                    <a:lstStyle/>
+                    <a:p>
+                      <a:pPr algn="r">
+                        <a:defRPr sz="1150">
+                          <a:solidFill>
+                            <a:srgbClr val="202428"/>
+                          </a:solidFill>
+                        </a:defRPr>
+                      </a:pPr>
+                      <a:r>
+                        <a:t>1.341 [1.176, 1.516]</a:t>
+                      </a:r>
+                    </a:p>
+                  </a:txBody>
+                  <a:tcPr marL="45720" marR="45720" marT="9144" marB="9144">
+                    <a:solidFill>
+                      <a:srgbClr val="FFFFFF"/>
+                    </a:solidFill>
+                  </a:tcPr>
+                </a:tc>
+                <a:tc>
+                  <a:txBody>
+                    <a:bodyPr/>
+                    <a:lstStyle/>
+                    <a:p>
+                      <a:pPr algn="r">
+                        <a:defRPr sz="1150">
+                          <a:solidFill>
+                            <a:srgbClr val="202428"/>
+                          </a:solidFill>
+                        </a:defRPr>
+                      </a:pPr>
+                      <a:r>
+                        <a:t>1/18</a:t>
+                      </a:r>
+                    </a:p>
+                  </a:txBody>
+                  <a:tcPr marL="45720" marR="45720" marT="9144" marB="9144">
+                    <a:solidFill>
+                      <a:srgbClr val="FFFFFF"/>
+                    </a:solidFill>
+                  </a:tcPr>
+                </a:tc>
+              </a:tr>
+              <a:tr h="301752">
+                <a:tc>
+                  <a:txBody>
+                    <a:bodyPr/>
+                    <a:lstStyle/>
+                    <a:p>
+                      <a:pPr algn="l">
+                        <a:defRPr sz="1150">
+                          <a:solidFill>
+                            <a:srgbClr val="202428"/>
+                          </a:solidFill>
+                        </a:defRPr>
+                      </a:pPr>
+                      <a:r>
+                        <a:t>M_bias v1 (abs inputs, no penalty)</a:t>
+                      </a:r>
+                    </a:p>
+                  </a:txBody>
+                  <a:tcPr marL="45720" marR="45720" marT="9144" marB="9144">
+                    <a:solidFill>
+                      <a:srgbClr val="FFFFFF"/>
+                    </a:solidFill>
+                  </a:tcPr>
+                </a:tc>
+                <a:tc>
+                  <a:txBody>
+                    <a:bodyPr/>
+                    <a:lstStyle/>
+                    <a:p>
+                      <a:pPr algn="r">
+                        <a:defRPr sz="1150">
+                          <a:solidFill>
+                            <a:srgbClr val="202428"/>
+                          </a:solidFill>
+                        </a:defRPr>
+                      </a:pPr>
+                      <a:r>
+                        <a:t>0.0735</a:t>
+                      </a:r>
+                    </a:p>
+                  </a:txBody>
+                  <a:tcPr marL="45720" marR="45720" marT="9144" marB="9144">
+                    <a:solidFill>
+                      <a:srgbClr val="FFFFFF"/>
+                    </a:solidFill>
+                  </a:tcPr>
+                </a:tc>
+                <a:tc>
+                  <a:txBody>
+                    <a:bodyPr/>
+                    <a:lstStyle/>
+                    <a:p>
+                      <a:pPr algn="r">
+                        <a:defRPr sz="1150">
+                          <a:solidFill>
+                            <a:srgbClr val="202428"/>
+                          </a:solidFill>
+                        </a:defRPr>
+                      </a:pPr>
+                      <a:r>
+                        <a:t>0.0695</a:t>
+                      </a:r>
+                    </a:p>
+                  </a:txBody>
+                  <a:tcPr marL="45720" marR="45720" marT="9144" marB="9144">
+                    <a:solidFill>
+                      <a:srgbClr val="FFFFFF"/>
+                    </a:solidFill>
+                  </a:tcPr>
+                </a:tc>
+                <a:tc>
+                  <a:txBody>
+                    <a:bodyPr/>
+                    <a:lstStyle/>
+                    <a:p>
+                      <a:pPr algn="r">
+                        <a:defRPr sz="1150">
+                          <a:solidFill>
+                            <a:srgbClr val="202428"/>
+                          </a:solidFill>
+                        </a:defRPr>
+                      </a:pPr>
+                      <a:r>
+                        <a:t>0.0637</a:t>
+                      </a:r>
+                    </a:p>
+                  </a:txBody>
+                  <a:tcPr marL="45720" marR="45720" marT="9144" marB="9144">
+                    <a:solidFill>
+                      <a:srgbClr val="FFFFFF"/>
+                    </a:solidFill>
+                  </a:tcPr>
+                </a:tc>
+                <a:tc>
+                  <a:txBody>
+                    <a:bodyPr/>
+                    <a:lstStyle/>
+                    <a:p>
+                      <a:pPr algn="r">
+                        <a:defRPr sz="1150">
+                          <a:solidFill>
+                            <a:srgbClr val="202428"/>
+                          </a:solidFill>
+                        </a:defRPr>
+                      </a:pPr>
+                      <a:r>
+                        <a:t>1</a:t>
+                      </a:r>
+                    </a:p>
+                  </a:txBody>
+                  <a:tcPr marL="45720" marR="45720" marT="9144" marB="9144">
+                    <a:solidFill>
+                      <a:srgbClr val="FFFFFF"/>
+                    </a:solidFill>
+                  </a:tcPr>
+                </a:tc>
+                <a:tc>
+                  <a:txBody>
+                    <a:bodyPr/>
+                    <a:lstStyle/>
+                    <a:p>
+                      <a:pPr algn="r">
+                        <a:defRPr sz="1150">
+                          <a:solidFill>
+                            <a:srgbClr val="202428"/>
+                          </a:solidFill>
+                        </a:defRPr>
+                      </a:pPr>
+                      <a:r>
+                        <a:t>-</a:t>
+                      </a:r>
+                    </a:p>
+                  </a:txBody>
+                  <a:tcPr marL="45720" marR="45720" marT="9144" marB="9144">
+                    <a:solidFill>
+                      <a:srgbClr val="FFFFFF"/>
+                    </a:solidFill>
+                  </a:tcPr>
+                </a:tc>
+              </a:tr>
+              <a:tr h="301752">
+                <a:tc>
+                  <a:txBody>
+                    <a:bodyPr/>
+                    <a:lstStyle/>
+                    <a:p>
+                      <a:pPr algn="l">
+                        <a:defRPr sz="1150">
+                          <a:solidFill>
+                            <a:srgbClr val="202428"/>
+                          </a:solidFill>
+                        </a:defRPr>
+                      </a:pPr>
+                      <a:r>
+                        <a:t>g v2, lambda = 10 V (I12-1)</a:t>
+                      </a:r>
+                    </a:p>
+                  </a:txBody>
+                  <a:tcPr marL="45720" marR="45720" marT="9144" marB="9144">
+                    <a:solidFill>
+                      <a:srgbClr val="FFFFFF"/>
+                    </a:solidFill>
+                  </a:tcPr>
+                </a:tc>
+                <a:tc>
+                  <a:txBody>
+                    <a:bodyPr/>
+                    <a:lstStyle/>
+                    <a:p>
+                      <a:pPr algn="r">
+                        <a:defRPr sz="1150">
+                          <a:solidFill>
+                            <a:srgbClr val="202428"/>
+                          </a:solidFill>
+                        </a:defRPr>
+                      </a:pPr>
+                      <a:r>
+                        <a:t>0.0772</a:t>
+                      </a:r>
+                    </a:p>
+                  </a:txBody>
+                  <a:tcPr marL="45720" marR="45720" marT="9144" marB="9144">
+                    <a:solidFill>
+                      <a:srgbClr val="FFFFFF"/>
+                    </a:solidFill>
+                  </a:tcPr>
+                </a:tc>
+                <a:tc>
+                  <a:txBody>
+                    <a:bodyPr/>
+                    <a:lstStyle/>
+                    <a:p>
+                      <a:pPr algn="r">
+                        <a:defRPr sz="1150">
+                          <a:solidFill>
+                            <a:srgbClr val="202428"/>
+                          </a:solidFill>
+                        </a:defRPr>
+                      </a:pPr>
+                      <a:r>
+                        <a:t>0.0732</a:t>
+                      </a:r>
+                    </a:p>
+                  </a:txBody>
+                  <a:tcPr marL="45720" marR="45720" marT="9144" marB="9144">
+                    <a:solidFill>
+                      <a:srgbClr val="FFFFFF"/>
+                    </a:solidFill>
+                  </a:tcPr>
+                </a:tc>
+                <a:tc>
+                  <a:txBody>
+                    <a:bodyPr/>
+                    <a:lstStyle/>
+                    <a:p>
+                      <a:pPr algn="r">
+                        <a:defRPr sz="1150">
+                          <a:solidFill>
+                            <a:srgbClr val="202428"/>
+                          </a:solidFill>
+                        </a:defRPr>
+                      </a:pPr>
+                      <a:r>
+                        <a:t>0.0544</a:t>
+                      </a:r>
+                    </a:p>
+                  </a:txBody>
+                  <a:tcPr marL="45720" marR="45720" marT="9144" marB="9144">
+                    <a:solidFill>
+                      <a:srgbClr val="FFFFFF"/>
+                    </a:solidFill>
+                  </a:tcPr>
+                </a:tc>
+                <a:tc>
+                  <a:txBody>
+                    <a:bodyPr/>
+                    <a:lstStyle/>
+                    <a:p>
+                      <a:pPr algn="r">
+                        <a:defRPr sz="1150">
+                          <a:solidFill>
+                            <a:srgbClr val="202428"/>
+                          </a:solidFill>
+                        </a:defRPr>
+                      </a:pPr>
+                      <a:r>
+                        <a:t>1.053 [0.966, 1.137]</a:t>
+                      </a:r>
+                    </a:p>
+                  </a:txBody>
+                  <a:tcPr marL="45720" marR="45720" marT="9144" marB="9144">
+                    <a:solidFill>
+                      <a:srgbClr val="FFFFFF"/>
+                    </a:solidFill>
+                  </a:tcPr>
+                </a:tc>
+                <a:tc>
+                  <a:txBody>
+                    <a:bodyPr/>
+                    <a:lstStyle/>
+                    <a:p>
+                      <a:pPr algn="r">
+                        <a:defRPr sz="1150">
+                          <a:solidFill>
+                            <a:srgbClr val="202428"/>
+                          </a:solidFill>
+                        </a:defRPr>
+                      </a:pPr>
+                      <a:r>
+                        <a:t>4/18</a:t>
+                      </a:r>
+                    </a:p>
+                  </a:txBody>
+                  <a:tcPr marL="45720" marR="45720" marT="9144" marB="9144">
+                    <a:solidFill>
+                      <a:srgbClr val="FFFFFF"/>
+                    </a:solidFill>
+                  </a:tcPr>
+                </a:tc>
+              </a:tr>
+              <a:tr h="301752">
+                <a:tc>
+                  <a:txBody>
+                    <a:bodyPr/>
+                    <a:lstStyle/>
+                    <a:p>
+                      <a:pPr algn="l">
+                        <a:defRPr sz="1150">
+                          <a:solidFill>
+                            <a:srgbClr val="202428"/>
+                          </a:solidFill>
+                        </a:defRPr>
+                      </a:pPr>
+                      <a:r>
+                        <a:t>g v2, selected lambda (I15-2 rows)</a:t>
+                      </a:r>
+                    </a:p>
+                  </a:txBody>
+                  <a:tcPr marL="45720" marR="45720" marT="9144" marB="9144">
+                    <a:solidFill>
+                      <a:srgbClr val="FFFFFF"/>
+                    </a:solidFill>
+                  </a:tcPr>
+                </a:tc>
+                <a:tc>
+                  <a:txBody>
+                    <a:bodyPr/>
+                    <a:lstStyle/>
+                    <a:p>
+                      <a:pPr algn="r">
+                        <a:defRPr sz="1150">
+                          <a:solidFill>
+                            <a:srgbClr val="202428"/>
+                          </a:solidFill>
+                        </a:defRPr>
+                      </a:pPr>
+                      <a:r>
+                        <a:t>0.0739</a:t>
+                      </a:r>
+                    </a:p>
+                  </a:txBody>
+                  <a:tcPr marL="45720" marR="45720" marT="9144" marB="9144">
+                    <a:solidFill>
+                      <a:srgbClr val="FFFFFF"/>
+                    </a:solidFill>
+                  </a:tcPr>
+                </a:tc>
+                <a:tc>
+                  <a:txBody>
+                    <a:bodyPr/>
+                    <a:lstStyle/>
+                    <a:p>
+                      <a:pPr algn="r">
+                        <a:defRPr sz="1150">
+                          <a:solidFill>
+                            <a:srgbClr val="202428"/>
+                          </a:solidFill>
+                        </a:defRPr>
+                      </a:pPr>
+                      <a:r>
+                        <a:t>0.0700</a:t>
+                      </a:r>
+                    </a:p>
+                  </a:txBody>
+                  <a:tcPr marL="45720" marR="45720" marT="9144" marB="9144">
+                    <a:solidFill>
+                      <a:srgbClr val="FFFFFF"/>
+                    </a:solidFill>
+                  </a:tcPr>
+                </a:tc>
+                <a:tc>
+                  <a:txBody>
+                    <a:bodyPr/>
+                    <a:lstStyle/>
+                    <a:p>
+                      <a:pPr algn="r">
+                        <a:defRPr sz="1150">
+                          <a:solidFill>
+                            <a:srgbClr val="202428"/>
+                          </a:solidFill>
+                        </a:defRPr>
+                      </a:pPr>
+                      <a:r>
+                        <a:t>0.0550</a:t>
+                      </a:r>
+                    </a:p>
+                  </a:txBody>
+                  <a:tcPr marL="45720" marR="45720" marT="9144" marB="9144">
+                    <a:solidFill>
+                      <a:srgbClr val="FFFFFF"/>
+                    </a:solidFill>
+                  </a:tcPr>
+                </a:tc>
+                <a:tc>
+                  <a:txBody>
+                    <a:bodyPr/>
+                    <a:lstStyle/>
+                    <a:p>
+                      <a:pPr algn="r">
+                        <a:defRPr sz="1150">
+                          <a:solidFill>
+                            <a:srgbClr val="202428"/>
+                          </a:solidFill>
+                        </a:defRPr>
+                      </a:pPr>
+                      <a:r>
+                        <a:t>0.997 [0.962, 1.027]</a:t>
+                      </a:r>
+                    </a:p>
+                  </a:txBody>
+                  <a:tcPr marL="45720" marR="45720" marT="9144" marB="9144">
+                    <a:solidFill>
+                      <a:srgbClr val="FFFFFF"/>
+                    </a:solidFill>
+                  </a:tcPr>
+                </a:tc>
+                <a:tc>
+                  <a:txBody>
+                    <a:bodyPr/>
+                    <a:lstStyle/>
+                    <a:p>
+                      <a:pPr algn="r">
+                        <a:defRPr sz="1150">
+                          <a:solidFill>
+                            <a:srgbClr val="202428"/>
+                          </a:solidFill>
+                        </a:defRPr>
+                      </a:pPr>
+                      <a:r>
+                        <a:t>7/18</a:t>
+                      </a:r>
+                    </a:p>
+                  </a:txBody>
+                  <a:tcPr marL="45720" marR="45720" marT="9144" marB="9144">
+                    <a:solidFill>
+                      <a:srgbClr val="FFFFFF"/>
+                    </a:solidFill>
+                  </a:tcPr>
+                </a:tc>
+              </a:tr>
+              <a:tr h="301752">
+                <a:tc>
+                  <a:txBody>
+                    <a:bodyPr/>
+                    <a:lstStyle/>
+                    <a:p>
+                      <a:pPr algn="l">
+                        <a:defRPr sz="1150">
+                          <a:solidFill>
+                            <a:srgbClr val="202428"/>
+                          </a:solidFill>
+                        </a:defRPr>
+                      </a:pPr>
+                      <a:r>
+                        <a:t>g v2, selected lambda, element deck (I16-1)</a:t>
+                      </a:r>
+                    </a:p>
+                  </a:txBody>
+                  <a:tcPr marL="45720" marR="45720" marT="9144" marB="9144">
+                    <a:solidFill>
+                      <a:srgbClr val="FFFFFF"/>
+                    </a:solidFill>
+                  </a:tcPr>
+                </a:tc>
+                <a:tc>
+                  <a:txBody>
+                    <a:bodyPr/>
+                    <a:lstStyle/>
+                    <a:p>
+                      <a:pPr algn="r">
+                        <a:defRPr sz="1150">
+                          <a:solidFill>
+                            <a:srgbClr val="202428"/>
+                          </a:solidFill>
+                        </a:defRPr>
+                      </a:pPr>
+                      <a:r>
+                        <a:t>0.0739</a:t>
+                      </a:r>
+                    </a:p>
+                  </a:txBody>
+                  <a:tcPr marL="45720" marR="45720" marT="9144" marB="9144">
+                    <a:solidFill>
+                      <a:srgbClr val="FFFFFF"/>
+                    </a:solidFill>
+                  </a:tcPr>
+                </a:tc>
+                <a:tc>
+                  <a:txBody>
+                    <a:bodyPr/>
+                    <a:lstStyle/>
+                    <a:p>
+                      <a:pPr algn="r">
+                        <a:defRPr sz="1150">
+                          <a:solidFill>
+                            <a:srgbClr val="202428"/>
+                          </a:solidFill>
+                        </a:defRPr>
+                      </a:pPr>
+                      <a:r>
+                        <a:t>0.0700</a:t>
+                      </a:r>
+                    </a:p>
+                  </a:txBody>
+                  <a:tcPr marL="45720" marR="45720" marT="9144" marB="9144">
+                    <a:solidFill>
+                      <a:srgbClr val="FFFFFF"/>
+                    </a:solidFill>
+                  </a:tcPr>
+                </a:tc>
+                <a:tc>
+                  <a:txBody>
+                    <a:bodyPr/>
+                    <a:lstStyle/>
+                    <a:p>
+                      <a:pPr algn="r">
+                        <a:defRPr sz="1150">
+                          <a:solidFill>
+                            <a:srgbClr val="202428"/>
+                          </a:solidFill>
+                        </a:defRPr>
+                      </a:pPr>
+                      <a:r>
+                        <a:t>0.0550</a:t>
+                      </a:r>
+                    </a:p>
+                  </a:txBody>
+                  <a:tcPr marL="45720" marR="45720" marT="9144" marB="9144">
+                    <a:solidFill>
+                      <a:srgbClr val="FFFFFF"/>
+                    </a:solidFill>
+                  </a:tcPr>
+                </a:tc>
+                <a:tc>
+                  <a:txBody>
+                    <a:bodyPr/>
+                    <a:lstStyle/>
+                    <a:p>
+                      <a:pPr algn="r">
+                        <a:defRPr sz="1150">
+                          <a:solidFill>
+                            <a:srgbClr val="202428"/>
+                          </a:solidFill>
+                        </a:defRPr>
+                      </a:pPr>
+                      <a:r>
+                        <a:t>0.996 [0.962, 1.027]</a:t>
+                      </a:r>
+                    </a:p>
+                  </a:txBody>
+                  <a:tcPr marL="45720" marR="45720" marT="9144" marB="9144">
+                    <a:solidFill>
+                      <a:srgbClr val="FFFFFF"/>
+                    </a:solidFill>
+                  </a:tcPr>
+                </a:tc>
+                <a:tc>
+                  <a:txBody>
+                    <a:bodyPr/>
+                    <a:lstStyle/>
+                    <a:p>
+                      <a:pPr algn="r">
+                        <a:defRPr sz="1150">
+                          <a:solidFill>
+                            <a:srgbClr val="202428"/>
+                          </a:solidFill>
+                        </a:defRPr>
+                      </a:pPr>
+                      <a:r>
+                        <a:t>7/18</a:t>
+                      </a:r>
+                    </a:p>
+                  </a:txBody>
+                  <a:tcPr marL="45720" marR="45720" marT="9144" marB="9144">
+                    <a:solidFill>
+                      <a:srgbClr val="FFFFFF"/>
+                    </a:solidFill>
+                  </a:tcPr>
+                </a:tc>
+              </a:tr>
+            </a:tbl>
+          </a:graphicData>
+        </a:graphic>
+      </p:graphicFrame>
+      <p:sp>
+        <p:nvSpPr>
+          <p:cNvPr id="5" name="TextBox 4"/>
+          <p:cNvSpPr txBox="1"/>
+          <p:nvPr/>
+        </p:nvSpPr>
+        <p:spPr>
+          <a:xfrm>
+            <a:off x="548640" y="6071616"/>
+            <a:ext cx="11064240" cy="685800"/>
+          </a:xfrm>
+          <a:prstGeom prst="rect">
+            <a:avLst/>
+          </a:prstGeom>
+          <a:noFill/>
+        </p:spPr>
+        <p:txBody>
+          <a:bodyPr wrap="square">
+            <a:spAutoFit/>
+          </a:bodyPr>
+          <a:lstStyle/>
+          <a:p>
+            <a:pPr>
+              <a:spcAft>
+                <a:spcPts val="400"/>
+              </a:spcAft>
+            </a:pPr>
+            <a:r>
+              <a:rPr sz="1050">
+                <a:solidFill>
+                  <a:srgbClr val="202428"/>
+                </a:solidFill>
+              </a:rPr>
+              <a:t>Strict paper RRMS, curve inclusion frozen to the published card; leave-one-device-out, state C. GMR: geometric-mean ratio, device bootstrap 10,000. Element deck: fold model as an OSDI module with its held-out card (max per-device |element - Python row| 2.0e-04).</a:t>
+            </a:r>
+          </a:p>
+        </p:txBody>
+      </p:sp>
+    </p:spTree>
+  </p:cSld>
+  <p:clrMapOvr>
+    <a:masterClrMapping/>
+  </p:clrMapOvr>
+</p:sld>
+</file>
+
+<file path=ppt/slides/slide26.xml><?xml version="1.0" encoding="utf-8"?>
+<p:sld xmlns:a="http://schemas.openxmlformats.org/drawingml/2006/main" xmlns:p="http://schemas.openxmlformats.org/presentationml/2006/main" xmlns:r="http://schemas.openxmlformats.org/officeDocument/2006/relationships">
+  <p:cSld>
+    <p:spTree>
+      <p:nvGrpSpPr>
+        <p:cNvPr id="1" name=""/>
+        <p:cNvGrpSpPr/>
+        <p:nvPr/>
+      </p:nvGrpSpPr>
+      <p:grpSpPr/>
+      <p:sp>
+        <p:nvSpPr>
+          <p:cNvPr id="2" name="TextBox 1"/>
+          <p:cNvSpPr txBox="1"/>
+          <p:nvPr/>
+        </p:nvSpPr>
+        <p:spPr>
+          <a:xfrm>
+            <a:off x="457200" y="228600"/>
+            <a:ext cx="11247120" cy="640080"/>
+          </a:xfrm>
+          <a:prstGeom prst="rect">
+            <a:avLst/>
+          </a:prstGeom>
+          <a:noFill/>
+        </p:spPr>
+        <p:txBody>
+          <a:bodyPr wrap="none">
+            <a:spAutoFit/>
+          </a:bodyPr>
+          <a:lstStyle/>
+          <a:p>
+            <a:r>
+              <a:rPr sz="2400" b="1">
+                <a:solidFill>
+                  <a:srgbClr val="202428"/>
+                </a:solidFill>
+              </a:rPr>
+              <a:t>Deployment checks of the selected g v2 (I16-1, pre-registered)</a:t>
+            </a:r>
+          </a:p>
+        </p:txBody>
+      </p:sp>
+      <p:graphicFrame>
+        <p:nvGraphicFramePr>
+          <p:cNvPr id="3" name="Table 2"/>
+          <p:cNvGraphicFramePr>
+            <a:graphicFrameLocks noGrp="1"/>
+          </p:cNvGraphicFramePr>
+          <p:nvPr/>
+        </p:nvGraphicFramePr>
+        <p:xfrm>
+          <a:off x="365760" y="731520"/>
+          <a:ext cx="11430000" cy="3703320"/>
+        </p:xfrm>
+        <a:graphic>
+          <a:graphicData uri="http://schemas.openxmlformats.org/drawingml/2006/table">
+            <a:tbl>
+              <a:tblPr firstRow="1" bandRow="1">
+                <a:tableStyleId>{5C22544A-7EE6-4342-B048-85BDC9FD1C3A}</a:tableStyleId>
+              </a:tblPr>
+              <a:tblGrid>
+                <a:gridCol w="3931920"/>
+                <a:gridCol w="1005840"/>
+                <a:gridCol w="2331720"/>
+                <a:gridCol w="2331720"/>
+                <a:gridCol w="1828800"/>
+              </a:tblGrid>
+              <a:tr h="246888">
+                <a:tc>
+                  <a:txBody>
+                    <a:bodyPr/>
+                    <a:lstStyle/>
+                    <a:p>
+                      <a:pPr algn="l">
+                        <a:defRPr sz="1050" b="1">
+                          <a:solidFill>
+                            <a:srgbClr val="202428"/>
+                          </a:solidFill>
+                        </a:defRPr>
+                      </a:pPr>
+                      <a:r>
+                        <a:t>Check</a:t>
+                      </a:r>
+                    </a:p>
+                  </a:txBody>
+                  <a:tcPr marL="45720" marR="45720" marT="9144" marB="9144">
+                    <a:solidFill>
+                      <a:srgbClr val="E8ECF0"/>
+                    </a:solidFill>
+                  </a:tcPr>
+                </a:tc>
+                <a:tc>
+                  <a:txBody>
+                    <a:bodyPr/>
+                    <a:lstStyle/>
+                    <a:p>
+                      <a:pPr algn="l">
+                        <a:defRPr sz="1050" b="1">
+                          <a:solidFill>
+                            <a:srgbClr val="202428"/>
+                          </a:solidFill>
+                        </a:defRPr>
+                      </a:pPr>
+                      <a:r>
+                        <a:t>Threshold</a:t>
+                      </a:r>
+                    </a:p>
+                  </a:txBody>
+                  <a:tcPr marL="45720" marR="45720" marT="9144" marB="9144">
+                    <a:solidFill>
+                      <a:srgbClr val="E8ECF0"/>
+                    </a:solidFill>
+                  </a:tcPr>
+                </a:tc>
+                <a:tc>
+                  <a:txBody>
+                    <a:bodyPr/>
+                    <a:lstStyle/>
+                    <a:p>
+                      <a:pPr algn="l">
+                        <a:defRPr sz="1050" b="1">
+                          <a:solidFill>
+                            <a:srgbClr val="202428"/>
+                          </a:solidFill>
+                        </a:defRPr>
+                      </a:pPr>
+                      <a:r>
+                        <a:t>g v2, selected lambda (I16-1)</a:t>
+                      </a:r>
+                    </a:p>
+                  </a:txBody>
+                  <a:tcPr marL="45720" marR="45720" marT="9144" marB="9144">
+                    <a:solidFill>
+                      <a:srgbClr val="E8ECF0"/>
+                    </a:solidFill>
+                  </a:tcPr>
+                </a:tc>
+                <a:tc>
+                  <a:txBody>
+                    <a:bodyPr/>
+                    <a:lstStyle/>
+                    <a:p>
+                      <a:pPr algn="l">
+                        <a:defRPr sz="1050" b="1">
+                          <a:solidFill>
+                            <a:srgbClr val="202428"/>
+                          </a:solidFill>
+                        </a:defRPr>
+                      </a:pPr>
+                      <a:r>
+                        <a:t>g v2, lambda 10 V (I15-1)</a:t>
+                      </a:r>
+                    </a:p>
+                  </a:txBody>
+                  <a:tcPr marL="45720" marR="45720" marT="9144" marB="9144">
+                    <a:solidFill>
+                      <a:srgbClr val="E8ECF0"/>
+                    </a:solidFill>
+                  </a:tcPr>
+                </a:tc>
+                <a:tc>
+                  <a:txBody>
+                    <a:bodyPr/>
+                    <a:lstStyle/>
+                    <a:p>
+                      <a:pPr algn="l">
+                        <a:defRPr sz="1050" b="1">
+                          <a:solidFill>
+                            <a:srgbClr val="202428"/>
+                          </a:solidFill>
+                        </a:defRPr>
+                      </a:pPr>
+                      <a:r>
+                        <a:t>M_bias v1 (I15-1)</a:t>
+                      </a:r>
+                    </a:p>
+                  </a:txBody>
+                  <a:tcPr marL="45720" marR="45720" marT="9144" marB="9144">
+                    <a:solidFill>
+                      <a:srgbClr val="E8ECF0"/>
+                    </a:solidFill>
+                  </a:tcPr>
+                </a:tc>
+              </a:tr>
+              <a:tr h="246888">
+                <a:tc>
+                  <a:txBody>
+                    <a:bodyPr/>
+                    <a:lstStyle/>
+                    <a:p>
+                      <a:pPr algn="l">
+                        <a:defRPr sz="1050">
+                          <a:solidFill>
+                            <a:srgbClr val="202428"/>
+                          </a:solidFill>
+                        </a:defRPr>
+                      </a:pPr>
+                      <a:r>
+                        <a:t>Q1 equivalence violations, tight</a:t>
+                      </a:r>
+                    </a:p>
+                  </a:txBody>
+                  <a:tcPr marL="45720" marR="45720" marT="9144" marB="9144">
+                    <a:solidFill>
+                      <a:srgbClr val="FFFFFF"/>
+                    </a:solidFill>
+                  </a:tcPr>
+                </a:tc>
+                <a:tc>
+                  <a:txBody>
+                    <a:bodyPr/>
+                    <a:lstStyle/>
+                    <a:p>
+                      <a:pPr algn="r">
+                        <a:defRPr sz="1050">
+                          <a:solidFill>
+                            <a:srgbClr val="202428"/>
+                          </a:solidFill>
+                        </a:defRPr>
+                      </a:pPr>
+                      <a:r>
+                        <a:t>0</a:t>
+                      </a:r>
+                    </a:p>
+                  </a:txBody>
+                  <a:tcPr marL="45720" marR="45720" marT="9144" marB="9144">
+                    <a:solidFill>
+                      <a:srgbClr val="FFFFFF"/>
+                    </a:solidFill>
+                  </a:tcPr>
+                </a:tc>
+                <a:tc>
+                  <a:txBody>
+                    <a:bodyPr/>
+                    <a:lstStyle/>
+                    <a:p>
+                      <a:pPr algn="r">
+                        <a:defRPr sz="1050">
+                          <a:solidFill>
+                            <a:srgbClr val="202428"/>
+                          </a:solidFill>
+                        </a:defRPr>
+                      </a:pPr>
+                      <a:r>
+                        <a:t>0 pass</a:t>
+                      </a:r>
+                    </a:p>
+                  </a:txBody>
+                  <a:tcPr marL="45720" marR="45720" marT="9144" marB="9144">
+                    <a:solidFill>
+                      <a:srgbClr val="FFFFFF"/>
+                    </a:solidFill>
+                  </a:tcPr>
+                </a:tc>
+                <a:tc>
+                  <a:txBody>
+                    <a:bodyPr/>
+                    <a:lstStyle/>
+                    <a:p>
+                      <a:pPr algn="r">
+                        <a:defRPr sz="1050">
+                          <a:solidFill>
+                            <a:srgbClr val="202428"/>
+                          </a:solidFill>
+                        </a:defRPr>
+                      </a:pPr>
+                      <a:r>
+                        <a:t>0 pass</a:t>
+                      </a:r>
+                    </a:p>
+                  </a:txBody>
+                  <a:tcPr marL="45720" marR="45720" marT="9144" marB="9144">
+                    <a:solidFill>
+                      <a:srgbClr val="FFFFFF"/>
+                    </a:solidFill>
+                  </a:tcPr>
+                </a:tc>
+                <a:tc>
+                  <a:txBody>
+                    <a:bodyPr/>
+                    <a:lstStyle/>
+                    <a:p>
+                      <a:pPr algn="r">
+                        <a:defRPr sz="1050">
+                          <a:solidFill>
+                            <a:srgbClr val="202428"/>
+                          </a:solidFill>
+                        </a:defRPr>
+                      </a:pPr>
+                      <a:r>
+                        <a:t>0 pass</a:t>
+                      </a:r>
+                    </a:p>
+                  </a:txBody>
+                  <a:tcPr marL="45720" marR="45720" marT="9144" marB="9144">
+                    <a:solidFill>
+                      <a:srgbClr val="FFFFFF"/>
+                    </a:solidFill>
+                  </a:tcPr>
+                </a:tc>
+              </a:tr>
+              <a:tr h="246888">
+                <a:tc>
+                  <a:txBody>
+                    <a:bodyPr/>
+                    <a:lstStyle/>
+                    <a:p>
+                      <a:pPr algn="l">
+                        <a:defRPr sz="1050">
+                          <a:solidFill>
+                            <a:srgbClr val="202428"/>
+                          </a:solidFill>
+                        </a:defRPr>
+                      </a:pPr>
+                      <a:r>
+                        <a:t>Q1 runs: convergence lines / non-finite</a:t>
+                      </a:r>
+                    </a:p>
+                  </a:txBody>
+                  <a:tcPr marL="45720" marR="45720" marT="9144" marB="9144">
+                    <a:solidFill>
+                      <a:srgbClr val="FFFFFF"/>
+                    </a:solidFill>
+                  </a:tcPr>
+                </a:tc>
+                <a:tc>
+                  <a:txBody>
+                    <a:bodyPr/>
+                    <a:lstStyle/>
+                    <a:p>
+                      <a:pPr algn="r">
+                        <a:defRPr sz="1050">
+                          <a:solidFill>
+                            <a:srgbClr val="202428"/>
+                          </a:solidFill>
+                        </a:defRPr>
+                      </a:pPr>
+                      <a:r>
+                        <a:t>0</a:t>
+                      </a:r>
+                    </a:p>
+                  </a:txBody>
+                  <a:tcPr marL="45720" marR="45720" marT="9144" marB="9144">
+                    <a:solidFill>
+                      <a:srgbClr val="FFFFFF"/>
+                    </a:solidFill>
+                  </a:tcPr>
+                </a:tc>
+                <a:tc>
+                  <a:txBody>
+                    <a:bodyPr/>
+                    <a:lstStyle/>
+                    <a:p>
+                      <a:pPr algn="r">
+                        <a:defRPr sz="1050">
+                          <a:solidFill>
+                            <a:srgbClr val="202428"/>
+                          </a:solidFill>
+                        </a:defRPr>
+                      </a:pPr>
+                      <a:r>
+                        <a:t>0 pass</a:t>
+                      </a:r>
+                    </a:p>
+                  </a:txBody>
+                  <a:tcPr marL="45720" marR="45720" marT="9144" marB="9144">
+                    <a:solidFill>
+                      <a:srgbClr val="FFFFFF"/>
+                    </a:solidFill>
+                  </a:tcPr>
+                </a:tc>
+                <a:tc>
+                  <a:txBody>
+                    <a:bodyPr/>
+                    <a:lstStyle/>
+                    <a:p>
+                      <a:pPr algn="r">
+                        <a:defRPr sz="1050">
+                          <a:solidFill>
+                            <a:srgbClr val="202428"/>
+                          </a:solidFill>
+                        </a:defRPr>
+                      </a:pPr>
+                      <a:r>
+                        <a:t>0 pass</a:t>
+                      </a:r>
+                    </a:p>
+                  </a:txBody>
+                  <a:tcPr marL="45720" marR="45720" marT="9144" marB="9144">
+                    <a:solidFill>
+                      <a:srgbClr val="FFFFFF"/>
+                    </a:solidFill>
+                  </a:tcPr>
+                </a:tc>
+                <a:tc>
+                  <a:txBody>
+                    <a:bodyPr/>
+                    <a:lstStyle/>
+                    <a:p>
+                      <a:pPr algn="r">
+                        <a:defRPr sz="1050">
+                          <a:solidFill>
+                            <a:srgbClr val="202428"/>
+                          </a:solidFill>
+                        </a:defRPr>
+                      </a:pPr>
+                      <a:r>
+                        <a:t>0 pass</a:t>
+                      </a:r>
+                    </a:p>
+                  </a:txBody>
+                  <a:tcPr marL="45720" marR="45720" marT="9144" marB="9144">
+                    <a:solidFill>
+                      <a:srgbClr val="FFFFFF"/>
+                    </a:solidFill>
+                  </a:tcPr>
+                </a:tc>
+              </a:tr>
+              <a:tr h="246888">
+                <a:tc>
+                  <a:txBody>
+                    <a:bodyPr/>
+                    <a:lstStyle/>
+                    <a:p>
+                      <a:pPr algn="l">
+                        <a:defRPr sz="1050">
+                          <a:solidFill>
+                            <a:srgbClr val="202428"/>
+                          </a:solidFill>
+                        </a:defRPr>
+                      </a:pPr>
+                      <a:r>
+                        <a:t>|I(Vds = 0)| (A)</a:t>
+                      </a:r>
+                    </a:p>
+                  </a:txBody>
+                  <a:tcPr marL="45720" marR="45720" marT="9144" marB="9144">
+                    <a:solidFill>
+                      <a:srgbClr val="FFFFFF"/>
+                    </a:solidFill>
+                  </a:tcPr>
+                </a:tc>
+                <a:tc>
+                  <a:txBody>
+                    <a:bodyPr/>
+                    <a:lstStyle/>
+                    <a:p>
+                      <a:pPr algn="r">
+                        <a:defRPr sz="1050">
+                          <a:solidFill>
+                            <a:srgbClr val="202428"/>
+                          </a:solidFill>
+                        </a:defRPr>
+                      </a:pPr>
+                      <a:r>
+                        <a:t>&lt;= 1e-12</a:t>
+                      </a:r>
+                    </a:p>
+                  </a:txBody>
+                  <a:tcPr marL="45720" marR="45720" marT="9144" marB="9144">
+                    <a:solidFill>
+                      <a:srgbClr val="FFFFFF"/>
+                    </a:solidFill>
+                  </a:tcPr>
+                </a:tc>
+                <a:tc>
+                  <a:txBody>
+                    <a:bodyPr/>
+                    <a:lstStyle/>
+                    <a:p>
+                      <a:pPr algn="r">
+                        <a:defRPr sz="1050">
+                          <a:solidFill>
+                            <a:srgbClr val="202428"/>
+                          </a:solidFill>
+                        </a:defRPr>
+                      </a:pPr>
+                      <a:r>
+                        <a:t>1.0006e-12 FAIL</a:t>
+                      </a:r>
+                    </a:p>
+                  </a:txBody>
+                  <a:tcPr marL="45720" marR="45720" marT="9144" marB="9144">
+                    <a:solidFill>
+                      <a:srgbClr val="FFFFFF"/>
+                    </a:solidFill>
+                  </a:tcPr>
+                </a:tc>
+                <a:tc>
+                  <a:txBody>
+                    <a:bodyPr/>
+                    <a:lstStyle/>
+                    <a:p>
+                      <a:pPr algn="r">
+                        <a:defRPr sz="1050">
+                          <a:solidFill>
+                            <a:srgbClr val="202428"/>
+                          </a:solidFill>
+                        </a:defRPr>
+                      </a:pPr>
+                      <a:r>
+                        <a:t>9.8357e-13 pass</a:t>
+                      </a:r>
+                    </a:p>
+                  </a:txBody>
+                  <a:tcPr marL="45720" marR="45720" marT="9144" marB="9144">
+                    <a:solidFill>
+                      <a:srgbClr val="FFFFFF"/>
+                    </a:solidFill>
+                  </a:tcPr>
+                </a:tc>
+                <a:tc>
+                  <a:txBody>
+                    <a:bodyPr/>
+                    <a:lstStyle/>
+                    <a:p>
+                      <a:pPr algn="r">
+                        <a:defRPr sz="1050">
+                          <a:solidFill>
+                            <a:srgbClr val="202428"/>
+                          </a:solidFill>
+                        </a:defRPr>
+                      </a:pPr>
+                      <a:r>
+                        <a:t>9.9506e-13 pass</a:t>
+                      </a:r>
+                    </a:p>
+                  </a:txBody>
+                  <a:tcPr marL="45720" marR="45720" marT="9144" marB="9144">
+                    <a:solidFill>
+                      <a:srgbClr val="FFFFFF"/>
+                    </a:solidFill>
+                  </a:tcPr>
+                </a:tc>
+              </a:tr>
+              <a:tr h="246888">
+                <a:tc>
+                  <a:txBody>
+                    <a:bodyPr/>
+                    <a:lstStyle/>
+                    <a:p>
+                      <a:pPr algn="l">
+                        <a:defRPr sz="1050">
+                          <a:solidFill>
+                            <a:srgbClr val="202428"/>
+                          </a:solidFill>
+                        </a:defRPr>
+                      </a:pPr>
+                      <a:r>
+                        <a:t>Verilog-A g vs Python</a:t>
+                      </a:r>
+                    </a:p>
+                  </a:txBody>
+                  <a:tcPr marL="45720" marR="45720" marT="9144" marB="9144">
+                    <a:solidFill>
+                      <a:srgbClr val="FFFFFF"/>
+                    </a:solidFill>
+                  </a:tcPr>
+                </a:tc>
+                <a:tc>
+                  <a:txBody>
+                    <a:bodyPr/>
+                    <a:lstStyle/>
+                    <a:p>
+                      <a:pPr algn="r">
+                        <a:defRPr sz="1050">
+                          <a:solidFill>
+                            <a:srgbClr val="202428"/>
+                          </a:solidFill>
+                        </a:defRPr>
+                      </a:pPr>
+                      <a:r>
+                        <a:t>&lt;= 1e-9</a:t>
+                      </a:r>
+                    </a:p>
+                  </a:txBody>
+                  <a:tcPr marL="45720" marR="45720" marT="9144" marB="9144">
+                    <a:solidFill>
+                      <a:srgbClr val="FFFFFF"/>
+                    </a:solidFill>
+                  </a:tcPr>
+                </a:tc>
+                <a:tc>
+                  <a:txBody>
+                    <a:bodyPr/>
+                    <a:lstStyle/>
+                    <a:p>
+                      <a:pPr algn="r">
+                        <a:defRPr sz="1050">
+                          <a:solidFill>
+                            <a:srgbClr val="202428"/>
+                          </a:solidFill>
+                        </a:defRPr>
+                      </a:pPr>
+                      <a:r>
+                        <a:t>2.8e-16 pass</a:t>
+                      </a:r>
+                    </a:p>
+                  </a:txBody>
+                  <a:tcPr marL="45720" marR="45720" marT="9144" marB="9144">
+                    <a:solidFill>
+                      <a:srgbClr val="FFFFFF"/>
+                    </a:solidFill>
+                  </a:tcPr>
+                </a:tc>
+                <a:tc>
+                  <a:txBody>
+                    <a:bodyPr/>
+                    <a:lstStyle/>
+                    <a:p>
+                      <a:pPr algn="r">
+                        <a:defRPr sz="1050">
+                          <a:solidFill>
+                            <a:srgbClr val="202428"/>
+                          </a:solidFill>
+                        </a:defRPr>
+                      </a:pPr>
+                      <a:r>
+                        <a:t>2.5e-16 pass</a:t>
+                      </a:r>
+                    </a:p>
+                  </a:txBody>
+                  <a:tcPr marL="45720" marR="45720" marT="9144" marB="9144">
+                    <a:solidFill>
+                      <a:srgbClr val="FFFFFF"/>
+                    </a:solidFill>
+                  </a:tcPr>
+                </a:tc>
+                <a:tc>
+                  <a:txBody>
+                    <a:bodyPr/>
+                    <a:lstStyle/>
+                    <a:p>
+                      <a:pPr algn="r">
+                        <a:defRPr sz="1050">
+                          <a:solidFill>
+                            <a:srgbClr val="202428"/>
+                          </a:solidFill>
+                        </a:defRPr>
+                      </a:pPr>
+                      <a:r>
+                        <a:t>2.9e-16 pass</a:t>
+                      </a:r>
+                    </a:p>
+                  </a:txBody>
+                  <a:tcPr marL="45720" marR="45720" marT="9144" marB="9144">
+                    <a:solidFill>
+                      <a:srgbClr val="FFFFFF"/>
+                    </a:solidFill>
+                  </a:tcPr>
+                </a:tc>
+              </a:tr>
+              <a:tr h="246888">
+                <a:tc>
+                  <a:txBody>
+                    <a:bodyPr/>
+                    <a:lstStyle/>
+                    <a:p>
+                      <a:pPr algn="l">
+                        <a:defRPr sz="1050">
+                          <a:solidFill>
+                            <a:srgbClr val="202428"/>
+                          </a:solidFill>
+                        </a:defRPr>
+                      </a:pPr>
+                      <a:r>
+                        <a:t>Verilog-A g, d/s exchanged</a:t>
+                      </a:r>
+                    </a:p>
+                  </a:txBody>
+                  <a:tcPr marL="45720" marR="45720" marT="9144" marB="9144">
+                    <a:solidFill>
+                      <a:srgbClr val="FFFFFF"/>
+                    </a:solidFill>
+                  </a:tcPr>
+                </a:tc>
+                <a:tc>
+                  <a:txBody>
+                    <a:bodyPr/>
+                    <a:lstStyle/>
+                    <a:p>
+                      <a:pPr algn="r">
+                        <a:defRPr sz="1050">
+                          <a:solidFill>
+                            <a:srgbClr val="202428"/>
+                          </a:solidFill>
+                        </a:defRPr>
+                      </a:pPr>
+                      <a:r>
+                        <a:t>&lt;= 1e-12</a:t>
+                      </a:r>
+                    </a:p>
+                  </a:txBody>
+                  <a:tcPr marL="45720" marR="45720" marT="9144" marB="9144">
+                    <a:solidFill>
+                      <a:srgbClr val="FFFFFF"/>
+                    </a:solidFill>
+                  </a:tcPr>
+                </a:tc>
+                <a:tc>
+                  <a:txBody>
+                    <a:bodyPr/>
+                    <a:lstStyle/>
+                    <a:p>
+                      <a:pPr algn="r">
+                        <a:defRPr sz="1050">
+                          <a:solidFill>
+                            <a:srgbClr val="202428"/>
+                          </a:solidFill>
+                        </a:defRPr>
+                      </a:pPr>
+                      <a:r>
+                        <a:t>1.7e-16 pass</a:t>
+                      </a:r>
+                    </a:p>
+                  </a:txBody>
+                  <a:tcPr marL="45720" marR="45720" marT="9144" marB="9144">
+                    <a:solidFill>
+                      <a:srgbClr val="FFFFFF"/>
+                    </a:solidFill>
+                  </a:tcPr>
+                </a:tc>
+                <a:tc>
+                  <a:txBody>
+                    <a:bodyPr/>
+                    <a:lstStyle/>
+                    <a:p>
+                      <a:pPr algn="r">
+                        <a:defRPr sz="1050">
+                          <a:solidFill>
+                            <a:srgbClr val="202428"/>
+                          </a:solidFill>
+                        </a:defRPr>
+                      </a:pPr>
+                      <a:r>
+                        <a:t>3.3e-16 pass</a:t>
+                      </a:r>
+                    </a:p>
+                  </a:txBody>
+                  <a:tcPr marL="45720" marR="45720" marT="9144" marB="9144">
+                    <a:solidFill>
+                      <a:srgbClr val="FFFFFF"/>
+                    </a:solidFill>
+                  </a:tcPr>
+                </a:tc>
+                <a:tc>
+                  <a:txBody>
+                    <a:bodyPr/>
+                    <a:lstStyle/>
+                    <a:p>
+                      <a:pPr algn="r">
+                        <a:defRPr sz="1050">
+                          <a:solidFill>
+                            <a:srgbClr val="202428"/>
+                          </a:solidFill>
+                        </a:defRPr>
+                      </a:pPr>
+                      <a:r>
+                        <a:t>0.134 FAIL</a:t>
+                      </a:r>
+                    </a:p>
+                  </a:txBody>
+                  <a:tcPr marL="45720" marR="45720" marT="9144" marB="9144">
+                    <a:solidFill>
+                      <a:srgbClr val="FFFFFF"/>
+                    </a:solidFill>
+                  </a:tcPr>
+                </a:tc>
+              </a:tr>
+              <a:tr h="246888">
+                <a:tc>
+                  <a:txBody>
+                    <a:bodyPr/>
+                    <a:lstStyle/>
+                    <a:p>
+                      <a:pPr algn="l">
+                        <a:defRPr sz="1050">
+                          <a:solidFill>
+                            <a:srgbClr val="202428"/>
+                          </a:solidFill>
+                        </a:defRPr>
+                      </a:pPr>
+                      <a:r>
+                        <a:t>exchange asymmetry</a:t>
+                      </a:r>
+                    </a:p>
+                  </a:txBody>
+                  <a:tcPr marL="45720" marR="45720" marT="9144" marB="9144">
+                    <a:solidFill>
+                      <a:srgbClr val="FFFFFF"/>
+                    </a:solidFill>
+                  </a:tcPr>
+                </a:tc>
+                <a:tc>
+                  <a:txBody>
+                    <a:bodyPr/>
+                    <a:lstStyle/>
+                    <a:p>
+                      <a:pPr algn="r">
+                        <a:defRPr sz="1050">
+                          <a:solidFill>
+                            <a:srgbClr val="202428"/>
+                          </a:solidFill>
+                        </a:defRPr>
+                      </a:pPr>
+                      <a:r>
+                        <a:t>&lt;= 1e-3</a:t>
+                      </a:r>
+                    </a:p>
+                  </a:txBody>
+                  <a:tcPr marL="45720" marR="45720" marT="9144" marB="9144">
+                    <a:solidFill>
+                      <a:srgbClr val="FFFFFF"/>
+                    </a:solidFill>
+                  </a:tcPr>
+                </a:tc>
+                <a:tc>
+                  <a:txBody>
+                    <a:bodyPr/>
+                    <a:lstStyle/>
+                    <a:p>
+                      <a:pPr algn="r">
+                        <a:defRPr sz="1050">
+                          <a:solidFill>
+                            <a:srgbClr val="202428"/>
+                          </a:solidFill>
+                        </a:defRPr>
+                      </a:pPr>
+                      <a:r>
+                        <a:t>2.2e-05 pass</a:t>
+                      </a:r>
+                    </a:p>
+                  </a:txBody>
+                  <a:tcPr marL="45720" marR="45720" marT="9144" marB="9144">
+                    <a:solidFill>
+                      <a:srgbClr val="FFFFFF"/>
+                    </a:solidFill>
+                  </a:tcPr>
+                </a:tc>
+                <a:tc>
+                  <a:txBody>
+                    <a:bodyPr/>
+                    <a:lstStyle/>
+                    <a:p>
+                      <a:pPr algn="r">
+                        <a:defRPr sz="1050">
+                          <a:solidFill>
+                            <a:srgbClr val="202428"/>
+                          </a:solidFill>
+                        </a:defRPr>
+                      </a:pPr>
+                      <a:r>
+                        <a:t>1.7e-05 pass</a:t>
+                      </a:r>
+                    </a:p>
+                  </a:txBody>
+                  <a:tcPr marL="45720" marR="45720" marT="9144" marB="9144">
+                    <a:solidFill>
+                      <a:srgbClr val="FFFFFF"/>
+                    </a:solidFill>
+                  </a:tcPr>
+                </a:tc>
+                <a:tc>
+                  <a:txBody>
+                    <a:bodyPr/>
+                    <a:lstStyle/>
+                    <a:p>
+                      <a:pPr algn="r">
+                        <a:defRPr sz="1050">
+                          <a:solidFill>
+                            <a:srgbClr val="202428"/>
+                          </a:solidFill>
+                        </a:defRPr>
+                      </a:pPr>
+                      <a:r>
+                        <a:t>0.125 FAIL</a:t>
+                      </a:r>
+                    </a:p>
+                  </a:txBody>
+                  <a:tcPr marL="45720" marR="45720" marT="9144" marB="9144">
+                    <a:solidFill>
+                      <a:srgbClr val="FFFFFF"/>
+                    </a:solidFill>
+                  </a:tcPr>
+                </a:tc>
+              </a:tr>
+              <a:tr h="246888">
+                <a:tc>
+                  <a:txBody>
+                    <a:bodyPr/>
+                    <a:lstStyle/>
+                    <a:p>
+                      <a:pPr algn="l">
+                        <a:defRPr sz="1050">
+                          <a:solidFill>
+                            <a:srgbClr val="202428"/>
+                          </a:solidFill>
+                        </a:defRPr>
+                      </a:pPr>
+                      <a:r>
+                        <a:t>Q2 gm / gds vs element identity</a:t>
+                      </a:r>
+                    </a:p>
+                  </a:txBody>
+                  <a:tcPr marL="45720" marR="45720" marT="9144" marB="9144">
+                    <a:solidFill>
+                      <a:srgbClr val="FFFFFF"/>
+                    </a:solidFill>
+                  </a:tcPr>
+                </a:tc>
+                <a:tc>
+                  <a:txBody>
+                    <a:bodyPr/>
+                    <a:lstStyle/>
+                    <a:p>
+                      <a:pPr algn="r">
+                        <a:defRPr sz="1050">
+                          <a:solidFill>
+                            <a:srgbClr val="202428"/>
+                          </a:solidFill>
+                        </a:defRPr>
+                      </a:pPr>
+                      <a:r>
+                        <a:t>&lt;= 1e-3</a:t>
+                      </a:r>
+                    </a:p>
+                  </a:txBody>
+                  <a:tcPr marL="45720" marR="45720" marT="9144" marB="9144">
+                    <a:solidFill>
+                      <a:srgbClr val="FFFFFF"/>
+                    </a:solidFill>
+                  </a:tcPr>
+                </a:tc>
+                <a:tc>
+                  <a:txBody>
+                    <a:bodyPr/>
+                    <a:lstStyle/>
+                    <a:p>
+                      <a:pPr algn="r">
+                        <a:defRPr sz="1050">
+                          <a:solidFill>
+                            <a:srgbClr val="202428"/>
+                          </a:solidFill>
+                        </a:defRPr>
+                      </a:pPr>
+                      <a:r>
+                        <a:t>1.1e-05 pass</a:t>
+                      </a:r>
+                    </a:p>
+                  </a:txBody>
+                  <a:tcPr marL="45720" marR="45720" marT="9144" marB="9144">
+                    <a:solidFill>
+                      <a:srgbClr val="FFFFFF"/>
+                    </a:solidFill>
+                  </a:tcPr>
+                </a:tc>
+                <a:tc>
+                  <a:txBody>
+                    <a:bodyPr/>
+                    <a:lstStyle/>
+                    <a:p>
+                      <a:pPr algn="r">
+                        <a:defRPr sz="1050">
+                          <a:solidFill>
+                            <a:srgbClr val="202428"/>
+                          </a:solidFill>
+                        </a:defRPr>
+                      </a:pPr>
+                      <a:r>
+                        <a:t>1.2e-05 pass</a:t>
+                      </a:r>
+                    </a:p>
+                  </a:txBody>
+                  <a:tcPr marL="45720" marR="45720" marT="9144" marB="9144">
+                    <a:solidFill>
+                      <a:srgbClr val="FFFFFF"/>
+                    </a:solidFill>
+                  </a:tcPr>
+                </a:tc>
+                <a:tc>
+                  <a:txBody>
+                    <a:bodyPr/>
+                    <a:lstStyle/>
+                    <a:p>
+                      <a:pPr algn="r">
+                        <a:defRPr sz="1050">
+                          <a:solidFill>
+                            <a:srgbClr val="202428"/>
+                          </a:solidFill>
+                        </a:defRPr>
+                      </a:pPr>
+                      <a:r>
+                        <a:t>6.6e-03 FAIL</a:t>
+                      </a:r>
+                    </a:p>
+                  </a:txBody>
+                  <a:tcPr marL="45720" marR="45720" marT="9144" marB="9144">
+                    <a:solidFill>
+                      <a:srgbClr val="FFFFFF"/>
+                    </a:solidFill>
+                  </a:tcPr>
+                </a:tc>
+              </a:tr>
+              <a:tr h="246888">
+                <a:tc>
+                  <a:txBody>
+                    <a:bodyPr/>
+                    <a:lstStyle/>
+                    <a:p>
+                      <a:pPr algn="l">
+                        <a:defRPr sz="1050">
+                          <a:solidFill>
+                            <a:srgbClr val="202428"/>
+                          </a:solidFill>
+                        </a:defRPr>
+                      </a:pPr>
+                      <a:r>
+                        <a:t>Q2 capacitances</a:t>
+                      </a:r>
+                    </a:p>
+                  </a:txBody>
+                  <a:tcPr marL="45720" marR="45720" marT="9144" marB="9144">
+                    <a:solidFill>
+                      <a:srgbClr val="FFFFFF"/>
+                    </a:solidFill>
+                  </a:tcPr>
+                </a:tc>
+                <a:tc>
+                  <a:txBody>
+                    <a:bodyPr/>
+                    <a:lstStyle/>
+                    <a:p>
+                      <a:pPr algn="r">
+                        <a:defRPr sz="1050">
+                          <a:solidFill>
+                            <a:srgbClr val="202428"/>
+                          </a:solidFill>
+                        </a:defRPr>
+                      </a:pPr>
+                      <a:r>
+                        <a:t>&lt;= 1e-3</a:t>
+                      </a:r>
+                    </a:p>
+                  </a:txBody>
+                  <a:tcPr marL="45720" marR="45720" marT="9144" marB="9144">
+                    <a:solidFill>
+                      <a:srgbClr val="FFFFFF"/>
+                    </a:solidFill>
+                  </a:tcPr>
+                </a:tc>
+                <a:tc>
+                  <a:txBody>
+                    <a:bodyPr/>
+                    <a:lstStyle/>
+                    <a:p>
+                      <a:pPr algn="r">
+                        <a:defRPr sz="1050">
+                          <a:solidFill>
+                            <a:srgbClr val="202428"/>
+                          </a:solidFill>
+                        </a:defRPr>
+                      </a:pPr>
+                      <a:r>
+                        <a:t>3.3e-14 pass</a:t>
+                      </a:r>
+                    </a:p>
+                  </a:txBody>
+                  <a:tcPr marL="45720" marR="45720" marT="9144" marB="9144">
+                    <a:solidFill>
+                      <a:srgbClr val="FFFFFF"/>
+                    </a:solidFill>
+                  </a:tcPr>
+                </a:tc>
+                <a:tc>
+                  <a:txBody>
+                    <a:bodyPr/>
+                    <a:lstStyle/>
+                    <a:p>
+                      <a:pPr algn="r">
+                        <a:defRPr sz="1050">
+                          <a:solidFill>
+                            <a:srgbClr val="202428"/>
+                          </a:solidFill>
+                        </a:defRPr>
+                      </a:pPr>
+                      <a:r>
+                        <a:t>1.1e-12 pass</a:t>
+                      </a:r>
+                    </a:p>
+                  </a:txBody>
+                  <a:tcPr marL="45720" marR="45720" marT="9144" marB="9144">
+                    <a:solidFill>
+                      <a:srgbClr val="FFFFFF"/>
+                    </a:solidFill>
+                  </a:tcPr>
+                </a:tc>
+                <a:tc>
+                  <a:txBody>
+                    <a:bodyPr/>
+                    <a:lstStyle/>
+                    <a:p>
+                      <a:pPr algn="r">
+                        <a:defRPr sz="1050">
+                          <a:solidFill>
+                            <a:srgbClr val="202428"/>
+                          </a:solidFill>
+                        </a:defRPr>
+                      </a:pPr>
+                      <a:r>
+                        <a:t>1.0e-13 pass</a:t>
+                      </a:r>
+                    </a:p>
+                  </a:txBody>
+                  <a:tcPr marL="45720" marR="45720" marT="9144" marB="9144">
+                    <a:solidFill>
+                      <a:srgbClr val="FFFFFF"/>
+                    </a:solidFill>
+                  </a:tcPr>
+                </a:tc>
+              </a:tr>
+              <a:tr h="246888">
+                <a:tc>
+                  <a:txBody>
+                    <a:bodyPr/>
+                    <a:lstStyle/>
+                    <a:p>
+                      <a:pPr algn="l">
+                        <a:defRPr sz="1050">
+                          <a:solidFill>
+                            <a:srgbClr val="202428"/>
+                          </a:solidFill>
+                        </a:defRPr>
+                      </a:pPr>
+                      <a:r>
+                        <a:t>gm curves with a sign change (of 54)</a:t>
+                      </a:r>
+                    </a:p>
+                  </a:txBody>
+                  <a:tcPr marL="45720" marR="45720" marT="9144" marB="9144">
+                    <a:solidFill>
+                      <a:srgbClr val="FFFFFF"/>
+                    </a:solidFill>
+                  </a:tcPr>
+                </a:tc>
+                <a:tc>
+                  <a:txBody>
+                    <a:bodyPr/>
+                    <a:lstStyle/>
+                    <a:p>
+                      <a:pPr algn="r">
+                        <a:defRPr sz="1050">
+                          <a:solidFill>
+                            <a:srgbClr val="202428"/>
+                          </a:solidFill>
+                        </a:defRPr>
+                      </a:pPr>
+                      <a:r>
+                        <a:t>0</a:t>
+                      </a:r>
+                    </a:p>
+                  </a:txBody>
+                  <a:tcPr marL="45720" marR="45720" marT="9144" marB="9144">
+                    <a:solidFill>
+                      <a:srgbClr val="FFFFFF"/>
+                    </a:solidFill>
+                  </a:tcPr>
+                </a:tc>
+                <a:tc>
+                  <a:txBody>
+                    <a:bodyPr/>
+                    <a:lstStyle/>
+                    <a:p>
+                      <a:pPr algn="r">
+                        <a:defRPr sz="1050">
+                          <a:solidFill>
+                            <a:srgbClr val="202428"/>
+                          </a:solidFill>
+                        </a:defRPr>
+                      </a:pPr>
+                      <a:r>
+                        <a:t>0 pass</a:t>
+                      </a:r>
+                    </a:p>
+                  </a:txBody>
+                  <a:tcPr marL="45720" marR="45720" marT="9144" marB="9144">
+                    <a:solidFill>
+                      <a:srgbClr val="FFFFFF"/>
+                    </a:solidFill>
+                  </a:tcPr>
+                </a:tc>
+                <a:tc>
+                  <a:txBody>
+                    <a:bodyPr/>
+                    <a:lstStyle/>
+                    <a:p>
+                      <a:pPr algn="r">
+                        <a:defRPr sz="1050">
+                          <a:solidFill>
+                            <a:srgbClr val="202428"/>
+                          </a:solidFill>
+                        </a:defRPr>
+                      </a:pPr>
+                      <a:r>
+                        <a:t>0 pass</a:t>
+                      </a:r>
+                    </a:p>
+                  </a:txBody>
+                  <a:tcPr marL="45720" marR="45720" marT="9144" marB="9144">
+                    <a:solidFill>
+                      <a:srgbClr val="FFFFFF"/>
+                    </a:solidFill>
+                  </a:tcPr>
+                </a:tc>
+                <a:tc>
+                  <a:txBody>
+                    <a:bodyPr/>
+                    <a:lstStyle/>
+                    <a:p>
+                      <a:pPr algn="r">
+                        <a:defRPr sz="1050">
+                          <a:solidFill>
+                            <a:srgbClr val="202428"/>
+                          </a:solidFill>
+                        </a:defRPr>
+                      </a:pPr>
+                      <a:r>
+                        <a:t>1 FAIL</a:t>
+                      </a:r>
+                    </a:p>
+                  </a:txBody>
+                  <a:tcPr marL="45720" marR="45720" marT="9144" marB="9144">
+                    <a:solidFill>
+                      <a:srgbClr val="FFFFFF"/>
+                    </a:solidFill>
+                  </a:tcPr>
+                </a:tc>
+              </a:tr>
+              <a:tr h="246888">
+                <a:tc>
+                  <a:txBody>
+                    <a:bodyPr/>
+                    <a:lstStyle/>
+                    <a:p>
+                      <a:pPr algn="l">
+                        <a:defRPr sz="1050">
+                          <a:solidFill>
+                            <a:srgbClr val="202428"/>
+                          </a:solidFill>
+                        </a:defRPr>
+                      </a:pPr>
+                      <a:r>
+                        <a:t>circuits failing only with the element</a:t>
+                      </a:r>
+                    </a:p>
+                  </a:txBody>
+                  <a:tcPr marL="45720" marR="45720" marT="9144" marB="9144">
+                    <a:solidFill>
+                      <a:srgbClr val="FFFFFF"/>
+                    </a:solidFill>
+                  </a:tcPr>
+                </a:tc>
+                <a:tc>
+                  <a:txBody>
+                    <a:bodyPr/>
+                    <a:lstStyle/>
+                    <a:p>
+                      <a:pPr algn="r">
+                        <a:defRPr sz="1050">
+                          <a:solidFill>
+                            <a:srgbClr val="202428"/>
+                          </a:solidFill>
+                        </a:defRPr>
+                      </a:pPr>
+                      <a:r>
+                        <a:t>0</a:t>
+                      </a:r>
+                    </a:p>
+                  </a:txBody>
+                  <a:tcPr marL="45720" marR="45720" marT="9144" marB="9144">
+                    <a:solidFill>
+                      <a:srgbClr val="FFFFFF"/>
+                    </a:solidFill>
+                  </a:tcPr>
+                </a:tc>
+                <a:tc>
+                  <a:txBody>
+                    <a:bodyPr/>
+                    <a:lstStyle/>
+                    <a:p>
+                      <a:pPr algn="r">
+                        <a:defRPr sz="1050">
+                          <a:solidFill>
+                            <a:srgbClr val="202428"/>
+                          </a:solidFill>
+                        </a:defRPr>
+                      </a:pPr>
+                      <a:r>
+                        <a:t>0 pass</a:t>
+                      </a:r>
+                    </a:p>
+                  </a:txBody>
+                  <a:tcPr marL="45720" marR="45720" marT="9144" marB="9144">
+                    <a:solidFill>
+                      <a:srgbClr val="FFFFFF"/>
+                    </a:solidFill>
+                  </a:tcPr>
+                </a:tc>
+                <a:tc>
+                  <a:txBody>
+                    <a:bodyPr/>
+                    <a:lstStyle/>
+                    <a:p>
+                      <a:pPr algn="r">
+                        <a:defRPr sz="1050">
+                          <a:solidFill>
+                            <a:srgbClr val="202428"/>
+                          </a:solidFill>
+                        </a:defRPr>
+                      </a:pPr>
+                      <a:r>
+                        <a:t>0 pass</a:t>
+                      </a:r>
+                    </a:p>
+                  </a:txBody>
+                  <a:tcPr marL="45720" marR="45720" marT="9144" marB="9144">
+                    <a:solidFill>
+                      <a:srgbClr val="FFFFFF"/>
+                    </a:solidFill>
+                  </a:tcPr>
+                </a:tc>
+                <a:tc>
+                  <a:txBody>
+                    <a:bodyPr/>
+                    <a:lstStyle/>
+                    <a:p>
+                      <a:pPr algn="r">
+                        <a:defRPr sz="1050">
+                          <a:solidFill>
+                            <a:srgbClr val="202428"/>
+                          </a:solidFill>
+                        </a:defRPr>
+                      </a:pPr>
+                      <a:r>
+                        <a:t>0 pass</a:t>
+                      </a:r>
+                    </a:p>
+                  </a:txBody>
+                  <a:tcPr marL="45720" marR="45720" marT="9144" marB="9144">
+                    <a:solidFill>
+                      <a:srgbClr val="FFFFFF"/>
+                    </a:solidFill>
+                  </a:tcPr>
+                </a:tc>
+              </a:tr>
+              <a:tr h="246888">
+                <a:tc>
+                  <a:txBody>
+                    <a:bodyPr/>
+                    <a:lstStyle/>
+                    <a:p>
+                      <a:pPr algn="l">
+                        <a:defRPr sz="1050">
+                          <a:solidFill>
+                            <a:srgbClr val="202428"/>
+                          </a:solidFill>
+                        </a:defRPr>
+                      </a:pPr>
+                      <a:r>
+                        <a:t>default tolerance, relative (restriction)</a:t>
+                      </a:r>
+                    </a:p>
+                  </a:txBody>
+                  <a:tcPr marL="45720" marR="45720" marT="9144" marB="9144">
+                    <a:solidFill>
+                      <a:srgbClr val="FFFFFF"/>
+                    </a:solidFill>
+                  </a:tcPr>
+                </a:tc>
+                <a:tc>
+                  <a:txBody>
+                    <a:bodyPr/>
+                    <a:lstStyle/>
+                    <a:p>
+                      <a:pPr algn="r">
+                        <a:defRPr sz="1050">
+                          <a:solidFill>
+                            <a:srgbClr val="202428"/>
+                          </a:solidFill>
+                        </a:defRPr>
+                      </a:pPr>
+                      <a:r>
+                        <a:t>&lt;= 1e-3</a:t>
+                      </a:r>
+                    </a:p>
+                  </a:txBody>
+                  <a:tcPr marL="45720" marR="45720" marT="9144" marB="9144">
+                    <a:solidFill>
+                      <a:srgbClr val="FFFFFF"/>
+                    </a:solidFill>
+                  </a:tcPr>
+                </a:tc>
+                <a:tc>
+                  <a:txBody>
+                    <a:bodyPr/>
+                    <a:lstStyle/>
+                    <a:p>
+                      <a:pPr algn="r">
+                        <a:defRPr sz="1050">
+                          <a:solidFill>
+                            <a:srgbClr val="202428"/>
+                          </a:solidFill>
+                        </a:defRPr>
+                      </a:pPr>
+                      <a:r>
+                        <a:t>1.8e-03 restriction</a:t>
+                      </a:r>
+                    </a:p>
+                  </a:txBody>
+                  <a:tcPr marL="45720" marR="45720" marT="9144" marB="9144">
+                    <a:solidFill>
+                      <a:srgbClr val="FFFFFF"/>
+                    </a:solidFill>
+                  </a:tcPr>
+                </a:tc>
+                <a:tc>
+                  <a:txBody>
+                    <a:bodyPr/>
+                    <a:lstStyle/>
+                    <a:p>
+                      <a:pPr algn="r">
+                        <a:defRPr sz="1050">
+                          <a:solidFill>
+                            <a:srgbClr val="202428"/>
+                          </a:solidFill>
+                        </a:defRPr>
+                      </a:pPr>
+                      <a:r>
+                        <a:t>1.8e-03 restriction</a:t>
+                      </a:r>
+                    </a:p>
+                  </a:txBody>
+                  <a:tcPr marL="45720" marR="45720" marT="9144" marB="9144">
+                    <a:solidFill>
+                      <a:srgbClr val="FFFFFF"/>
+                    </a:solidFill>
+                  </a:tcPr>
+                </a:tc>
+                <a:tc>
+                  <a:txBody>
+                    <a:bodyPr/>
+                    <a:lstStyle/>
+                    <a:p>
+                      <a:pPr algn="r">
+                        <a:defRPr sz="1050">
+                          <a:solidFill>
+                            <a:srgbClr val="202428"/>
+                          </a:solidFill>
+                        </a:defRPr>
+                      </a:pPr>
+                      <a:r>
+                        <a:t>1.9e-03 restriction</a:t>
+                      </a:r>
+                    </a:p>
+                  </a:txBody>
+                  <a:tcPr marL="45720" marR="45720" marT="9144" marB="9144">
+                    <a:solidFill>
+                      <a:srgbClr val="FFFFFF"/>
+                    </a:solidFill>
+                  </a:tcPr>
+                </a:tc>
+              </a:tr>
+              <a:tr h="246888">
+                <a:tc>
+                  <a:txBody>
+                    <a:bodyPr/>
+                    <a:lstStyle/>
+                    <a:p>
+                      <a:pPr algn="l">
+                        <a:defRPr sz="1050">
+                          <a:solidFill>
+                            <a:srgbClr val="202428"/>
+                          </a:solidFill>
+                        </a:defRPr>
+                      </a:pPr>
+                      <a:r>
+                        <a:t>gds curves with a sign change, of 90 (restriction)</a:t>
+                      </a:r>
+                    </a:p>
+                  </a:txBody>
+                  <a:tcPr marL="45720" marR="45720" marT="9144" marB="9144">
+                    <a:solidFill>
+                      <a:srgbClr val="FFFFFF"/>
+                    </a:solidFill>
+                  </a:tcPr>
+                </a:tc>
+                <a:tc>
+                  <a:txBody>
+                    <a:bodyPr/>
+                    <a:lstStyle/>
+                    <a:p>
+                      <a:pPr algn="r">
+                        <a:defRPr sz="1050">
+                          <a:solidFill>
+                            <a:srgbClr val="202428"/>
+                          </a:solidFill>
+                        </a:defRPr>
+                      </a:pPr>
+                      <a:r>
+                        <a:t>0</a:t>
+                      </a:r>
+                    </a:p>
+                  </a:txBody>
+                  <a:tcPr marL="45720" marR="45720" marT="9144" marB="9144">
+                    <a:solidFill>
+                      <a:srgbClr val="FFFFFF"/>
+                    </a:solidFill>
+                  </a:tcPr>
+                </a:tc>
+                <a:tc>
+                  <a:txBody>
+                    <a:bodyPr/>
+                    <a:lstStyle/>
+                    <a:p>
+                      <a:pPr algn="r">
+                        <a:defRPr sz="1050">
+                          <a:solidFill>
+                            <a:srgbClr val="202428"/>
+                          </a:solidFill>
+                        </a:defRPr>
+                      </a:pPr>
+                      <a:r>
+                        <a:t>6 restriction</a:t>
+                      </a:r>
+                    </a:p>
+                  </a:txBody>
+                  <a:tcPr marL="45720" marR="45720" marT="9144" marB="9144">
+                    <a:solidFill>
+                      <a:srgbClr val="FFFFFF"/>
+                    </a:solidFill>
+                  </a:tcPr>
+                </a:tc>
+                <a:tc>
+                  <a:txBody>
+                    <a:bodyPr/>
+                    <a:lstStyle/>
+                    <a:p>
+                      <a:pPr algn="r">
+                        <a:defRPr sz="1050">
+                          <a:solidFill>
+                            <a:srgbClr val="202428"/>
+                          </a:solidFill>
+                        </a:defRPr>
+                      </a:pPr>
+                      <a:r>
+                        <a:t>2 restriction</a:t>
+                      </a:r>
+                    </a:p>
+                  </a:txBody>
+                  <a:tcPr marL="45720" marR="45720" marT="9144" marB="9144">
+                    <a:solidFill>
+                      <a:srgbClr val="FFFFFF"/>
+                    </a:solidFill>
+                  </a:tcPr>
+                </a:tc>
+                <a:tc>
+                  <a:txBody>
+                    <a:bodyPr/>
+                    <a:lstStyle/>
+                    <a:p>
+                      <a:pPr algn="r">
+                        <a:defRPr sz="1050">
+                          <a:solidFill>
+                            <a:srgbClr val="202428"/>
+                          </a:solidFill>
+                        </a:defRPr>
+                      </a:pPr>
+                      <a:r>
+                        <a:t>28 restriction</a:t>
+                      </a:r>
+                    </a:p>
+                  </a:txBody>
+                  <a:tcPr marL="45720" marR="45720" marT="9144" marB="9144">
+                    <a:solidFill>
+                      <a:srgbClr val="FFFFFF"/>
+                    </a:solidFill>
+                  </a:tcPr>
+                </a:tc>
+              </a:tr>
+              <a:tr h="246888">
+                <a:tc>
+                  <a:txBody>
+                    <a:bodyPr/>
+                    <a:lstStyle/>
+                    <a:p>
+                      <a:pPr algn="l">
+                        <a:defRPr sz="1050">
+                          <a:solidFill>
+                            <a:srgbClr val="202428"/>
+                          </a:solidFill>
+                        </a:defRPr>
+                      </a:pPr>
+                      <a:r>
+                        <a:t>wall-time ratio element / card (restriction)</a:t>
+                      </a:r>
+                    </a:p>
+                  </a:txBody>
+                  <a:tcPr marL="45720" marR="45720" marT="9144" marB="9144">
+                    <a:solidFill>
+                      <a:srgbClr val="FFFFFF"/>
+                    </a:solidFill>
+                  </a:tcPr>
+                </a:tc>
+                <a:tc>
+                  <a:txBody>
+                    <a:bodyPr/>
+                    <a:lstStyle/>
+                    <a:p>
+                      <a:pPr algn="r">
+                        <a:defRPr sz="1050">
+                          <a:solidFill>
+                            <a:srgbClr val="202428"/>
+                          </a:solidFill>
+                        </a:defRPr>
+                      </a:pPr>
+                      <a:r>
+                        <a:t>&lt;= 2</a:t>
+                      </a:r>
+                    </a:p>
+                  </a:txBody>
+                  <a:tcPr marL="45720" marR="45720" marT="9144" marB="9144">
+                    <a:solidFill>
+                      <a:srgbClr val="FFFFFF"/>
+                    </a:solidFill>
+                  </a:tcPr>
+                </a:tc>
+                <a:tc>
+                  <a:txBody>
+                    <a:bodyPr/>
+                    <a:lstStyle/>
+                    <a:p>
+                      <a:pPr algn="r">
+                        <a:defRPr sz="1050">
+                          <a:solidFill>
+                            <a:srgbClr val="202428"/>
+                          </a:solidFill>
+                        </a:defRPr>
+                      </a:pPr>
+                      <a:r>
+                        <a:t>4.56 restriction</a:t>
+                      </a:r>
+                    </a:p>
+                  </a:txBody>
+                  <a:tcPr marL="45720" marR="45720" marT="9144" marB="9144">
+                    <a:solidFill>
+                      <a:srgbClr val="FFFFFF"/>
+                    </a:solidFill>
+                  </a:tcPr>
+                </a:tc>
+                <a:tc>
+                  <a:txBody>
+                    <a:bodyPr/>
+                    <a:lstStyle/>
+                    <a:p>
+                      <a:pPr algn="r">
+                        <a:defRPr sz="1050">
+                          <a:solidFill>
+                            <a:srgbClr val="202428"/>
+                          </a:solidFill>
+                        </a:defRPr>
+                      </a:pPr>
+                      <a:r>
+                        <a:t>4.3 restriction</a:t>
+                      </a:r>
+                    </a:p>
+                  </a:txBody>
+                  <a:tcPr marL="45720" marR="45720" marT="9144" marB="9144">
+                    <a:solidFill>
+                      <a:srgbClr val="FFFFFF"/>
+                    </a:solidFill>
+                  </a:tcPr>
+                </a:tc>
+                <a:tc>
+                  <a:txBody>
+                    <a:bodyPr/>
+                    <a:lstStyle/>
+                    <a:p>
+                      <a:pPr algn="r">
+                        <a:defRPr sz="1050">
+                          <a:solidFill>
+                            <a:srgbClr val="202428"/>
+                          </a:solidFill>
+                        </a:defRPr>
+                      </a:pPr>
+                      <a:r>
+                        <a:t>4.29 restriction</a:t>
+                      </a:r>
+                    </a:p>
+                  </a:txBody>
+                  <a:tcPr marL="45720" marR="45720" marT="9144" marB="9144">
+                    <a:solidFill>
+                      <a:srgbClr val="FFFFFF"/>
+                    </a:solidFill>
+                  </a:tcPr>
+                </a:tc>
+              </a:tr>
+              <a:tr h="246888">
+                <a:tc>
+                  <a:txBody>
+                    <a:bodyPr/>
+                    <a:lstStyle/>
+                    <a:p>
+                      <a:pPr algn="l">
+                        <a:defRPr sz="1050">
+                          <a:solidFill>
+                            <a:srgbClr val="202428"/>
+                          </a:solidFill>
+                        </a:defRPr>
+                      </a:pPr>
+                      <a:r>
+                        <a:t>Label</a:t>
+                      </a:r>
+                    </a:p>
+                  </a:txBody>
+                  <a:tcPr marL="45720" marR="45720" marT="9144" marB="9144">
+                    <a:solidFill>
+                      <a:srgbClr val="FFFFFF"/>
+                    </a:solidFill>
+                  </a:tcPr>
+                </a:tc>
+                <a:tc>
+                  <a:txBody>
+                    <a:bodyPr/>
+                    <a:lstStyle/>
+                    <a:p>
+                      <a:pPr algn="r">
+                        <a:defRPr sz="1050">
+                          <a:solidFill>
+                            <a:srgbClr val="202428"/>
+                          </a:solidFill>
+                        </a:defRPr>
+                      </a:pPr>
+                    </a:p>
+                  </a:txBody>
+                  <a:tcPr marL="45720" marR="45720" marT="9144" marB="9144">
+                    <a:solidFill>
+                      <a:srgbClr val="FFFFFF"/>
+                    </a:solidFill>
+                  </a:tcPr>
+                </a:tc>
+                <a:tc>
+                  <a:txBody>
+                    <a:bodyPr/>
+                    <a:lstStyle/>
+                    <a:p>
+                      <a:pPr algn="r">
+                        <a:defRPr sz="1050">
+                          <a:solidFill>
+                            <a:srgbClr val="202428"/>
+                          </a:solidFill>
+                        </a:defRPr>
+                      </a:pPr>
+                      <a:r>
+                        <a:t>not deployable</a:t>
+                      </a:r>
+                    </a:p>
+                  </a:txBody>
+                  <a:tcPr marL="45720" marR="45720" marT="9144" marB="9144">
+                    <a:solidFill>
+                      <a:srgbClr val="FFFFFF"/>
+                    </a:solidFill>
+                  </a:tcPr>
+                </a:tc>
+                <a:tc>
+                  <a:txBody>
+                    <a:bodyPr/>
+                    <a:lstStyle/>
+                    <a:p>
+                      <a:pPr algn="r">
+                        <a:defRPr sz="1050">
+                          <a:solidFill>
+                            <a:srgbClr val="202428"/>
+                          </a:solidFill>
+                        </a:defRPr>
+                      </a:pPr>
+                      <a:r>
+                        <a:t>deployable with restrictions</a:t>
+                      </a:r>
+                    </a:p>
+                  </a:txBody>
+                  <a:tcPr marL="45720" marR="45720" marT="9144" marB="9144">
+                    <a:solidFill>
+                      <a:srgbClr val="FFFFFF"/>
+                    </a:solidFill>
+                  </a:tcPr>
+                </a:tc>
+                <a:tc>
+                  <a:txBody>
+                    <a:bodyPr/>
+                    <a:lstStyle/>
+                    <a:p>
+                      <a:pPr algn="r">
+                        <a:defRPr sz="1050">
+                          <a:solidFill>
+                            <a:srgbClr val="202428"/>
+                          </a:solidFill>
+                        </a:defRPr>
+                      </a:pPr>
+                      <a:r>
+                        <a:t>not deployable</a:t>
+                      </a:r>
+                    </a:p>
+                  </a:txBody>
+                  <a:tcPr marL="45720" marR="45720" marT="9144" marB="9144">
+                    <a:solidFill>
+                      <a:srgbClr val="FFFFFF"/>
+                    </a:solidFill>
+                  </a:tcPr>
+                </a:tc>
+              </a:tr>
+            </a:tbl>
+          </a:graphicData>
+        </a:graphic>
+      </p:graphicFrame>
+      <p:sp>
+        <p:nvSpPr>
+          <p:cNvPr id="4" name="TextBox 3"/>
+          <p:cNvSpPr txBox="1"/>
+          <p:nvPr/>
+        </p:nvSpPr>
+        <p:spPr>
+          <a:xfrm>
+            <a:off x="548640" y="4526280"/>
+            <a:ext cx="11064240" cy="2194560"/>
+          </a:xfrm>
+          <a:prstGeom prst="rect">
+            <a:avLst/>
+          </a:prstGeom>
+          <a:noFill/>
+        </p:spPr>
+        <p:txBody>
+          <a:bodyPr wrap="square">
+            <a:spAutoFit/>
+          </a:bodyPr>
+          <a:lstStyle/>
+          <a:p>
+            <a:pPr>
+              <a:spcAft>
+                <a:spcPts val="400"/>
+              </a:spcAft>
+            </a:pPr>
+            <a:r>
+              <a:rPr sz="1100">
+                <a:solidFill>
+                  <a:srgbClr val="202428"/>
+                </a:solidFill>
+              </a:rPr>
+              <a:t>Outcome (pre-registered rule): not deployable; label not deployable. Core failures: Q1 I_D at Vds = 0. Restrictions: default tolerance above 1e-3; gds sign changes introduced; runtime overhead &gt; 2x.</a:t>
+            </a:r>
+          </a:p>
+          <a:p>
+            <a:pPr>
+              <a:spcAft>
+                <a:spcPts val="400"/>
+              </a:spcAft>
+            </a:pPr>
+            <a:r>
+              <a:rPr sz="1100">
+                <a:solidFill>
+                  <a:srgbClr val="202428"/>
+                </a:solidFill>
+              </a:rPr>
+              <a:t>gds curves with an introduced sign change: 6 of 90 (pmos_L2_W5 (1), pmos_L8_W0p84 (2), pmos_L8_W1p6 (2), pmos_L8_W5 (1)). On these curves the element has 2439 points with dI/dV(d,s) &lt; 0, I_card exp(g) of the card sweep 2439, the card alone 0: the sign changes come from g. A gds sign change is a restriction, a gm sign change in strong inversion a core failure (I15-1).</a:t>
+            </a:r>
+          </a:p>
+          <a:p>
+            <a:pPr>
+              <a:spcAft>
+                <a:spcPts val="400"/>
+              </a:spcAft>
+            </a:pPr>
+            <a:r>
+              <a:rPr sz="1100">
+                <a:solidFill>
+                  <a:srgbClr val="202428"/>
+                </a:solidFill>
+              </a:rPr>
+              <a:t>Failed core check: |I(Vds = 0)| = 1.0006e-12 A at 1 of 2700 points (pmos_L8_W0p84, |Vgs| = 0.825 V, default tolerance, ngspice abstol 1e-12 A); card + replica run at that point 8e-24 A; tight-tolerance maximum 4.9e-17 A (post hoc diagnosis).</a:t>
+            </a:r>
+          </a:p>
+          <a:p>
+            <a:pPr>
+              <a:spcAft>
+                <a:spcPts val="400"/>
+              </a:spcAft>
+            </a:pPr>
+            <a:r>
+              <a:rPr sz="1100">
+                <a:solidFill>
+                  <a:srgbClr val="202428"/>
+                </a:solidFill>
+              </a:rPr>
+              <a:t>M2 card: 43-parameter card refit from the starting card with the full-data g in the loop. Q1 grids: V(g,s), V(d,s) in 25 mV steps, V(d,s) swept in serpentine order; tight: reltol 1e-9.</a:t>
+            </a:r>
+          </a:p>
+        </p:txBody>
+      </p:sp>
+    </p:spTree>
+  </p:cSld>
+  <p:clrMapOvr>
+    <a:masterClrMapping/>
+  </p:clrMapOvr>
+</p:sld>
+</file>
+
+<file path=ppt/slides/slide27.xml><?xml version="1.0" encoding="utf-8"?>
+<p:sld xmlns:a="http://schemas.openxmlformats.org/drawingml/2006/main" xmlns:p="http://schemas.openxmlformats.org/presentationml/2006/main" xmlns:r="http://schemas.openxmlformats.org/officeDocument/2006/relationships">
+  <p:cSld>
+    <p:spTree>
+      <p:nvGrpSpPr>
+        <p:cNvPr id="1" name=""/>
+        <p:cNvGrpSpPr/>
+        <p:nvPr/>
+      </p:nvGrpSpPr>
+      <p:grpSpPr/>
+      <p:sp>
+        <p:nvSpPr>
+          <p:cNvPr id="2" name="TextBox 1"/>
+          <p:cNvSpPr txBox="1"/>
+          <p:nvPr/>
+        </p:nvSpPr>
+        <p:spPr>
+          <a:xfrm>
+            <a:off x="457200" y="228600"/>
+            <a:ext cx="11247120" cy="640080"/>
+          </a:xfrm>
+          <a:prstGeom prst="rect">
+            <a:avLst/>
+          </a:prstGeom>
+          <a:noFill/>
+        </p:spPr>
+        <p:txBody>
+          <a:bodyPr wrap="none">
+            <a:spAutoFit/>
+          </a:bodyPr>
+          <a:lstStyle/>
+          <a:p>
+            <a:r>
+              <a:rPr sz="2400" b="1">
+                <a:solidFill>
+                  <a:srgbClr val="202428"/>
+                </a:solidFill>
+              </a:rPr>
               <a:t>Learned g, full model trained on all 18 devices</a:t>
             </a:r>
           </a:p>
@@ -17123,7 +20222,7 @@
 </p:sld>
 </file>
 
-<file path=ppt/slides/slide26.xml><?xml version="1.0" encoding="utf-8"?>
+<file path=ppt/slides/slide28.xml><?xml version="1.0" encoding="utf-8"?>
 <p:sld xmlns:a="http://schemas.openxmlformats.org/drawingml/2006/main" xmlns:p="http://schemas.openxmlformats.org/presentationml/2006/main" xmlns:r="http://schemas.openxmlformats.org/officeDocument/2006/relationships">
   <p:cSld>
     <p:spTree>
@@ -17236,232 +20335,6 @@
 </p:sld>
 </file>
 
-<file path=ppt/slides/slide27.xml><?xml version="1.0" encoding="utf-8"?>
-<p:sld xmlns:a="http://schemas.openxmlformats.org/drawingml/2006/main" xmlns:p="http://schemas.openxmlformats.org/presentationml/2006/main" xmlns:r="http://schemas.openxmlformats.org/officeDocument/2006/relationships">
-  <p:cSld>
-    <p:spTree>
-      <p:nvGrpSpPr>
-        <p:cNvPr id="1" name=""/>
-        <p:cNvGrpSpPr/>
-        <p:nvPr/>
-      </p:nvGrpSpPr>
-      <p:grpSpPr/>
-      <p:sp>
-        <p:nvSpPr>
-          <p:cNvPr id="2" name="TextBox 1"/>
-          <p:cNvSpPr txBox="1"/>
-          <p:nvPr/>
-        </p:nvSpPr>
-        <p:spPr>
-          <a:xfrm>
-            <a:off x="457200" y="228600"/>
-            <a:ext cx="11247120" cy="640080"/>
-          </a:xfrm>
-          <a:prstGeom prst="rect">
-            <a:avLst/>
-          </a:prstGeom>
-          <a:noFill/>
-        </p:spPr>
-        <p:txBody>
-          <a:bodyPr wrap="none">
-            <a:spAutoFit/>
-          </a:bodyPr>
-          <a:lstStyle/>
-          <a:p>
-            <a:r>
-              <a:rPr sz="2000" b="1">
-                <a:solidFill>
-                  <a:srgbClr val="202428"/>
-                </a:solidFill>
-              </a:rPr>
-              <a:t>nmos_L0p19_W7:  NMOS, L = 0.19 um, W = 7 um  (former TEST device)</a:t>
-            </a:r>
-          </a:p>
-        </p:txBody>
-      </p:sp>
-      <p:pic>
-        <p:nvPicPr>
-          <p:cNvPr id="3" name="Picture 2" descr="iv_nmos_L0p19_W7.png"/>
-          <p:cNvPicPr>
-            <a:picLocks noChangeAspect="1"/>
-          </p:cNvPicPr>
-          <p:nvPr/>
-        </p:nvPicPr>
-        <p:blipFill>
-          <a:blip r:embed="rId2"/>
-          <a:stretch>
-            <a:fillRect/>
-          </a:stretch>
-        </p:blipFill>
-        <p:spPr>
-          <a:xfrm>
-            <a:off x="365760" y="731520"/>
-            <a:ext cx="11430000" cy="3879272"/>
-          </a:xfrm>
-          <a:prstGeom prst="rect">
-            <a:avLst/>
-          </a:prstGeom>
-        </p:spPr>
-      </p:pic>
-      <p:sp>
-        <p:nvSpPr>
-          <p:cNvPr id="4" name="TextBox 3"/>
-          <p:cNvSpPr txBox="1"/>
-          <p:nvPr/>
-        </p:nvSpPr>
-        <p:spPr>
-          <a:xfrm>
-            <a:off x="548640" y="6172200"/>
-            <a:ext cx="11064240" cy="548640"/>
-          </a:xfrm>
-          <a:prstGeom prst="rect">
-            <a:avLst/>
-          </a:prstGeom>
-          <a:noFill/>
-        </p:spPr>
-        <p:txBody>
-          <a:bodyPr wrap="square">
-            <a:spAutoFit/>
-          </a:bodyPr>
-          <a:lstStyle/>
-          <a:p>
-            <a:pPr>
-              <a:spcAft>
-                <a:spcPts val="400"/>
-              </a:spcAft>
-            </a:pPr>
-            <a:r>
-              <a:rPr sz="1100">
-                <a:solidFill>
-                  <a:srgbClr val="202428"/>
-                </a:solidFill>
-              </a:rPr>
-              <a:t>Points: measured. Lines: NGSpice (ngspice-41). M_bias line: refit card with the fold Verilog-A g in the netlist (OSDI), g trained without this device. Faded: curves outside the frozen inclusion set (not scored). RRMS: strict paper metric for this device.</a:t>
-            </a:r>
-          </a:p>
-        </p:txBody>
-      </p:sp>
-    </p:spTree>
-  </p:cSld>
-  <p:clrMapOvr>
-    <a:masterClrMapping/>
-  </p:clrMapOvr>
-</p:sld>
-</file>
-
-<file path=ppt/slides/slide28.xml><?xml version="1.0" encoding="utf-8"?>
-<p:sld xmlns:a="http://schemas.openxmlformats.org/drawingml/2006/main" xmlns:p="http://schemas.openxmlformats.org/presentationml/2006/main" xmlns:r="http://schemas.openxmlformats.org/officeDocument/2006/relationships">
-  <p:cSld>
-    <p:spTree>
-      <p:nvGrpSpPr>
-        <p:cNvPr id="1" name=""/>
-        <p:cNvGrpSpPr/>
-        <p:nvPr/>
-      </p:nvGrpSpPr>
-      <p:grpSpPr/>
-      <p:sp>
-        <p:nvSpPr>
-          <p:cNvPr id="2" name="TextBox 1"/>
-          <p:cNvSpPr txBox="1"/>
-          <p:nvPr/>
-        </p:nvSpPr>
-        <p:spPr>
-          <a:xfrm>
-            <a:off x="457200" y="228600"/>
-            <a:ext cx="11247120" cy="640080"/>
-          </a:xfrm>
-          <a:prstGeom prst="rect">
-            <a:avLst/>
-          </a:prstGeom>
-          <a:noFill/>
-        </p:spPr>
-        <p:txBody>
-          <a:bodyPr wrap="none">
-            <a:spAutoFit/>
-          </a:bodyPr>
-          <a:lstStyle/>
-          <a:p>
-            <a:r>
-              <a:rPr sz="2000" b="1">
-                <a:solidFill>
-                  <a:srgbClr val="202428"/>
-                </a:solidFill>
-              </a:rPr>
-              <a:t>nmos_L0p25_W1p6:  NMOS, L = 0.25 um, W = 1.6 um</a:t>
-            </a:r>
-          </a:p>
-        </p:txBody>
-      </p:sp>
-      <p:pic>
-        <p:nvPicPr>
-          <p:cNvPr id="3" name="Picture 2" descr="iv_nmos_L0p25_W1p6.png"/>
-          <p:cNvPicPr>
-            <a:picLocks noChangeAspect="1"/>
-          </p:cNvPicPr>
-          <p:nvPr/>
-        </p:nvPicPr>
-        <p:blipFill>
-          <a:blip r:embed="rId2"/>
-          <a:stretch>
-            <a:fillRect/>
-          </a:stretch>
-        </p:blipFill>
-        <p:spPr>
-          <a:xfrm>
-            <a:off x="365760" y="731520"/>
-            <a:ext cx="11430000" cy="3879272"/>
-          </a:xfrm>
-          <a:prstGeom prst="rect">
-            <a:avLst/>
-          </a:prstGeom>
-        </p:spPr>
-      </p:pic>
-      <p:sp>
-        <p:nvSpPr>
-          <p:cNvPr id="4" name="TextBox 3"/>
-          <p:cNvSpPr txBox="1"/>
-          <p:nvPr/>
-        </p:nvSpPr>
-        <p:spPr>
-          <a:xfrm>
-            <a:off x="548640" y="6172200"/>
-            <a:ext cx="11064240" cy="548640"/>
-          </a:xfrm>
-          <a:prstGeom prst="rect">
-            <a:avLst/>
-          </a:prstGeom>
-          <a:noFill/>
-        </p:spPr>
-        <p:txBody>
-          <a:bodyPr wrap="square">
-            <a:spAutoFit/>
-          </a:bodyPr>
-          <a:lstStyle/>
-          <a:p>
-            <a:pPr>
-              <a:spcAft>
-                <a:spcPts val="400"/>
-              </a:spcAft>
-            </a:pPr>
-            <a:r>
-              <a:rPr sz="1100">
-                <a:solidFill>
-                  <a:srgbClr val="202428"/>
-                </a:solidFill>
-              </a:rPr>
-              <a:t>Points: measured. Lines: NGSpice (ngspice-41). M_bias line: refit card with the fold Verilog-A g in the netlist (OSDI), g trained without this device. Faded: curves outside the frozen inclusion set (not scored). RRMS: strict paper metric for this device.</a:t>
-            </a:r>
-          </a:p>
-        </p:txBody>
-      </p:sp>
-    </p:spTree>
-  </p:cSld>
-  <p:clrMapOvr>
-    <a:masterClrMapping/>
-  </p:clrMapOvr>
-</p:sld>
-</file>
-
 <file path=ppt/slides/slide29.xml><?xml version="1.0" encoding="utf-8"?>
 <p:sld xmlns:a="http://schemas.openxmlformats.org/drawingml/2006/main" xmlns:p="http://schemas.openxmlformats.org/presentationml/2006/main" xmlns:r="http://schemas.openxmlformats.org/officeDocument/2006/relationships">
   <p:cSld>
@@ -17500,14 +20373,14 @@
                   <a:srgbClr val="202428"/>
                 </a:solidFill>
               </a:rPr>
-              <a:t>nmos_L100_W100:  NMOS, L = 100 um, W = 100 um</a:t>
+              <a:t>nmos_L0p19_W7:  NMOS, L = 0.19 um, W = 7 um  (former TEST device)</a:t>
             </a:r>
           </a:p>
         </p:txBody>
       </p:sp>
       <p:pic>
         <p:nvPicPr>
-          <p:cNvPr id="3" name="Picture 2" descr="iv_nmos_L100_W100.png"/>
+          <p:cNvPr id="3" name="Picture 2" descr="iv_nmos_L0p19_W7.png"/>
           <p:cNvPicPr>
             <a:picLocks noChangeAspect="1"/>
           </p:cNvPicPr>
@@ -18409,6 +21282,232 @@
                   <a:srgbClr val="202428"/>
                 </a:solidFill>
               </a:rPr>
+              <a:t>nmos_L0p25_W1p6:  NMOS, L = 0.25 um, W = 1.6 um</a:t>
+            </a:r>
+          </a:p>
+        </p:txBody>
+      </p:sp>
+      <p:pic>
+        <p:nvPicPr>
+          <p:cNvPr id="3" name="Picture 2" descr="iv_nmos_L0p25_W1p6.png"/>
+          <p:cNvPicPr>
+            <a:picLocks noChangeAspect="1"/>
+          </p:cNvPicPr>
+          <p:nvPr/>
+        </p:nvPicPr>
+        <p:blipFill>
+          <a:blip r:embed="rId2"/>
+          <a:stretch>
+            <a:fillRect/>
+          </a:stretch>
+        </p:blipFill>
+        <p:spPr>
+          <a:xfrm>
+            <a:off x="365760" y="731520"/>
+            <a:ext cx="11430000" cy="3879272"/>
+          </a:xfrm>
+          <a:prstGeom prst="rect">
+            <a:avLst/>
+          </a:prstGeom>
+        </p:spPr>
+      </p:pic>
+      <p:sp>
+        <p:nvSpPr>
+          <p:cNvPr id="4" name="TextBox 3"/>
+          <p:cNvSpPr txBox="1"/>
+          <p:nvPr/>
+        </p:nvSpPr>
+        <p:spPr>
+          <a:xfrm>
+            <a:off x="548640" y="6172200"/>
+            <a:ext cx="11064240" cy="548640"/>
+          </a:xfrm>
+          <a:prstGeom prst="rect">
+            <a:avLst/>
+          </a:prstGeom>
+          <a:noFill/>
+        </p:spPr>
+        <p:txBody>
+          <a:bodyPr wrap="square">
+            <a:spAutoFit/>
+          </a:bodyPr>
+          <a:lstStyle/>
+          <a:p>
+            <a:pPr>
+              <a:spcAft>
+                <a:spcPts val="400"/>
+              </a:spcAft>
+            </a:pPr>
+            <a:r>
+              <a:rPr sz="1100">
+                <a:solidFill>
+                  <a:srgbClr val="202428"/>
+                </a:solidFill>
+              </a:rPr>
+              <a:t>Points: measured. Lines: NGSpice (ngspice-41). M_bias line: refit card with the fold Verilog-A g in the netlist (OSDI), g trained without this device. Faded: curves outside the frozen inclusion set (not scored). RRMS: strict paper metric for this device.</a:t>
+            </a:r>
+          </a:p>
+        </p:txBody>
+      </p:sp>
+    </p:spTree>
+  </p:cSld>
+  <p:clrMapOvr>
+    <a:masterClrMapping/>
+  </p:clrMapOvr>
+</p:sld>
+</file>
+
+<file path=ppt/slides/slide31.xml><?xml version="1.0" encoding="utf-8"?>
+<p:sld xmlns:a="http://schemas.openxmlformats.org/drawingml/2006/main" xmlns:p="http://schemas.openxmlformats.org/presentationml/2006/main" xmlns:r="http://schemas.openxmlformats.org/officeDocument/2006/relationships">
+  <p:cSld>
+    <p:spTree>
+      <p:nvGrpSpPr>
+        <p:cNvPr id="1" name=""/>
+        <p:cNvGrpSpPr/>
+        <p:nvPr/>
+      </p:nvGrpSpPr>
+      <p:grpSpPr/>
+      <p:sp>
+        <p:nvSpPr>
+          <p:cNvPr id="2" name="TextBox 1"/>
+          <p:cNvSpPr txBox="1"/>
+          <p:nvPr/>
+        </p:nvSpPr>
+        <p:spPr>
+          <a:xfrm>
+            <a:off x="457200" y="228600"/>
+            <a:ext cx="11247120" cy="640080"/>
+          </a:xfrm>
+          <a:prstGeom prst="rect">
+            <a:avLst/>
+          </a:prstGeom>
+          <a:noFill/>
+        </p:spPr>
+        <p:txBody>
+          <a:bodyPr wrap="none">
+            <a:spAutoFit/>
+          </a:bodyPr>
+          <a:lstStyle/>
+          <a:p>
+            <a:r>
+              <a:rPr sz="2000" b="1">
+                <a:solidFill>
+                  <a:srgbClr val="202428"/>
+                </a:solidFill>
+              </a:rPr>
+              <a:t>nmos_L100_W100:  NMOS, L = 100 um, W = 100 um</a:t>
+            </a:r>
+          </a:p>
+        </p:txBody>
+      </p:sp>
+      <p:pic>
+        <p:nvPicPr>
+          <p:cNvPr id="3" name="Picture 2" descr="iv_nmos_L100_W100.png"/>
+          <p:cNvPicPr>
+            <a:picLocks noChangeAspect="1"/>
+          </p:cNvPicPr>
+          <p:nvPr/>
+        </p:nvPicPr>
+        <p:blipFill>
+          <a:blip r:embed="rId2"/>
+          <a:stretch>
+            <a:fillRect/>
+          </a:stretch>
+        </p:blipFill>
+        <p:spPr>
+          <a:xfrm>
+            <a:off x="365760" y="731520"/>
+            <a:ext cx="11430000" cy="3879272"/>
+          </a:xfrm>
+          <a:prstGeom prst="rect">
+            <a:avLst/>
+          </a:prstGeom>
+        </p:spPr>
+      </p:pic>
+      <p:sp>
+        <p:nvSpPr>
+          <p:cNvPr id="4" name="TextBox 3"/>
+          <p:cNvSpPr txBox="1"/>
+          <p:nvPr/>
+        </p:nvSpPr>
+        <p:spPr>
+          <a:xfrm>
+            <a:off x="548640" y="6172200"/>
+            <a:ext cx="11064240" cy="548640"/>
+          </a:xfrm>
+          <a:prstGeom prst="rect">
+            <a:avLst/>
+          </a:prstGeom>
+          <a:noFill/>
+        </p:spPr>
+        <p:txBody>
+          <a:bodyPr wrap="square">
+            <a:spAutoFit/>
+          </a:bodyPr>
+          <a:lstStyle/>
+          <a:p>
+            <a:pPr>
+              <a:spcAft>
+                <a:spcPts val="400"/>
+              </a:spcAft>
+            </a:pPr>
+            <a:r>
+              <a:rPr sz="1100">
+                <a:solidFill>
+                  <a:srgbClr val="202428"/>
+                </a:solidFill>
+              </a:rPr>
+              <a:t>Points: measured. Lines: NGSpice (ngspice-41). M_bias line: refit card with the fold Verilog-A g in the netlist (OSDI), g trained without this device. Faded: curves outside the frozen inclusion set (not scored). RRMS: strict paper metric for this device.</a:t>
+            </a:r>
+          </a:p>
+        </p:txBody>
+      </p:sp>
+    </p:spTree>
+  </p:cSld>
+  <p:clrMapOvr>
+    <a:masterClrMapping/>
+  </p:clrMapOvr>
+</p:sld>
+</file>
+
+<file path=ppt/slides/slide32.xml><?xml version="1.0" encoding="utf-8"?>
+<p:sld xmlns:a="http://schemas.openxmlformats.org/drawingml/2006/main" xmlns:p="http://schemas.openxmlformats.org/presentationml/2006/main" xmlns:r="http://schemas.openxmlformats.org/officeDocument/2006/relationships">
+  <p:cSld>
+    <p:spTree>
+      <p:nvGrpSpPr>
+        <p:cNvPr id="1" name=""/>
+        <p:cNvGrpSpPr/>
+        <p:nvPr/>
+      </p:nvGrpSpPr>
+      <p:grpSpPr/>
+      <p:sp>
+        <p:nvSpPr>
+          <p:cNvPr id="2" name="TextBox 1"/>
+          <p:cNvSpPr txBox="1"/>
+          <p:nvPr/>
+        </p:nvSpPr>
+        <p:spPr>
+          <a:xfrm>
+            <a:off x="457200" y="228600"/>
+            <a:ext cx="11247120" cy="640080"/>
+          </a:xfrm>
+          <a:prstGeom prst="rect">
+            <a:avLst/>
+          </a:prstGeom>
+          <a:noFill/>
+        </p:spPr>
+        <p:txBody>
+          <a:bodyPr wrap="none">
+            <a:spAutoFit/>
+          </a:bodyPr>
+          <a:lstStyle/>
+          <a:p>
+            <a:r>
+              <a:rPr sz="2000" b="1">
+                <a:solidFill>
+                  <a:srgbClr val="202428"/>
+                </a:solidFill>
+              </a:rPr>
               <a:t>nmos_L1_W1p6:  NMOS, L = 1 um, W = 1.6 um  (former TEST device)</a:t>
             </a:r>
           </a:p>
@@ -18484,7 +21583,7 @@
 </p:sld>
 </file>
 
-<file path=ppt/slides/slide31.xml><?xml version="1.0" encoding="utf-8"?>
+<file path=ppt/slides/slide33.xml><?xml version="1.0" encoding="utf-8"?>
 <p:sld xmlns:a="http://schemas.openxmlformats.org/drawingml/2006/main" xmlns:p="http://schemas.openxmlformats.org/presentationml/2006/main" xmlns:r="http://schemas.openxmlformats.org/officeDocument/2006/relationships">
   <p:cSld>
     <p:spTree>
@@ -18597,7 +21696,7 @@
 </p:sld>
 </file>
 
-<file path=ppt/slides/slide32.xml><?xml version="1.0" encoding="utf-8"?>
+<file path=ppt/slides/slide34.xml><?xml version="1.0" encoding="utf-8"?>
 <p:sld xmlns:a="http://schemas.openxmlformats.org/drawingml/2006/main" xmlns:p="http://schemas.openxmlformats.org/presentationml/2006/main" xmlns:r="http://schemas.openxmlformats.org/officeDocument/2006/relationships">
   <p:cSld>
     <p:spTree>
@@ -18710,7 +21809,7 @@
 </p:sld>
 </file>
 
-<file path=ppt/slides/slide33.xml><?xml version="1.0" encoding="utf-8"?>
+<file path=ppt/slides/slide35.xml><?xml version="1.0" encoding="utf-8"?>
 <p:sld xmlns:a="http://schemas.openxmlformats.org/drawingml/2006/main" xmlns:p="http://schemas.openxmlformats.org/presentationml/2006/main" xmlns:r="http://schemas.openxmlformats.org/officeDocument/2006/relationships">
   <p:cSld>
     <p:spTree>
@@ -18823,7 +21922,7 @@
 </p:sld>
 </file>
 
-<file path=ppt/slides/slide34.xml><?xml version="1.0" encoding="utf-8"?>
+<file path=ppt/slides/slide36.xml><?xml version="1.0" encoding="utf-8"?>
 <p:sld xmlns:a="http://schemas.openxmlformats.org/drawingml/2006/main" xmlns:p="http://schemas.openxmlformats.org/presentationml/2006/main" xmlns:r="http://schemas.openxmlformats.org/officeDocument/2006/relationships">
   <p:cSld>
     <p:spTree>
@@ -18936,7 +22035,7 @@
 </p:sld>
 </file>
 
-<file path=ppt/slides/slide35.xml><?xml version="1.0" encoding="utf-8"?>
+<file path=ppt/slides/slide37.xml><?xml version="1.0" encoding="utf-8"?>
 <p:sld xmlns:a="http://schemas.openxmlformats.org/drawingml/2006/main" xmlns:p="http://schemas.openxmlformats.org/presentationml/2006/main" xmlns:r="http://schemas.openxmlformats.org/officeDocument/2006/relationships">
   <p:cSld>
     <p:spTree>
@@ -19049,7 +22148,7 @@
 </p:sld>
 </file>
 
-<file path=ppt/slides/slide36.xml><?xml version="1.0" encoding="utf-8"?>
+<file path=ppt/slides/slide38.xml><?xml version="1.0" encoding="utf-8"?>
 <p:sld xmlns:a="http://schemas.openxmlformats.org/drawingml/2006/main" xmlns:p="http://schemas.openxmlformats.org/presentationml/2006/main" xmlns:r="http://schemas.openxmlformats.org/officeDocument/2006/relationships">
   <p:cSld>
     <p:spTree>
@@ -19162,232 +22261,6 @@
 </p:sld>
 </file>
 
-<file path=ppt/slides/slide37.xml><?xml version="1.0" encoding="utf-8"?>
-<p:sld xmlns:a="http://schemas.openxmlformats.org/drawingml/2006/main" xmlns:p="http://schemas.openxmlformats.org/presentationml/2006/main" xmlns:r="http://schemas.openxmlformats.org/officeDocument/2006/relationships">
-  <p:cSld>
-    <p:spTree>
-      <p:nvGrpSpPr>
-        <p:cNvPr id="1" name=""/>
-        <p:cNvGrpSpPr/>
-        <p:nvPr/>
-      </p:nvGrpSpPr>
-      <p:grpSpPr/>
-      <p:sp>
-        <p:nvSpPr>
-          <p:cNvPr id="2" name="TextBox 1"/>
-          <p:cNvSpPr txBox="1"/>
-          <p:nvPr/>
-        </p:nvSpPr>
-        <p:spPr>
-          <a:xfrm>
-            <a:off x="457200" y="228600"/>
-            <a:ext cx="11247120" cy="640080"/>
-          </a:xfrm>
-          <a:prstGeom prst="rect">
-            <a:avLst/>
-          </a:prstGeom>
-          <a:noFill/>
-        </p:spPr>
-        <p:txBody>
-          <a:bodyPr wrap="none">
-            <a:spAutoFit/>
-          </a:bodyPr>
-          <a:lstStyle/>
-          <a:p>
-            <a:r>
-              <a:rPr sz="2000" b="1">
-                <a:solidFill>
-                  <a:srgbClr val="202428"/>
-                </a:solidFill>
-              </a:rPr>
-              <a:t>pmos_L0p5_W0p42:  PMOS, L = 0.5 um, W = 0.42 um</a:t>
-            </a:r>
-          </a:p>
-        </p:txBody>
-      </p:sp>
-      <p:pic>
-        <p:nvPicPr>
-          <p:cNvPr id="3" name="Picture 2" descr="iv_pmos_L0p5_W0p42.png"/>
-          <p:cNvPicPr>
-            <a:picLocks noChangeAspect="1"/>
-          </p:cNvPicPr>
-          <p:nvPr/>
-        </p:nvPicPr>
-        <p:blipFill>
-          <a:blip r:embed="rId2"/>
-          <a:stretch>
-            <a:fillRect/>
-          </a:stretch>
-        </p:blipFill>
-        <p:spPr>
-          <a:xfrm>
-            <a:off x="365760" y="731520"/>
-            <a:ext cx="11430000" cy="3879272"/>
-          </a:xfrm>
-          <a:prstGeom prst="rect">
-            <a:avLst/>
-          </a:prstGeom>
-        </p:spPr>
-      </p:pic>
-      <p:sp>
-        <p:nvSpPr>
-          <p:cNvPr id="4" name="TextBox 3"/>
-          <p:cNvSpPr txBox="1"/>
-          <p:nvPr/>
-        </p:nvSpPr>
-        <p:spPr>
-          <a:xfrm>
-            <a:off x="548640" y="6172200"/>
-            <a:ext cx="11064240" cy="548640"/>
-          </a:xfrm>
-          <a:prstGeom prst="rect">
-            <a:avLst/>
-          </a:prstGeom>
-          <a:noFill/>
-        </p:spPr>
-        <p:txBody>
-          <a:bodyPr wrap="square">
-            <a:spAutoFit/>
-          </a:bodyPr>
-          <a:lstStyle/>
-          <a:p>
-            <a:pPr>
-              <a:spcAft>
-                <a:spcPts val="400"/>
-              </a:spcAft>
-            </a:pPr>
-            <a:r>
-              <a:rPr sz="1100">
-                <a:solidFill>
-                  <a:srgbClr val="202428"/>
-                </a:solidFill>
-              </a:rPr>
-              <a:t>Points: measured. Lines: NGSpice (ngspice-41). M_bias line: refit card with the fold Verilog-A g in the netlist (OSDI), g trained without this device. Faded: curves outside the frozen inclusion set (not scored). RRMS: strict paper metric for this device.</a:t>
-            </a:r>
-          </a:p>
-        </p:txBody>
-      </p:sp>
-    </p:spTree>
-  </p:cSld>
-  <p:clrMapOvr>
-    <a:masterClrMapping/>
-  </p:clrMapOvr>
-</p:sld>
-</file>
-
-<file path=ppt/slides/slide38.xml><?xml version="1.0" encoding="utf-8"?>
-<p:sld xmlns:a="http://schemas.openxmlformats.org/drawingml/2006/main" xmlns:p="http://schemas.openxmlformats.org/presentationml/2006/main" xmlns:r="http://schemas.openxmlformats.org/officeDocument/2006/relationships">
-  <p:cSld>
-    <p:spTree>
-      <p:nvGrpSpPr>
-        <p:cNvPr id="1" name=""/>
-        <p:cNvGrpSpPr/>
-        <p:nvPr/>
-      </p:nvGrpSpPr>
-      <p:grpSpPr/>
-      <p:sp>
-        <p:nvSpPr>
-          <p:cNvPr id="2" name="TextBox 1"/>
-          <p:cNvSpPr txBox="1"/>
-          <p:nvPr/>
-        </p:nvSpPr>
-        <p:spPr>
-          <a:xfrm>
-            <a:off x="457200" y="228600"/>
-            <a:ext cx="11247120" cy="640080"/>
-          </a:xfrm>
-          <a:prstGeom prst="rect">
-            <a:avLst/>
-          </a:prstGeom>
-          <a:noFill/>
-        </p:spPr>
-        <p:txBody>
-          <a:bodyPr wrap="none">
-            <a:spAutoFit/>
-          </a:bodyPr>
-          <a:lstStyle/>
-          <a:p>
-            <a:r>
-              <a:rPr sz="2000" b="1">
-                <a:solidFill>
-                  <a:srgbClr val="202428"/>
-                </a:solidFill>
-              </a:rPr>
-              <a:t>pmos_L0p5_W0p64:  PMOS, L = 0.5 um, W = 0.64 um  (former TEST device)</a:t>
-            </a:r>
-          </a:p>
-        </p:txBody>
-      </p:sp>
-      <p:pic>
-        <p:nvPicPr>
-          <p:cNvPr id="3" name="Picture 2" descr="iv_pmos_L0p5_W0p64.png"/>
-          <p:cNvPicPr>
-            <a:picLocks noChangeAspect="1"/>
-          </p:cNvPicPr>
-          <p:nvPr/>
-        </p:nvPicPr>
-        <p:blipFill>
-          <a:blip r:embed="rId2"/>
-          <a:stretch>
-            <a:fillRect/>
-          </a:stretch>
-        </p:blipFill>
-        <p:spPr>
-          <a:xfrm>
-            <a:off x="365760" y="731520"/>
-            <a:ext cx="11430000" cy="3879272"/>
-          </a:xfrm>
-          <a:prstGeom prst="rect">
-            <a:avLst/>
-          </a:prstGeom>
-        </p:spPr>
-      </p:pic>
-      <p:sp>
-        <p:nvSpPr>
-          <p:cNvPr id="4" name="TextBox 3"/>
-          <p:cNvSpPr txBox="1"/>
-          <p:nvPr/>
-        </p:nvSpPr>
-        <p:spPr>
-          <a:xfrm>
-            <a:off x="548640" y="6172200"/>
-            <a:ext cx="11064240" cy="548640"/>
-          </a:xfrm>
-          <a:prstGeom prst="rect">
-            <a:avLst/>
-          </a:prstGeom>
-          <a:noFill/>
-        </p:spPr>
-        <p:txBody>
-          <a:bodyPr wrap="square">
-            <a:spAutoFit/>
-          </a:bodyPr>
-          <a:lstStyle/>
-          <a:p>
-            <a:pPr>
-              <a:spcAft>
-                <a:spcPts val="400"/>
-              </a:spcAft>
-            </a:pPr>
-            <a:r>
-              <a:rPr sz="1100">
-                <a:solidFill>
-                  <a:srgbClr val="202428"/>
-                </a:solidFill>
-              </a:rPr>
-              <a:t>Points: measured. Lines: NGSpice (ngspice-41). M_bias line: refit card with the fold Verilog-A g in the netlist (OSDI), g trained without this device. Faded: curves outside the frozen inclusion set (not scored). RRMS: strict paper metric for this device.</a:t>
-            </a:r>
-          </a:p>
-        </p:txBody>
-      </p:sp>
-    </p:spTree>
-  </p:cSld>
-  <p:clrMapOvr>
-    <a:masterClrMapping/>
-  </p:clrMapOvr>
-</p:sld>
-</file>
-
 <file path=ppt/slides/slide39.xml><?xml version="1.0" encoding="utf-8"?>
 <p:sld xmlns:a="http://schemas.openxmlformats.org/drawingml/2006/main" xmlns:p="http://schemas.openxmlformats.org/presentationml/2006/main" xmlns:r="http://schemas.openxmlformats.org/officeDocument/2006/relationships">
   <p:cSld>
@@ -19426,14 +22299,14 @@
                   <a:srgbClr val="202428"/>
                 </a:solidFill>
               </a:rPr>
-              <a:t>pmos_L2_W5:  PMOS, L = 2 um, W = 5 um</a:t>
+              <a:t>pmos_L0p5_W0p42:  PMOS, L = 0.5 um, W = 0.42 um</a:t>
             </a:r>
           </a:p>
         </p:txBody>
       </p:sp>
       <p:pic>
         <p:nvPicPr>
-          <p:cNvPr id="3" name="Picture 2" descr="iv_pmos_L2_W5.png"/>
+          <p:cNvPr id="3" name="Picture 2" descr="iv_pmos_L0p5_W0p42.png"/>
           <p:cNvPicPr>
             <a:picLocks noChangeAspect="1"/>
           </p:cNvPicPr>
@@ -19768,6 +22641,232 @@
                   <a:srgbClr val="202428"/>
                 </a:solidFill>
               </a:rPr>
+              <a:t>pmos_L0p5_W0p64:  PMOS, L = 0.5 um, W = 0.64 um  (former TEST device)</a:t>
+            </a:r>
+          </a:p>
+        </p:txBody>
+      </p:sp>
+      <p:pic>
+        <p:nvPicPr>
+          <p:cNvPr id="3" name="Picture 2" descr="iv_pmos_L0p5_W0p64.png"/>
+          <p:cNvPicPr>
+            <a:picLocks noChangeAspect="1"/>
+          </p:cNvPicPr>
+          <p:nvPr/>
+        </p:nvPicPr>
+        <p:blipFill>
+          <a:blip r:embed="rId2"/>
+          <a:stretch>
+            <a:fillRect/>
+          </a:stretch>
+        </p:blipFill>
+        <p:spPr>
+          <a:xfrm>
+            <a:off x="365760" y="731520"/>
+            <a:ext cx="11430000" cy="3879272"/>
+          </a:xfrm>
+          <a:prstGeom prst="rect">
+            <a:avLst/>
+          </a:prstGeom>
+        </p:spPr>
+      </p:pic>
+      <p:sp>
+        <p:nvSpPr>
+          <p:cNvPr id="4" name="TextBox 3"/>
+          <p:cNvSpPr txBox="1"/>
+          <p:nvPr/>
+        </p:nvSpPr>
+        <p:spPr>
+          <a:xfrm>
+            <a:off x="548640" y="6172200"/>
+            <a:ext cx="11064240" cy="548640"/>
+          </a:xfrm>
+          <a:prstGeom prst="rect">
+            <a:avLst/>
+          </a:prstGeom>
+          <a:noFill/>
+        </p:spPr>
+        <p:txBody>
+          <a:bodyPr wrap="square">
+            <a:spAutoFit/>
+          </a:bodyPr>
+          <a:lstStyle/>
+          <a:p>
+            <a:pPr>
+              <a:spcAft>
+                <a:spcPts val="400"/>
+              </a:spcAft>
+            </a:pPr>
+            <a:r>
+              <a:rPr sz="1100">
+                <a:solidFill>
+                  <a:srgbClr val="202428"/>
+                </a:solidFill>
+              </a:rPr>
+              <a:t>Points: measured. Lines: NGSpice (ngspice-41). M_bias line: refit card with the fold Verilog-A g in the netlist (OSDI), g trained without this device. Faded: curves outside the frozen inclusion set (not scored). RRMS: strict paper metric for this device.</a:t>
+            </a:r>
+          </a:p>
+        </p:txBody>
+      </p:sp>
+    </p:spTree>
+  </p:cSld>
+  <p:clrMapOvr>
+    <a:masterClrMapping/>
+  </p:clrMapOvr>
+</p:sld>
+</file>
+
+<file path=ppt/slides/slide41.xml><?xml version="1.0" encoding="utf-8"?>
+<p:sld xmlns:a="http://schemas.openxmlformats.org/drawingml/2006/main" xmlns:p="http://schemas.openxmlformats.org/presentationml/2006/main" xmlns:r="http://schemas.openxmlformats.org/officeDocument/2006/relationships">
+  <p:cSld>
+    <p:spTree>
+      <p:nvGrpSpPr>
+        <p:cNvPr id="1" name=""/>
+        <p:cNvGrpSpPr/>
+        <p:nvPr/>
+      </p:nvGrpSpPr>
+      <p:grpSpPr/>
+      <p:sp>
+        <p:nvSpPr>
+          <p:cNvPr id="2" name="TextBox 1"/>
+          <p:cNvSpPr txBox="1"/>
+          <p:nvPr/>
+        </p:nvSpPr>
+        <p:spPr>
+          <a:xfrm>
+            <a:off x="457200" y="228600"/>
+            <a:ext cx="11247120" cy="640080"/>
+          </a:xfrm>
+          <a:prstGeom prst="rect">
+            <a:avLst/>
+          </a:prstGeom>
+          <a:noFill/>
+        </p:spPr>
+        <p:txBody>
+          <a:bodyPr wrap="none">
+            <a:spAutoFit/>
+          </a:bodyPr>
+          <a:lstStyle/>
+          <a:p>
+            <a:r>
+              <a:rPr sz="2000" b="1">
+                <a:solidFill>
+                  <a:srgbClr val="202428"/>
+                </a:solidFill>
+              </a:rPr>
+              <a:t>pmos_L2_W5:  PMOS, L = 2 um, W = 5 um</a:t>
+            </a:r>
+          </a:p>
+        </p:txBody>
+      </p:sp>
+      <p:pic>
+        <p:nvPicPr>
+          <p:cNvPr id="3" name="Picture 2" descr="iv_pmos_L2_W5.png"/>
+          <p:cNvPicPr>
+            <a:picLocks noChangeAspect="1"/>
+          </p:cNvPicPr>
+          <p:nvPr/>
+        </p:nvPicPr>
+        <p:blipFill>
+          <a:blip r:embed="rId2"/>
+          <a:stretch>
+            <a:fillRect/>
+          </a:stretch>
+        </p:blipFill>
+        <p:spPr>
+          <a:xfrm>
+            <a:off x="365760" y="731520"/>
+            <a:ext cx="11430000" cy="3879272"/>
+          </a:xfrm>
+          <a:prstGeom prst="rect">
+            <a:avLst/>
+          </a:prstGeom>
+        </p:spPr>
+      </p:pic>
+      <p:sp>
+        <p:nvSpPr>
+          <p:cNvPr id="4" name="TextBox 3"/>
+          <p:cNvSpPr txBox="1"/>
+          <p:nvPr/>
+        </p:nvSpPr>
+        <p:spPr>
+          <a:xfrm>
+            <a:off x="548640" y="6172200"/>
+            <a:ext cx="11064240" cy="548640"/>
+          </a:xfrm>
+          <a:prstGeom prst="rect">
+            <a:avLst/>
+          </a:prstGeom>
+          <a:noFill/>
+        </p:spPr>
+        <p:txBody>
+          <a:bodyPr wrap="square">
+            <a:spAutoFit/>
+          </a:bodyPr>
+          <a:lstStyle/>
+          <a:p>
+            <a:pPr>
+              <a:spcAft>
+                <a:spcPts val="400"/>
+              </a:spcAft>
+            </a:pPr>
+            <a:r>
+              <a:rPr sz="1100">
+                <a:solidFill>
+                  <a:srgbClr val="202428"/>
+                </a:solidFill>
+              </a:rPr>
+              <a:t>Points: measured. Lines: NGSpice (ngspice-41). M_bias line: refit card with the fold Verilog-A g in the netlist (OSDI), g trained without this device. Faded: curves outside the frozen inclusion set (not scored). RRMS: strict paper metric for this device.</a:t>
+            </a:r>
+          </a:p>
+        </p:txBody>
+      </p:sp>
+    </p:spTree>
+  </p:cSld>
+  <p:clrMapOvr>
+    <a:masterClrMapping/>
+  </p:clrMapOvr>
+</p:sld>
+</file>
+
+<file path=ppt/slides/slide42.xml><?xml version="1.0" encoding="utf-8"?>
+<p:sld xmlns:a="http://schemas.openxmlformats.org/drawingml/2006/main" xmlns:p="http://schemas.openxmlformats.org/presentationml/2006/main" xmlns:r="http://schemas.openxmlformats.org/officeDocument/2006/relationships">
+  <p:cSld>
+    <p:spTree>
+      <p:nvGrpSpPr>
+        <p:cNvPr id="1" name=""/>
+        <p:cNvGrpSpPr/>
+        <p:nvPr/>
+      </p:nvGrpSpPr>
+      <p:grpSpPr/>
+      <p:sp>
+        <p:nvSpPr>
+          <p:cNvPr id="2" name="TextBox 1"/>
+          <p:cNvSpPr txBox="1"/>
+          <p:nvPr/>
+        </p:nvSpPr>
+        <p:spPr>
+          <a:xfrm>
+            <a:off x="457200" y="228600"/>
+            <a:ext cx="11247120" cy="640080"/>
+          </a:xfrm>
+          <a:prstGeom prst="rect">
+            <a:avLst/>
+          </a:prstGeom>
+          <a:noFill/>
+        </p:spPr>
+        <p:txBody>
+          <a:bodyPr wrap="none">
+            <a:spAutoFit/>
+          </a:bodyPr>
+          <a:lstStyle/>
+          <a:p>
+            <a:r>
+              <a:rPr sz="2000" b="1">
+                <a:solidFill>
+                  <a:srgbClr val="202428"/>
+                </a:solidFill>
+              </a:rPr>
               <a:t>pmos_L4_W7:  PMOS, L = 4 um, W = 7 um</a:t>
             </a:r>
           </a:p>
@@ -19843,7 +22942,7 @@
 </p:sld>
 </file>
 
-<file path=ppt/slides/slide41.xml><?xml version="1.0" encoding="utf-8"?>
+<file path=ppt/slides/slide43.xml><?xml version="1.0" encoding="utf-8"?>
 <p:sld xmlns:a="http://schemas.openxmlformats.org/drawingml/2006/main" xmlns:p="http://schemas.openxmlformats.org/presentationml/2006/main" xmlns:r="http://schemas.openxmlformats.org/officeDocument/2006/relationships">
   <p:cSld>
     <p:spTree>
@@ -19956,7 +23055,7 @@
 </p:sld>
 </file>
 
-<file path=ppt/slides/slide42.xml><?xml version="1.0" encoding="utf-8"?>
+<file path=ppt/slides/slide44.xml><?xml version="1.0" encoding="utf-8"?>
 <p:sld xmlns:a="http://schemas.openxmlformats.org/drawingml/2006/main" xmlns:p="http://schemas.openxmlformats.org/presentationml/2006/main" xmlns:r="http://schemas.openxmlformats.org/officeDocument/2006/relationships">
   <p:cSld>
     <p:spTree>
@@ -20069,7 +23168,7 @@
 </p:sld>
 </file>
 
-<file path=ppt/slides/slide43.xml><?xml version="1.0" encoding="utf-8"?>
+<file path=ppt/slides/slide45.xml><?xml version="1.0" encoding="utf-8"?>
 <p:sld xmlns:a="http://schemas.openxmlformats.org/drawingml/2006/main" xmlns:p="http://schemas.openxmlformats.org/presentationml/2006/main" xmlns:r="http://schemas.openxmlformats.org/officeDocument/2006/relationships">
   <p:cSld>
     <p:spTree>

</xml_diff>

<commit_message>
M_bias deck slides 25-26: selected g v2 element-deck accuracy from the I17-1 rerun; deployment checks table from I17-1 (V(d,s) = 0 check at tight tolerance, default-tolerance value reported without a rule, label deployable with restrictions), with the statement that the check was changed after the observed I16-1 failure and the I16-1 outcome stays not deployable; deck regenerated (45 slides)
Co-Authored-By: Claude Opus 5.5 <noreply@anthropic.com>
Claude-Session: https://claude.ai/code/session_01FTjyogfhfbXwhjQosGAjKp
</commit_message>
<xml_diff>
--- a/slides/cryo_ml_mbias_real_data.pptx
+++ b/slides/cryo_ml_mbias_real_data.pptx
@@ -18018,7 +18018,7 @@
                         </a:defRPr>
                       </a:pPr>
                       <a:r>
-                        <a:t>g v2, selected lambda, element deck (I16-1)</a:t>
+                        <a:t>g v2, selected lambda, element deck (I17-1)</a:t>
                       </a:r>
                     </a:p>
                   </a:txBody>
@@ -18227,12 +18227,12 @@
           <a:lstStyle/>
           <a:p>
             <a:r>
-              <a:rPr sz="2400" b="1">
+              <a:rPr sz="2200" b="1">
                 <a:solidFill>
                   <a:srgbClr val="202428"/>
                 </a:solidFill>
               </a:rPr>
-              <a:t>Deployment checks of the selected g v2 (I16-1, pre-registered)</a:t>
+              <a:t>Deployment checks of the selected g v2 (I17-1, re-registered V(d,s) = 0 check)</a:t>
             </a:r>
           </a:p>
         </p:txBody>
@@ -18247,7 +18247,7 @@
         </p:nvGraphicFramePr>
         <p:xfrm>
           <a:off x="365760" y="731520"/>
-          <a:ext cx="11430000" cy="3703320"/>
+          <a:ext cx="11430000" cy="3803904"/>
         </p:xfrm>
         <a:graphic>
           <a:graphicData uri="http://schemas.openxmlformats.org/drawingml/2006/table">
@@ -18262,7 +18262,7 @@
                 <a:gridCol w="2331720"/>
                 <a:gridCol w="1828800"/>
               </a:tblGrid>
-              <a:tr h="246888">
+              <a:tr h="237744">
                 <a:tc>
                   <a:txBody>
                     <a:bodyPr/>
@@ -18322,7 +18322,7 @@
                         </a:defRPr>
                       </a:pPr>
                       <a:r>
-                        <a:t>g v2, selected lambda (I16-1)</a:t>
+                        <a:t>g v2, selected lambda (I17-1)</a:t>
                       </a:r>
                     </a:p>
                   </a:txBody>
@@ -18379,7 +18379,7 @@
                   </a:tcPr>
                 </a:tc>
               </a:tr>
-              <a:tr h="246888">
+              <a:tr h="237744">
                 <a:tc>
                   <a:txBody>
                     <a:bodyPr/>
@@ -18496,7 +18496,7 @@
                   </a:tcPr>
                 </a:tc>
               </a:tr>
-              <a:tr h="246888">
+              <a:tr h="237744">
                 <a:tc>
                   <a:txBody>
                     <a:bodyPr/>
@@ -18613,7 +18613,7 @@
                   </a:tcPr>
                 </a:tc>
               </a:tr>
-              <a:tr h="246888">
+              <a:tr h="237744">
                 <a:tc>
                   <a:txBody>
                     <a:bodyPr/>
@@ -18627,7 +18627,7 @@
                         </a:defRPr>
                       </a:pPr>
                       <a:r>
-                        <a:t>|I(Vds = 0)| (A)</a:t>
+                        <a:t>|I(Vds = 0)| (A), tight tolerance</a:t>
                       </a:r>
                     </a:p>
                   </a:txBody>
@@ -18673,7 +18673,7 @@
                         </a:defRPr>
                       </a:pPr>
                       <a:r>
-                        <a:t>1.0006e-12 FAIL</a:t>
+                        <a:t>4.87e-17 pass</a:t>
                       </a:r>
                     </a:p>
                   </a:txBody>
@@ -18696,7 +18696,7 @@
                         </a:defRPr>
                       </a:pPr>
                       <a:r>
-                        <a:t>9.8357e-13 pass</a:t>
+                        <a:t>5.08e-17 pass</a:t>
                       </a:r>
                     </a:p>
                   </a:txBody>
@@ -18719,7 +18719,7 @@
                         </a:defRPr>
                       </a:pPr>
                       <a:r>
-                        <a:t>9.9506e-13 pass</a:t>
+                        <a:t>4.86e-17 pass</a:t>
                       </a:r>
                     </a:p>
                   </a:txBody>
@@ -18730,7 +18730,7 @@
                   </a:tcPr>
                 </a:tc>
               </a:tr>
-              <a:tr h="246888">
+              <a:tr h="237744">
                 <a:tc>
                   <a:txBody>
                     <a:bodyPr/>
@@ -18847,7 +18847,7 @@
                   </a:tcPr>
                 </a:tc>
               </a:tr>
-              <a:tr h="246888">
+              <a:tr h="237744">
                 <a:tc>
                   <a:txBody>
                     <a:bodyPr/>
@@ -18964,7 +18964,7 @@
                   </a:tcPr>
                 </a:tc>
               </a:tr>
-              <a:tr h="246888">
+              <a:tr h="237744">
                 <a:tc>
                   <a:txBody>
                     <a:bodyPr/>
@@ -19081,7 +19081,7 @@
                   </a:tcPr>
                 </a:tc>
               </a:tr>
-              <a:tr h="246888">
+              <a:tr h="237744">
                 <a:tc>
                   <a:txBody>
                     <a:bodyPr/>
@@ -19198,7 +19198,7 @@
                   </a:tcPr>
                 </a:tc>
               </a:tr>
-              <a:tr h="246888">
+              <a:tr h="237744">
                 <a:tc>
                   <a:txBody>
                     <a:bodyPr/>
@@ -19315,7 +19315,7 @@
                   </a:tcPr>
                 </a:tc>
               </a:tr>
-              <a:tr h="246888">
+              <a:tr h="237744">
                 <a:tc>
                   <a:txBody>
                     <a:bodyPr/>
@@ -19432,7 +19432,7 @@
                   </a:tcPr>
                 </a:tc>
               </a:tr>
-              <a:tr h="246888">
+              <a:tr h="237744">
                 <a:tc>
                   <a:txBody>
                     <a:bodyPr/>
@@ -19549,7 +19549,7 @@
                   </a:tcPr>
                 </a:tc>
               </a:tr>
-              <a:tr h="246888">
+              <a:tr h="237744">
                 <a:tc>
                   <a:txBody>
                     <a:bodyPr/>
@@ -19666,7 +19666,7 @@
                   </a:tcPr>
                 </a:tc>
               </a:tr>
-              <a:tr h="246888">
+              <a:tr h="237744">
                 <a:tc>
                   <a:txBody>
                     <a:bodyPr/>
@@ -19783,7 +19783,7 @@
                   </a:tcPr>
                 </a:tc>
               </a:tr>
-              <a:tr h="246888">
+              <a:tr h="237744">
                 <a:tc>
                   <a:txBody>
                     <a:bodyPr/>
@@ -19843,7 +19843,7 @@
                         </a:defRPr>
                       </a:pPr>
                       <a:r>
-                        <a:t>4.56 restriction</a:t>
+                        <a:t>4.6 restriction</a:t>
                       </a:r>
                     </a:p>
                   </a:txBody>
@@ -19900,7 +19900,7 @@
                   </a:tcPr>
                 </a:tc>
               </a:tr>
-              <a:tr h="246888">
+              <a:tr h="237744">
                 <a:tc>
                   <a:txBody>
                     <a:bodyPr/>
@@ -19914,6 +19914,123 @@
                         </a:defRPr>
                       </a:pPr>
                       <a:r>
+                        <a:t>|I(Vds = 0)| (A), default tolerance (reported, no rule)</a:t>
+                      </a:r>
+                    </a:p>
+                  </a:txBody>
+                  <a:tcPr marL="45720" marR="45720" marT="9144" marB="9144">
+                    <a:solidFill>
+                      <a:srgbClr val="FFFFFF"/>
+                    </a:solidFill>
+                  </a:tcPr>
+                </a:tc>
+                <a:tc>
+                  <a:txBody>
+                    <a:bodyPr/>
+                    <a:lstStyle/>
+                    <a:p>
+                      <a:pPr algn="r">
+                        <a:defRPr sz="1050">
+                          <a:solidFill>
+                            <a:srgbClr val="202428"/>
+                          </a:solidFill>
+                        </a:defRPr>
+                      </a:pPr>
+                      <a:r>
+                        <a:t>-</a:t>
+                      </a:r>
+                    </a:p>
+                  </a:txBody>
+                  <a:tcPr marL="45720" marR="45720" marT="9144" marB="9144">
+                    <a:solidFill>
+                      <a:srgbClr val="FFFFFF"/>
+                    </a:solidFill>
+                  </a:tcPr>
+                </a:tc>
+                <a:tc>
+                  <a:txBody>
+                    <a:bodyPr/>
+                    <a:lstStyle/>
+                    <a:p>
+                      <a:pPr algn="r">
+                        <a:defRPr sz="1050">
+                          <a:solidFill>
+                            <a:srgbClr val="202428"/>
+                          </a:solidFill>
+                        </a:defRPr>
+                      </a:pPr>
+                      <a:r>
+                        <a:t>1.0006e-12</a:t>
+                      </a:r>
+                    </a:p>
+                  </a:txBody>
+                  <a:tcPr marL="45720" marR="45720" marT="9144" marB="9144">
+                    <a:solidFill>
+                      <a:srgbClr val="FFFFFF"/>
+                    </a:solidFill>
+                  </a:tcPr>
+                </a:tc>
+                <a:tc>
+                  <a:txBody>
+                    <a:bodyPr/>
+                    <a:lstStyle/>
+                    <a:p>
+                      <a:pPr algn="r">
+                        <a:defRPr sz="1050">
+                          <a:solidFill>
+                            <a:srgbClr val="202428"/>
+                          </a:solidFill>
+                        </a:defRPr>
+                      </a:pPr>
+                      <a:r>
+                        <a:t>9.8357e-13</a:t>
+                      </a:r>
+                    </a:p>
+                  </a:txBody>
+                  <a:tcPr marL="45720" marR="45720" marT="9144" marB="9144">
+                    <a:solidFill>
+                      <a:srgbClr val="FFFFFF"/>
+                    </a:solidFill>
+                  </a:tcPr>
+                </a:tc>
+                <a:tc>
+                  <a:txBody>
+                    <a:bodyPr/>
+                    <a:lstStyle/>
+                    <a:p>
+                      <a:pPr algn="r">
+                        <a:defRPr sz="1050">
+                          <a:solidFill>
+                            <a:srgbClr val="202428"/>
+                          </a:solidFill>
+                        </a:defRPr>
+                      </a:pPr>
+                      <a:r>
+                        <a:t>9.9506e-13</a:t>
+                      </a:r>
+                    </a:p>
+                  </a:txBody>
+                  <a:tcPr marL="45720" marR="45720" marT="9144" marB="9144">
+                    <a:solidFill>
+                      <a:srgbClr val="FFFFFF"/>
+                    </a:solidFill>
+                  </a:tcPr>
+                </a:tc>
+              </a:tr>
+              <a:tr h="237744">
+                <a:tc>
+                  <a:txBody>
+                    <a:bodyPr/>
+                    <a:lstStyle/>
+                    <a:p>
+                      <a:pPr algn="l">
+                        <a:defRPr sz="1050">
+                          <a:solidFill>
+                            <a:srgbClr val="202428"/>
+                          </a:solidFill>
+                        </a:defRPr>
+                      </a:pPr>
+                      <a:r>
                         <a:t>Label</a:t>
                       </a:r>
                     </a:p>
@@ -19957,7 +20074,7 @@
                         </a:defRPr>
                       </a:pPr>
                       <a:r>
-                        <a:t>not deployable</a:t>
+                        <a:t>deployable with restrictions</a:t>
                       </a:r>
                     </a:p>
                   </a:txBody>
@@ -20026,8 +20143,8 @@
         </p:nvSpPr>
         <p:spPr>
           <a:xfrm>
-            <a:off x="548640" y="4526280"/>
-            <a:ext cx="11064240" cy="2194560"/>
+            <a:off x="548640" y="4626864"/>
+            <a:ext cx="11064240" cy="2103120"/>
           </a:xfrm>
           <a:prstGeom prst="rect">
             <a:avLst/>
@@ -20046,12 +20163,12 @@
               </a:spcAft>
             </a:pPr>
             <a:r>
-              <a:rPr sz="1100">
+              <a:rPr sz="1050">
                 <a:solidFill>
                   <a:srgbClr val="202428"/>
                 </a:solidFill>
               </a:rPr>
-              <a:t>Outcome (pre-registered rule): not deployable; label not deployable. Core failures: Q1 I_D at Vds = 0. Restrictions: default tolerance above 1e-3; gds sign changes introduced; runtime overhead &gt; 2x.</a:t>
+              <a:t>Outcome (I17-1 rule): deployable; label deployable with restrictions. Restrictions: default tolerance above 1e-3; gds sign changes introduced; runtime overhead &gt; 2x.</a:t>
             </a:r>
           </a:p>
           <a:p>
@@ -20061,12 +20178,12 @@
               </a:spcAft>
             </a:pPr>
             <a:r>
-              <a:rPr sz="1100">
+              <a:rPr sz="1050">
                 <a:solidFill>
                   <a:srgbClr val="202428"/>
                 </a:solidFill>
               </a:rPr>
-              <a:t>gds curves with an introduced sign change: 6 of 90 (pmos_L2_W5 (1), pmos_L8_W0p84 (2), pmos_L8_W1p6 (2), pmos_L8_W5 (1)). On these curves the element has 2439 points with dI/dV(d,s) &lt; 0, I_card exp(g) of the card sweep 2439, the card alone 0: the sign changes come from g. A gds sign change is a restriction, a gm sign change in strong inversion a core failure (I15-1).</a:t>
+              <a:t>The |I(Vds = 0)| check was changed after an observed failure: I16-1 took the maximum over default and tight tolerance and failed at 1 of 2700 points (1.0006e-12 A, pmos_L8_W0p84, default tolerance, where the threshold equals ngspice abstol 1e-12 A). I17-1 uses tight tolerance only (abstol 1e-18 A), threshold kept. The I16-1 outcome stays 'not deployable'; the I17-1 run under the I16-1 rule is also 'not deployable'. All other I17-1 values equal the I16-1 run except runtime.</a:t>
             </a:r>
           </a:p>
           <a:p>
@@ -20076,27 +20193,12 @@
               </a:spcAft>
             </a:pPr>
             <a:r>
-              <a:rPr sz="1100">
+              <a:rPr sz="1050">
                 <a:solidFill>
                   <a:srgbClr val="202428"/>
                 </a:solidFill>
               </a:rPr>
-              <a:t>Failed core check: |I(Vds = 0)| = 1.0006e-12 A at 1 of 2700 points (pmos_L8_W0p84, |Vgs| = 0.825 V, default tolerance, ngspice abstol 1e-12 A); card + replica run at that point 8e-24 A; tight-tolerance maximum 4.9e-17 A (post hoc diagnosis).</a:t>
-            </a:r>
-          </a:p>
-          <a:p>
-            <a:pPr>
-              <a:spcAft>
-                <a:spcPts val="400"/>
-              </a:spcAft>
-            </a:pPr>
-            <a:r>
-              <a:rPr sz="1100">
-                <a:solidFill>
-                  <a:srgbClr val="202428"/>
-                </a:solidFill>
-              </a:rPr>
-              <a:t>M2 card: 43-parameter card refit from the starting card with the full-data g in the loop. Q1 grids: V(g,s), V(d,s) in 25 mV steps, V(d,s) swept in serpentine order; tight: reltol 1e-9.</a:t>
+              <a:t>gds curves with an introduced sign change: 6 of 90 (pmos_L2_W5 (1), pmos_L8_W0p84 (2), pmos_L8_W1p6 (2), pmos_L8_W5 (1)). Element 2439 points with dI/dV(d,s) &lt; 0, I_card exp(g) 2439, card alone 0: the sign changes come from g.</a:t>
             </a:r>
           </a:p>
         </p:txBody>

</xml_diff>